<commit_message>
Add browser walkthrough test, correct deck claims, refresh screenshots
The walkthrough resets the demo and drives every role through the browser,
failing on console errors. Slide 3 now separates what runs in the
prototype from production upgrades, and the README lists what is not
built yet.
</commit_message>
<xml_diff>
--- a/ppt/SIH26263_AI_Riders_Idea.pptx
+++ b/ppt/SIH26263_AI_Riders_Idea.pptx
@@ -112,32 +112,32 @@
   <p:extLst>
     <p:ext uri="{521415D9-36F7-43E2-AB2F-B90AF26B5E84}">
       <p14:sectionLst xmlns:p14="http://schemas.microsoft.com/office/powerpoint/2010/main">
-        <p14:section name="Title" id="{771b8619-50a3-87eb-ae5d-06cee8f3f2c1}">
+        <p14:section name="Title" id="{010f5f10-b597-e6d6-bd5f-72e4ab37ccd1}">
           <p14:sldIdLst>
             <p14:sldId id="256"/>
           </p14:sldIdLst>
         </p14:section>
-        <p14:section name="Proposed solution" id="{07e14fe8-9d0c-80dc-c7e0-62f41b49e809}">
+        <p14:section name="Proposed solution" id="{3a3e4072-cbb9-cf21-35a6-6e5afb5f2ca7}">
           <p14:sldIdLst>
             <p14:sldId id="257"/>
           </p14:sldIdLst>
         </p14:section>
-        <p14:section name="Technical approach" id="{c068f30c-f9df-0dcf-22f0-788775b1a521}">
+        <p14:section name="Technical approach" id="{a92d262f-eb22-bed5-7974-33fd1109d33f}">
           <p14:sldIdLst>
             <p14:sldId id="258"/>
           </p14:sldIdLst>
         </p14:section>
-        <p14:section name="Feasibility and viability" id="{c3fc5189-aa1e-b069-3a21-a1b9eb28089e}">
+        <p14:section name="Feasibility and viability" id="{009a29ad-28c7-6fb3-4af0-5b76d605cbf9}">
           <p14:sldIdLst>
             <p14:sldId id="259"/>
           </p14:sldIdLst>
         </p14:section>
-        <p14:section name="Impact and benefits" id="{a15413a4-e31f-9ce4-041d-d0ab9048e786}">
+        <p14:section name="Impact and benefits" id="{b1ec1f82-1419-0272-08cc-28c92393e8ba}">
           <p14:sldIdLst>
             <p14:sldId id="260"/>
           </p14:sldIdLst>
         </p14:section>
-        <p14:section name="Research and references" id="{ed030a36-b8ec-a471-61a3-945ba956f637}">
+        <p14:section name="Research and references" id="{de10a48a-4206-e780-175d-50a17ecde6e7}">
           <p14:sldIdLst>
             <p14:sldId id="261"/>
           </p14:sldIdLst>
@@ -4542,7 +4542,7 @@
                   <a:schemeClr val="tx2"/>
                 </a:solidFill>
               </a:rPr>
-              <a:t>Modular and API-first: every box below is running in the prototype</a:t>
+              <a:t>Modular and API-first: one codebase from demo to production</a:t>
             </a:r>
             <a:endParaRPr lang="en-US" sz="2800" dirty="0"/>
           </a:p>
@@ -4655,7 +4655,7 @@
                   <a:schemeClr val="tx2"/>
                 </a:solidFill>
               </a:rPr>
-              <a:t>(CSV / Excel)</a:t>
+              <a:t>(Excel / CSV upload)</a:t>
             </a:r>
             <a:endParaRPr lang="en-US" sz="1100" dirty="0"/>
           </a:p>
@@ -4809,7 +4809,7 @@
                   <a:schemeClr val="tx2"/>
                 </a:solidFill>
               </a:rPr>
-              <a:t>(DigiLocker-ready)</a:t>
+              <a:t>(consent, credentials)</a:t>
             </a:r>
             <a:endParaRPr lang="en-US" sz="1100" dirty="0"/>
           </a:p>
@@ -4985,7 +4985,7 @@
                   <a:schemeClr val="bg1"/>
                 </a:solidFill>
               </a:rPr>
-              <a:t>API gateway · OAuth2 / OIDC (AICTE SSO, MFA) · role-based access with institution scope · rate limits</a:t>
+              <a:t>Role-based access with institution scoping, session expiry  →  production: AICTE SSO (OIDC + MFA), rate limits</a:t>
             </a:r>
             <a:endParaRPr lang="en-US" sz="1100" dirty="0"/>
           </a:p>
@@ -5505,7 +5505,7 @@
                   <a:schemeClr val="tx2"/>
                 </a:solidFill>
               </a:rPr>
-              <a:t>PostgreSQL · encrypted PII,</a:t>
+              <a:t>SQLite now →</a:t>
             </a:r>
             <a:endParaRPr lang="en-US" sz="1100" dirty="0"/>
           </a:p>
@@ -5519,7 +5519,7 @@
                   <a:schemeClr val="tx2"/>
                 </a:solidFill>
               </a:rPr>
-              <a:t>row-level security</a:t>
+              <a:t>PostgreSQL, encrypted PII</a:t>
             </a:r>
             <a:endParaRPr lang="en-US" sz="1100" dirty="0"/>
           </a:p>
@@ -5753,18 +5753,54 @@
       </p:sp>
       <p:sp>
         <p:nvSpPr>
-          <p:cNvPr id="37" name="Shape 35"/>
+          <p:cNvPr id="37" name="Text 35"/>
+          <p:cNvSpPr txBox="1"/>
+          <p:nvPr/>
+        </p:nvSpPr>
+        <p:spPr>
+          <a:xfrm>
+            <a:off x="1508760" y="4572000"/>
+            <a:ext cx="5623560" cy="201168"/>
+          </a:xfrm>
+          <a:prstGeom prst="rect">
+            <a:avLst/>
+          </a:prstGeom>
+          <a:noFill/>
+          <a:ln/>
+        </p:spPr>
+        <p:txBody>
+          <a:bodyPr wrap="square" lIns="0" tIns="0" rIns="0" bIns="0" rtlCol="0" anchor="ctr"/>
+          <a:lstStyle/>
+          <a:p>
+            <a:pPr indent="0" marL="0">
+              <a:buNone/>
+            </a:pPr>
+            <a:r>
+              <a:rPr lang="en-US" sz="1000" i="1" dirty="0">
+                <a:solidFill>
+                  <a:schemeClr val="accent6"/>
+                </a:solidFill>
+              </a:rPr>
+              <a:t>Everything shown runs in the prototype today; text after → is the production upgrade.</a:t>
+            </a:r>
+            <a:endParaRPr lang="en-US" sz="1000" dirty="0"/>
+          </a:p>
+        </p:txBody>
+      </p:sp>
+      <p:sp>
+        <p:nvSpPr>
+          <p:cNvPr id="38" name="Shape 36"/>
           <p:cNvSpPr/>
           <p:nvPr/>
         </p:nvSpPr>
         <p:spPr>
           <a:xfrm>
-            <a:off x="502920" y="4800600"/>
-            <a:ext cx="6629400" cy="1234440"/>
+            <a:off x="502920" y="4846320"/>
+            <a:ext cx="6629400" cy="1188720"/>
           </a:xfrm>
           <a:prstGeom prst="roundRect">
             <a:avLst>
-              <a:gd name="adj" fmla="val 5926"/>
+              <a:gd name="adj" fmla="val 6154"/>
             </a:avLst>
           </a:prstGeom>
           <a:solidFill>
@@ -5780,14 +5816,14 @@
       </p:sp>
       <p:sp>
         <p:nvSpPr>
-          <p:cNvPr id="38" name="Text 36"/>
+          <p:cNvPr id="39" name="Text 37"/>
           <p:cNvSpPr txBox="1"/>
           <p:nvPr/>
         </p:nvSpPr>
         <p:spPr>
           <a:xfrm>
-            <a:off x="667512" y="4892040"/>
-            <a:ext cx="6309360" cy="1097280"/>
+            <a:off x="667512" y="4937760"/>
+            <a:ext cx="6309360" cy="1051560"/>
           </a:xfrm>
           <a:prstGeom prst="rect">
             <a:avLst/>
@@ -5833,7 +5869,7 @@
       </p:sp>
       <p:sp>
         <p:nvSpPr>
-          <p:cNvPr id="39" name="Text 37"/>
+          <p:cNvPr id="40" name="Text 38"/>
           <p:cNvSpPr txBox="1"/>
           <p:nvPr/>
         </p:nvSpPr>
@@ -5869,7 +5905,7 @@
       </p:sp>
       <p:sp>
         <p:nvSpPr>
-          <p:cNvPr id="40" name="Shape 38"/>
+          <p:cNvPr id="41" name="Shape 39"/>
           <p:cNvSpPr/>
           <p:nvPr/>
         </p:nvSpPr>
@@ -5896,7 +5932,7 @@
       </p:sp>
       <p:sp>
         <p:nvSpPr>
-          <p:cNvPr id="41" name="Text 39"/>
+          <p:cNvPr id="42" name="Text 40"/>
           <p:cNvSpPr txBox="1"/>
           <p:nvPr/>
         </p:nvSpPr>
@@ -5932,7 +5968,7 @@
       </p:sp>
       <p:sp>
         <p:nvSpPr>
-          <p:cNvPr id="42" name="Shape 40"/>
+          <p:cNvPr id="43" name="Shape 41"/>
           <p:cNvSpPr/>
           <p:nvPr/>
         </p:nvSpPr>
@@ -5959,7 +5995,7 @@
       </p:sp>
       <p:sp>
         <p:nvSpPr>
-          <p:cNvPr id="43" name="Text 41"/>
+          <p:cNvPr id="44" name="Text 42"/>
           <p:cNvSpPr txBox="1"/>
           <p:nvPr/>
         </p:nvSpPr>
@@ -5995,7 +6031,7 @@
       </p:sp>
       <p:sp>
         <p:nvSpPr>
-          <p:cNvPr id="44" name="Shape 42"/>
+          <p:cNvPr id="45" name="Shape 43"/>
           <p:cNvSpPr/>
           <p:nvPr/>
         </p:nvSpPr>
@@ -6022,7 +6058,7 @@
       </p:sp>
       <p:sp>
         <p:nvSpPr>
-          <p:cNvPr id="45" name="Text 43"/>
+          <p:cNvPr id="46" name="Text 44"/>
           <p:cNvSpPr txBox="1"/>
           <p:nvPr/>
         </p:nvSpPr>
@@ -6058,7 +6094,7 @@
       </p:sp>
       <p:sp>
         <p:nvSpPr>
-          <p:cNvPr id="46" name="Shape 44"/>
+          <p:cNvPr id="47" name="Shape 45"/>
           <p:cNvSpPr/>
           <p:nvPr/>
         </p:nvSpPr>
@@ -6085,7 +6121,7 @@
       </p:sp>
       <p:sp>
         <p:nvSpPr>
-          <p:cNvPr id="47" name="Text 45"/>
+          <p:cNvPr id="48" name="Text 46"/>
           <p:cNvSpPr txBox="1"/>
           <p:nvPr/>
         </p:nvSpPr>
@@ -6121,7 +6157,7 @@
       </p:sp>
       <p:sp>
         <p:nvSpPr>
-          <p:cNvPr id="48" name="Shape 46"/>
+          <p:cNvPr id="49" name="Shape 47"/>
           <p:cNvSpPr/>
           <p:nvPr/>
         </p:nvSpPr>
@@ -6148,7 +6184,7 @@
       </p:sp>
       <p:sp>
         <p:nvSpPr>
-          <p:cNvPr id="49" name="Text 47"/>
+          <p:cNvPr id="50" name="Text 48"/>
           <p:cNvSpPr txBox="1"/>
           <p:nvPr/>
         </p:nvSpPr>
@@ -6184,7 +6220,7 @@
       </p:sp>
       <p:sp>
         <p:nvSpPr>
-          <p:cNvPr id="50" name="Shape 48"/>
+          <p:cNvPr id="51" name="Shape 49"/>
           <p:cNvSpPr/>
           <p:nvPr/>
         </p:nvSpPr>
@@ -6211,7 +6247,7 @@
       </p:sp>
       <p:sp>
         <p:nvSpPr>
-          <p:cNvPr id="51" name="Text 49"/>
+          <p:cNvPr id="52" name="Text 50"/>
           <p:cNvSpPr txBox="1"/>
           <p:nvPr/>
         </p:nvSpPr>
@@ -6247,7 +6283,7 @@
       </p:sp>
       <p:sp>
         <p:nvSpPr>
-          <p:cNvPr id="52" name="Shape 50"/>
+          <p:cNvPr id="53" name="Shape 51"/>
           <p:cNvSpPr/>
           <p:nvPr/>
         </p:nvSpPr>
@@ -6279,7 +6315,7 @@
       </p:sp>
       <p:pic>
         <p:nvPicPr>
-          <p:cNvPr id="53" name="Upload validation screen" descr="Upload validation screen">    </p:cNvPr>
+          <p:cNvPr id="54" name="Upload validation screen" descr="Upload validation screen">    </p:cNvPr>
           <p:cNvPicPr>
             <a:picLocks noChangeAspect="1"/>
           </p:cNvPicPr>
@@ -6303,7 +6339,7 @@
       </p:pic>
       <p:sp>
         <p:nvSpPr>
-          <p:cNvPr id="54" name="Text 51"/>
+          <p:cNvPr id="55" name="Text 52"/>
           <p:cNvSpPr txBox="1"/>
           <p:nvPr/>
         </p:nvSpPr>
@@ -7107,7 +7143,7 @@
                   <a:schemeClr val="accent6"/>
                 </a:solidFill>
               </a:rPr>
-              <a:t>Benchmark on synthetic data with planted anomalies (docs/benchmark.json in the repo). Real data will be noisier; thresholds and rules are configuration, and every flag goes to a human reviewer.</a:t>
+              <a:t>Synthetic data with planted anomalies (docs/benchmark.json). Also covered by 16 automated API tests and a repeatable browser walkthrough of every role. Real data will be noisier; every flag goes to a human reviewer.</a:t>
             </a:r>
             <a:endParaRPr lang="en-US" sz="1050" dirty="0"/>
           </a:p>
@@ -7946,7 +7982,7 @@
                             <a:srgbClr val="0B0B0B"/>
                           </a:solidFill>
                         </a:rPr>
-                        <a:t>Excel template, plain-language errors, Hindi UI, works on mobile</a:t>
+                        <a:t>Excel template with drop-downs, plain-language errors, English / Hindi toggle, works on mobile</a:t>
                       </a:r>
                       <a:endParaRPr lang="en-US" sz="1150" dirty="0"/>
                     </a:p>

</xml_diff>

<commit_message>
Add live prototype and repository links to the idea deck
Slides 3 and 6 carry the Render link and QR codes (decoded and checked);
slide 6 links the VidyaPramaan repository. Team ID is left blank until it
is allotted.
</commit_message>
<xml_diff>
--- a/ppt/SIH26263_AI_Riders_Idea.pptx
+++ b/ppt/SIH26263_AI_Riders_Idea.pptx
@@ -5800,7 +5800,7 @@
                 </a:solidFill>
                 <a:latin typeface="Arial"/>
               </a:rPr>
-              <a:t> (as allotted on the SIH portal)</a:t>
+              <a:t> </a:t>
             </a:r>
           </a:p>
           <a:p>
@@ -11854,16 +11854,40 @@
           <a:p/>
         </p:txBody>
       </p:sp>
-      <p:sp>
-        <p:nvSpPr>
-          <p:cNvPr id="17470" name="TextBox 17469"/>
+      <p:pic>
+        <p:nvPicPr>
+          <p:cNvPr id="17470" name="Picture 17469" descr="qr_live.png"/>
+          <p:cNvPicPr>
+            <a:picLocks noChangeAspect="1"/>
+          </p:cNvPicPr>
+          <p:nvPr/>
+        </p:nvPicPr>
+        <p:blipFill>
+          <a:blip r:embed="rId11"/>
+          <a:stretch>
+            <a:fillRect/>
+          </a:stretch>
+        </p:blipFill>
+        <p:spPr>
+          <a:xfrm>
+            <a:off x="6693408" y="5570848"/>
+            <a:ext cx="628783" cy="628783"/>
+          </a:xfrm>
+          <a:prstGeom prst="rect">
+            <a:avLst/>
+          </a:prstGeom>
+        </p:spPr>
+      </p:pic>
+      <p:sp>
+        <p:nvSpPr>
+          <p:cNvPr id="17471" name="TextBox 17470"/>
           <p:cNvSpPr txBox="1"/>
           <p:nvPr/>
         </p:nvSpPr>
         <p:spPr>
           <a:xfrm>
-            <a:off x="6693408" y="5552560"/>
-            <a:ext cx="5120640" cy="665359"/>
+            <a:off x="7431919" y="5552560"/>
+            <a:ext cx="4206240" cy="665359"/>
           </a:xfrm>
           <a:prstGeom prst="rect">
             <a:avLst/>
@@ -11882,7 +11906,7 @@
                 </a:solidFill>
                 <a:latin typeface="Arial"/>
               </a:rPr>
-              <a:t>Run locally: </a:t>
+              <a:t>Try it live: </a:t>
             </a:r>
             <a:r>
               <a:rPr sz="1200" b="0" i="0">
@@ -11891,7 +11915,7 @@
                 </a:solidFill>
                 <a:latin typeface="Arial"/>
               </a:rPr>
-              <a:t>./run.sh</a:t>
+              <a:t>https://vidya-pramaan-sih26263.onrender.com</a:t>
             </a:r>
           </a:p>
           <a:p>
@@ -19585,7 +19609,7 @@
       </p:sp>
       <p:pic>
         <p:nvPicPr>
-          <p:cNvPr id="17450" name="Picture 17449" descr="qr_repo.png"/>
+          <p:cNvPr id="17450" name="Picture 17449" descr="qr_live.png"/>
           <p:cNvPicPr>
             <a:picLocks noChangeAspect="1"/>
           </p:cNvPicPr>
@@ -19635,6 +19659,87 @@
                 </a:solidFill>
                 <a:latin typeface="Arial"/>
               </a:rPr>
+              <a:t>Live prototype</a:t>
+            </a:r>
+          </a:p>
+          <a:p>
+            <a:pPr algn="l"/>
+            <a:r>
+              <a:rPr sz="1200" b="0" i="0">
+                <a:solidFill>
+                  <a:srgbClr val="0070C0"/>
+                </a:solidFill>
+                <a:latin typeface="Arial"/>
+              </a:rPr>
+              <a:t>https://vidya-pramaan-sih26263.onrender.com</a:t>
+            </a:r>
+          </a:p>
+          <a:p>
+            <a:pPr algn="l"/>
+            <a:r>
+              <a:rPr sz="1050" b="0" i="0">
+                <a:solidFill>
+                  <a:srgbClr val="595959"/>
+                </a:solidFill>
+                <a:latin typeface="Arial"/>
+              </a:rPr>
+              <a:t>Synthetic data only · demo users for every role</a:t>
+            </a:r>
+          </a:p>
+        </p:txBody>
+      </p:sp>
+      <p:pic>
+        <p:nvPicPr>
+          <p:cNvPr id="17452" name="Picture 17451" descr="qr_repo.png"/>
+          <p:cNvPicPr>
+            <a:picLocks noChangeAspect="1"/>
+          </p:cNvPicPr>
+          <p:nvPr/>
+        </p:nvPicPr>
+        <p:blipFill>
+          <a:blip r:embed="rId10"/>
+          <a:stretch>
+            <a:fillRect/>
+          </a:stretch>
+        </p:blipFill>
+        <p:spPr>
+          <a:xfrm>
+            <a:off x="6217920" y="5074920"/>
+            <a:ext cx="1078992" cy="1078992"/>
+          </a:xfrm>
+          <a:prstGeom prst="rect">
+            <a:avLst/>
+          </a:prstGeom>
+        </p:spPr>
+      </p:pic>
+      <p:sp>
+        <p:nvSpPr>
+          <p:cNvPr id="17453" name="TextBox 17452"/>
+          <p:cNvSpPr txBox="1"/>
+          <p:nvPr/>
+        </p:nvSpPr>
+        <p:spPr>
+          <a:xfrm>
+            <a:off x="7424927" y="5093208"/>
+            <a:ext cx="4389120" cy="1042415"/>
+          </a:xfrm>
+          <a:prstGeom prst="rect">
+            <a:avLst/>
+          </a:prstGeom>
+          <a:noFill/>
+        </p:spPr>
+        <p:txBody>
+          <a:bodyPr wrap="square" lIns="45720" rIns="45720" tIns="18288" bIns="18288" anchor="ctr"/>
+          <a:lstStyle/>
+          <a:p>
+            <a:pPr algn="l"/>
+            <a:r>
+              <a:rPr sz="1300" b="1" i="0">
+                <a:solidFill>
+                  <a:srgbClr val="E46C0A"/>
+                </a:solidFill>
+                <a:latin typeface="Arial"/>
+              </a:rPr>
               <a:t>Source code &amp; tests</a:t>
             </a:r>
           </a:p>
@@ -19647,7 +19752,7 @@
                 </a:solidFill>
                 <a:latin typeface="Arial"/>
               </a:rPr>
-              <a:t>https://github.com/Pulkitkh/AI_Riders_</a:t>
+              <a:t>https://github.com/Pulkitkh/VidyaPramaan</a:t>
             </a:r>
           </a:p>
           <a:p>

</xml_diff>

<commit_message>
Deck: before/after impact on slide 5 and speaker notes on every slide
Slide 5 contrasts today's process (annual returns, AISHE years late, unseen
duplicates) with the prototype's same-day checks. Each slide carries a short
speaker script in its notes. Claim map and test counts updated (59 tests).
</commit_message>
<xml_diff>
--- a/ppt/SIH26263_AI_Riders_Idea.pptx
+++ b/ppt/SIH26263_AI_Riders_Idea.pptx
@@ -643,14 +643,9 @@
           </a:bodyPr>
           <a:lstStyle/>
           <a:p>
-            <a:pPr eaLnBrk="1" hangingPunct="1">
-              <a:spcBef>
-                <a:spcPct val="0"/>
-              </a:spcBef>
-            </a:pPr>
-            <a:endParaRPr lang="en-US">
-              <a:ea typeface="ＭＳ Ｐゴシック" pitchFamily="1" charset="-128"/>
-            </a:endParaRPr>
+            <a:r>
+              <a:t>AICTE today sees totals, late. Excess admission costs five times the fee per student, yet it surfaces in annual returns. Our flow is the one the problem statement asks for: upload, APAAR check, verification, central record, live monitoring, consented verification. What is new: name matching that keeps twins apart, ghost-admission rings, decisions that are remembered, signed audit checkpoints, rules as data, and APAAR on every degree.</a:t>
+            </a:r>
           </a:p>
         </p:txBody>
       </p:sp>
@@ -762,14 +757,9 @@
           </a:bodyPr>
           <a:lstStyle/>
           <a:p>
-            <a:pPr eaLnBrk="1" hangingPunct="1">
-              <a:spcBef>
-                <a:spcPct val="0"/>
-              </a:spcBef>
-            </a:pPr>
-            <a:endParaRPr lang="en-US">
-              <a:ea typeface="ＭＳ Ｐゴシック" pitchFamily="1" charset="-128"/>
-            </a:endParaRPr>
+            <a:r>
+              <a:t>Open-source stack, PostgreSQL tested. Every row goes through 31 explained rules; errors come back with reasons; accepted rows trigger a national scan and risk scoring against peers. The screenshot is the real prototype: 77 rows, 65 accepted, 12 returned. Scan the QR to try it.</a:t>
+            </a:r>
           </a:p>
         </p:txBody>
       </p:sp>
@@ -881,14 +871,9 @@
           </a:bodyPr>
           <a:lstStyle/>
           <a:p>
-            <a:pPr eaLnBrk="1" hangingPunct="1">
-              <a:spcBef>
-                <a:spcPct val="0"/>
-              </a:spcBef>
-            </a:pPr>
-            <a:endParaRPr lang="en-US">
-              <a:ea typeface="ＭＳ Ｐゴシック" pitchFamily="1" charset="-128"/>
-            </a:endParaRPr>
+            <a:r>
+              <a:t>Feasibility is measured, not promised. On name pairs written independently of our data: precision 0.79, recall 0.92, against 0.65 and 0.68 for the usual fuzzy match. No twin is ever merged. Planted cases are regression checks, and we say so. 59 tests on SQLite and PostgreSQL. Each risk has a built answer, and the roadmap goes from one-state pilot to national rollout within a year on open-source software.</a:t>
+            </a:r>
           </a:p>
         </p:txBody>
       </p:sp>
@@ -1059,14 +1044,9 @@
           </a:bodyPr>
           <a:lstStyle/>
           <a:p>
-            <a:pPr eaLnBrk="1" hangingPunct="1">
-              <a:spcBef>
-                <a:spcPct val="0"/>
-              </a:spcBef>
-            </a:pPr>
-            <a:endParaRPr lang="en-US">
-              <a:ea typeface="ＭＳ Ｐゴシック" pitchFamily="1" charset="-128"/>
-            </a:endParaRPr>
+            <a:r>
+              <a:t>Everyone gains from one national view: AICTE and regulators catch problems at submission, institutions get explained errors, universities print APAAR on degrees, employers verify in seconds, students control access. The contrast at the bottom is the point: from years late to the same day.</a:t>
+            </a:r>
           </a:p>
         </p:txBody>
       </p:sp>
@@ -1237,14 +1217,9 @@
           </a:bodyPr>
           <a:lstStyle/>
           <a:p>
-            <a:pPr eaLnBrk="1" hangingPunct="1">
-              <a:spcBef>
-                <a:spcPct val="0"/>
-              </a:spcBef>
-            </a:pPr>
-            <a:endParaRPr lang="en-US">
-              <a:ea typeface="ＭＳ Ｐゴシック" pitchFamily="1" charset="-128"/>
-            </a:endParaRPr>
+            <a:r>
+              <a:t>We do not replace NAD, ABC or AISHE; we fill the gap none of them covers: student-level reconciliation of admissions against approved intake. Sources are on the right. Both QR codes work: the live prototype and the code with its tests.</a:t>
+            </a:r>
           </a:p>
         </p:txBody>
       </p:sp>
@@ -1344,6 +1319,76 @@
         <p14:creationId xmlns:p14="http://schemas.microsoft.com/office/powerpoint/2010/main" val="1908672725"/>
       </p:ext>
     </p:extLst>
+  </p:cSld>
+  <p:clrMapOvr>
+    <a:masterClrMapping/>
+  </p:clrMapOvr>
+</p:notes>
+</file>
+
+<file path=ppt/notesSlides/notesSlide6.xml><?xml version="1.0" encoding="utf-8"?>
+<p:notes xmlns:a="http://schemas.openxmlformats.org/drawingml/2006/main" xmlns:p="http://schemas.openxmlformats.org/presentationml/2006/main" xmlns:r="http://schemas.openxmlformats.org/officeDocument/2006/relationships">
+  <p:cSld>
+    <p:spTree>
+      <p:nvGrpSpPr>
+        <p:cNvPr id="1" name=""/>
+        <p:cNvGrpSpPr/>
+        <p:nvPr/>
+      </p:nvGrpSpPr>
+      <p:grpSpPr>
+        <a:xfrm>
+          <a:off x="0" y="0"/>
+          <a:ext cx="0" cy="0"/>
+          <a:chOff x="0" y="0"/>
+          <a:chExt cx="0" cy="0"/>
+        </a:xfrm>
+      </p:grpSpPr>
+      <p:sp>
+        <p:nvSpPr>
+          <p:cNvPr id="2" name="Slide Image Placeholder 1"/>
+          <p:cNvSpPr>
+            <a:spLocks noGrp="1"/>
+          </p:cNvSpPr>
+          <p:nvPr>
+            <p:ph type="sldImg" idx="2"/>
+          </p:nvPr>
+        </p:nvSpPr>
+        <p:spPr/>
+      </p:sp>
+      <p:sp>
+        <p:nvSpPr>
+          <p:cNvPr id="3" name="Notes Placeholder 2"/>
+          <p:cNvSpPr>
+            <a:spLocks noGrp="1"/>
+          </p:cNvSpPr>
+          <p:nvPr>
+            <p:ph type="body" idx="3" sz="quarter"/>
+          </p:nvPr>
+        </p:nvSpPr>
+        <p:spPr/>
+        <p:txBody>
+          <a:bodyPr/>
+          <a:lstStyle/>
+          <a:p>
+            <a:r>
+              <a:t>Vidya Pramaan: one student, one APAAR ID, one verifiable record. A working prototype for SIH26263, live at the link on this slide, with seven demo roles and synthetic data only.</a:t>
+            </a:r>
+          </a:p>
+        </p:txBody>
+      </p:sp>
+      <p:sp>
+        <p:nvSpPr>
+          <p:cNvPr id="4" name="Slide Number Placeholder 3"/>
+          <p:cNvSpPr>
+            <a:spLocks noGrp="1"/>
+          </p:cNvSpPr>
+          <p:nvPr>
+            <p:ph type="sldNum" idx="5" sz="quarter"/>
+          </p:nvPr>
+        </p:nvSpPr>
+        <p:spPr/>
+      </p:sp>
+    </p:spTree>
   </p:cSld>
   <p:clrMapOvr>
     <a:masterClrMapping/>
@@ -13581,7 +13626,7 @@
                 </a:solidFill>
                 <a:latin typeface="Arial"/>
               </a:rPr>
-              <a:t>58 tests</a:t>
+              <a:t>59 tests</a:t>
             </a:r>
           </a:p>
         </p:txBody>
@@ -17118,6 +17163,356 @@
         </p:nvSpPr>
         <p:spPr>
           <a:xfrm>
+            <a:off x="320040" y="4443984"/>
+            <a:ext cx="2011680" cy="1737360"/>
+          </a:xfrm>
+          <a:prstGeom prst="roundRect">
+            <a:avLst>
+              <a:gd name="adj" fmla="val 6315"/>
+            </a:avLst>
+          </a:prstGeom>
+          <a:solidFill>
+            <a:srgbClr val="FCECEA"/>
+          </a:solidFill>
+          <a:ln w="9525">
+            <a:solidFill>
+              <a:srgbClr val="F0C4C0"/>
+            </a:solidFill>
+          </a:ln>
+          <a:effectLst/>
+        </p:spPr>
+        <p:style>
+          <a:lnRef idx="1">
+            <a:schemeClr val="accent1"/>
+          </a:lnRef>
+          <a:fillRef idx="3">
+            <a:schemeClr val="accent1"/>
+          </a:fillRef>
+          <a:effectRef idx="2">
+            <a:schemeClr val="accent1"/>
+          </a:effectRef>
+          <a:fontRef idx="minor">
+            <a:schemeClr val="lt1"/>
+          </a:fontRef>
+        </p:style>
+        <p:txBody>
+          <a:bodyPr rtlCol="0" anchor="ctr"/>
+          <a:lstStyle/>
+          <a:p/>
+        </p:txBody>
+      </p:sp>
+      <p:sp>
+        <p:nvSpPr>
+          <p:cNvPr id="17445" name="TextBox 17444"/>
+          <p:cNvSpPr txBox="1"/>
+          <p:nvPr/>
+        </p:nvSpPr>
+        <p:spPr>
+          <a:xfrm>
+            <a:off x="393192" y="4480560"/>
+            <a:ext cx="1865376" cy="274320"/>
+          </a:xfrm>
+          <a:prstGeom prst="rect">
+            <a:avLst/>
+          </a:prstGeom>
+          <a:noFill/>
+        </p:spPr>
+        <p:txBody>
+          <a:bodyPr wrap="square" lIns="45720" rIns="45720" tIns="18288" bIns="18288" anchor="ctr"/>
+          <a:lstStyle/>
+          <a:p>
+            <a:pPr algn="l"/>
+            <a:r>
+              <a:rPr sz="1150" b="1" i="0">
+                <a:solidFill>
+                  <a:srgbClr val="B42B2B"/>
+                </a:solidFill>
+                <a:latin typeface="Arial"/>
+              </a:rPr>
+              <a:t>Today</a:t>
+            </a:r>
+          </a:p>
+        </p:txBody>
+      </p:sp>
+      <p:sp>
+        <p:nvSpPr>
+          <p:cNvPr id="17446" name="TextBox 17445"/>
+          <p:cNvSpPr txBox="1"/>
+          <p:nvPr/>
+        </p:nvSpPr>
+        <p:spPr>
+          <a:xfrm>
+            <a:off x="393192" y="4754880"/>
+            <a:ext cx="1865376" cy="1389888"/>
+          </a:xfrm>
+          <a:prstGeom prst="rect">
+            <a:avLst/>
+          </a:prstGeom>
+          <a:noFill/>
+        </p:spPr>
+        <p:txBody>
+          <a:bodyPr wrap="square" lIns="45720" rIns="45720" tIns="18288" bIns="18288" anchor="t"/>
+          <a:lstStyle/>
+          <a:p>
+            <a:pPr algn="l">
+              <a:spcAft>
+                <a:spcPts val="300"/>
+              </a:spcAft>
+            </a:pPr>
+            <a:r>
+              <a:rPr sz="1000" b="1" i="0">
+                <a:solidFill>
+                  <a:srgbClr val="B42B2B"/>
+                </a:solidFill>
+                <a:latin typeface="Arial"/>
+              </a:rPr>
+              <a:t>✖ </a:t>
+            </a:r>
+            <a:r>
+              <a:rPr sz="1000" b="0" i="0">
+                <a:solidFill>
+                  <a:srgbClr val="1A1A1A"/>
+                </a:solidFill>
+                <a:latin typeface="Arial"/>
+              </a:rPr>
+              <a:t>Excess admissions surface in annual returns</a:t>
+            </a:r>
+          </a:p>
+          <a:p>
+            <a:pPr algn="l">
+              <a:spcAft>
+                <a:spcPts val="300"/>
+              </a:spcAft>
+            </a:pPr>
+            <a:r>
+              <a:rPr sz="1000" b="1" i="0">
+                <a:solidFill>
+                  <a:srgbClr val="B42B2B"/>
+                </a:solidFill>
+                <a:latin typeface="Arial"/>
+              </a:rPr>
+              <a:t>✖ </a:t>
+            </a:r>
+            <a:r>
+              <a:rPr sz="1000" b="0" i="0">
+                <a:solidFill>
+                  <a:srgbClr val="1A1A1A"/>
+                </a:solidFill>
+                <a:latin typeface="Arial"/>
+              </a:rPr>
+              <a:t>AISHE figures arrive 2–3 years late</a:t>
+            </a:r>
+          </a:p>
+          <a:p>
+            <a:pPr algn="l">
+              <a:spcAft>
+                <a:spcPts val="300"/>
+              </a:spcAft>
+            </a:pPr>
+            <a:r>
+              <a:rPr sz="1000" b="1" i="0">
+                <a:solidFill>
+                  <a:srgbClr val="B42B2B"/>
+                </a:solidFill>
+                <a:latin typeface="Arial"/>
+              </a:rPr>
+              <a:t>✖ </a:t>
+            </a:r>
+            <a:r>
+              <a:rPr sz="1000" b="0" i="0">
+                <a:solidFill>
+                  <a:srgbClr val="1A1A1A"/>
+                </a:solidFill>
+                <a:latin typeface="Arial"/>
+              </a:rPr>
+              <a:t>Same student at two colleges goes unseen</a:t>
+            </a:r>
+          </a:p>
+        </p:txBody>
+      </p:sp>
+      <p:sp>
+        <p:nvSpPr>
+          <p:cNvPr id="17447" name="Rounded Rectangle 17446"/>
+          <p:cNvSpPr/>
+          <p:nvPr/>
+        </p:nvSpPr>
+        <p:spPr>
+          <a:xfrm>
+            <a:off x="4315968" y="4443984"/>
+            <a:ext cx="2039112" cy="1737360"/>
+          </a:xfrm>
+          <a:prstGeom prst="roundRect">
+            <a:avLst>
+              <a:gd name="adj" fmla="val 6315"/>
+            </a:avLst>
+          </a:prstGeom>
+          <a:solidFill>
+            <a:srgbClr val="E8F5EC"/>
+          </a:solidFill>
+          <a:ln w="9525">
+            <a:solidFill>
+              <a:srgbClr val="BFE3C9"/>
+            </a:solidFill>
+          </a:ln>
+          <a:effectLst/>
+        </p:spPr>
+        <p:style>
+          <a:lnRef idx="1">
+            <a:schemeClr val="accent1"/>
+          </a:lnRef>
+          <a:fillRef idx="3">
+            <a:schemeClr val="accent1"/>
+          </a:fillRef>
+          <a:effectRef idx="2">
+            <a:schemeClr val="accent1"/>
+          </a:effectRef>
+          <a:fontRef idx="minor">
+            <a:schemeClr val="lt1"/>
+          </a:fontRef>
+        </p:style>
+        <p:txBody>
+          <a:bodyPr rtlCol="0" anchor="ctr"/>
+          <a:lstStyle/>
+          <a:p/>
+        </p:txBody>
+      </p:sp>
+      <p:sp>
+        <p:nvSpPr>
+          <p:cNvPr id="17448" name="TextBox 17447"/>
+          <p:cNvSpPr txBox="1"/>
+          <p:nvPr/>
+        </p:nvSpPr>
+        <p:spPr>
+          <a:xfrm>
+            <a:off x="4389120" y="4480560"/>
+            <a:ext cx="1892807" cy="274320"/>
+          </a:xfrm>
+          <a:prstGeom prst="rect">
+            <a:avLst/>
+          </a:prstGeom>
+          <a:noFill/>
+        </p:spPr>
+        <p:txBody>
+          <a:bodyPr wrap="square" lIns="45720" rIns="45720" tIns="18288" bIns="18288" anchor="ctr"/>
+          <a:lstStyle/>
+          <a:p>
+            <a:pPr algn="l"/>
+            <a:r>
+              <a:rPr sz="1150" b="1" i="0">
+                <a:solidFill>
+                  <a:srgbClr val="1E7B3E"/>
+                </a:solidFill>
+                <a:latin typeface="Arial"/>
+              </a:rPr>
+              <a:t>With Vidya Pramaan</a:t>
+            </a:r>
+          </a:p>
+        </p:txBody>
+      </p:sp>
+      <p:sp>
+        <p:nvSpPr>
+          <p:cNvPr id="17449" name="TextBox 17448"/>
+          <p:cNvSpPr txBox="1"/>
+          <p:nvPr/>
+        </p:nvSpPr>
+        <p:spPr>
+          <a:xfrm>
+            <a:off x="4389120" y="4754880"/>
+            <a:ext cx="1892807" cy="1389888"/>
+          </a:xfrm>
+          <a:prstGeom prst="rect">
+            <a:avLst/>
+          </a:prstGeom>
+          <a:noFill/>
+        </p:spPr>
+        <p:txBody>
+          <a:bodyPr wrap="square" lIns="45720" rIns="45720" tIns="18288" bIns="18288" anchor="t"/>
+          <a:lstStyle/>
+          <a:p>
+            <a:pPr algn="l">
+              <a:spcAft>
+                <a:spcPts val="300"/>
+              </a:spcAft>
+            </a:pPr>
+            <a:r>
+              <a:rPr sz="1000" b="1" i="0">
+                <a:solidFill>
+                  <a:srgbClr val="1E7B3E"/>
+                </a:solidFill>
+                <a:latin typeface="Arial"/>
+              </a:rPr>
+              <a:t>✔ </a:t>
+            </a:r>
+            <a:r>
+              <a:rPr sz="1000" b="0" i="0">
+                <a:solidFill>
+                  <a:srgbClr val="1A1A1A"/>
+                </a:solidFill>
+                <a:latin typeface="Arial"/>
+              </a:rPr>
+              <a:t>Seat #61 of 60 stopped the day it is uploaded</a:t>
+            </a:r>
+          </a:p>
+          <a:p>
+            <a:pPr algn="l">
+              <a:spcAft>
+                <a:spcPts val="300"/>
+              </a:spcAft>
+            </a:pPr>
+            <a:r>
+              <a:rPr sz="1000" b="1" i="0">
+                <a:solidFill>
+                  <a:srgbClr val="1E7B3E"/>
+                </a:solidFill>
+                <a:latin typeface="Arial"/>
+              </a:rPr>
+              <a:t>✔ </a:t>
+            </a:r>
+            <a:r>
+              <a:rPr sz="1000" b="0" i="0">
+                <a:solidFill>
+                  <a:srgbClr val="1A1A1A"/>
+                </a:solidFill>
+                <a:latin typeface="Arial"/>
+              </a:rPr>
+              <a:t>Duplicates and ghost rings flagged within minutes</a:t>
+            </a:r>
+          </a:p>
+          <a:p>
+            <a:pPr algn="l">
+              <a:spcAft>
+                <a:spcPts val="300"/>
+              </a:spcAft>
+            </a:pPr>
+            <a:r>
+              <a:rPr sz="1000" b="1" i="0">
+                <a:solidFill>
+                  <a:srgbClr val="1E7B3E"/>
+                </a:solidFill>
+                <a:latin typeface="Arial"/>
+              </a:rPr>
+              <a:t>✔ </a:t>
+            </a:r>
+            <a:r>
+              <a:rPr sz="1000" b="0" i="0">
+                <a:solidFill>
+                  <a:srgbClr val="1A1A1A"/>
+                </a:solidFill>
+                <a:latin typeface="Arial"/>
+              </a:rPr>
+              <a:t>QR check in seconds, even offline</a:t>
+            </a:r>
+          </a:p>
+        </p:txBody>
+      </p:sp>
+      <p:sp>
+        <p:nvSpPr>
+          <p:cNvPr id="17450" name="Rounded Rectangle 17449"/>
+          <p:cNvSpPr/>
+          <p:nvPr/>
+        </p:nvSpPr>
+        <p:spPr>
+          <a:xfrm>
             <a:off x="6583680" y="1097280"/>
             <a:ext cx="5285232" cy="310896"/>
           </a:xfrm>
@@ -17176,7 +17571,7 @@
       </p:sp>
       <p:sp>
         <p:nvSpPr>
-          <p:cNvPr id="17445" name="Rounded Rectangle 17444"/>
+          <p:cNvPr id="17451" name="Rounded Rectangle 17450"/>
           <p:cNvSpPr/>
           <p:nvPr/>
         </p:nvSpPr>
@@ -17222,7 +17617,7 @@
       </p:sp>
       <p:sp>
         <p:nvSpPr>
-          <p:cNvPr id="17446" name="Oval 17445"/>
+          <p:cNvPr id="17452" name="Oval 17451"/>
           <p:cNvSpPr/>
           <p:nvPr/>
         </p:nvSpPr>
@@ -17264,7 +17659,7 @@
       </p:sp>
       <p:pic>
         <p:nvPicPr>
-          <p:cNvPr id="17447" name="Picture 17446" descr="LuHeartHandshake_white.png"/>
+          <p:cNvPr id="17453" name="Picture 17452" descr="LuHeartHandshake_white.png"/>
           <p:cNvPicPr>
             <a:picLocks noChangeAspect="1"/>
           </p:cNvPicPr>
@@ -17288,7 +17683,7 @@
       </p:pic>
       <p:sp>
         <p:nvSpPr>
-          <p:cNvPr id="17448" name="TextBox 17447"/>
+          <p:cNvPr id="17454" name="TextBox 17453"/>
           <p:cNvSpPr txBox="1"/>
           <p:nvPr/>
         </p:nvSpPr>
@@ -17321,7 +17716,7 @@
       </p:sp>
       <p:sp>
         <p:nvSpPr>
-          <p:cNvPr id="17449" name="TextBox 17448"/>
+          <p:cNvPr id="17455" name="TextBox 17454"/>
           <p:cNvSpPr txBox="1"/>
           <p:nvPr/>
         </p:nvSpPr>
@@ -17355,7 +17750,7 @@
       </p:sp>
       <p:sp>
         <p:nvSpPr>
-          <p:cNvPr id="17450" name="Rounded Rectangle 17449"/>
+          <p:cNvPr id="17456" name="Rounded Rectangle 17455"/>
           <p:cNvSpPr/>
           <p:nvPr/>
         </p:nvSpPr>
@@ -17401,7 +17796,7 @@
       </p:sp>
       <p:sp>
         <p:nvSpPr>
-          <p:cNvPr id="17451" name="Oval 17450"/>
+          <p:cNvPr id="17457" name="Oval 17456"/>
           <p:cNvSpPr/>
           <p:nvPr/>
         </p:nvSpPr>
@@ -17443,7 +17838,7 @@
       </p:sp>
       <p:pic>
         <p:nvPicPr>
-          <p:cNvPr id="17452" name="Picture 17451" descr="LuIndianRupee_white.png"/>
+          <p:cNvPr id="17458" name="Picture 17457" descr="LuIndianRupee_white.png"/>
           <p:cNvPicPr>
             <a:picLocks noChangeAspect="1"/>
           </p:cNvPicPr>
@@ -17467,7 +17862,7 @@
       </p:pic>
       <p:sp>
         <p:nvSpPr>
-          <p:cNvPr id="17453" name="TextBox 17452"/>
+          <p:cNvPr id="17459" name="TextBox 17458"/>
           <p:cNvSpPr txBox="1"/>
           <p:nvPr/>
         </p:nvSpPr>
@@ -17500,7 +17895,7 @@
       </p:sp>
       <p:sp>
         <p:nvSpPr>
-          <p:cNvPr id="17454" name="TextBox 17453"/>
+          <p:cNvPr id="17460" name="TextBox 17459"/>
           <p:cNvSpPr txBox="1"/>
           <p:nvPr/>
         </p:nvSpPr>
@@ -17534,7 +17929,7 @@
       </p:sp>
       <p:sp>
         <p:nvSpPr>
-          <p:cNvPr id="17455" name="Rounded Rectangle 17454"/>
+          <p:cNvPr id="17461" name="Rounded Rectangle 17460"/>
           <p:cNvSpPr/>
           <p:nvPr/>
         </p:nvSpPr>
@@ -17580,7 +17975,7 @@
       </p:sp>
       <p:sp>
         <p:nvSpPr>
-          <p:cNvPr id="17456" name="Oval 17455"/>
+          <p:cNvPr id="17462" name="Oval 17461"/>
           <p:cNvSpPr/>
           <p:nvPr/>
         </p:nvSpPr>
@@ -17622,7 +18017,7 @@
       </p:sp>
       <p:pic>
         <p:nvPicPr>
-          <p:cNvPr id="17457" name="Picture 17456" descr="LuLeaf_white.png"/>
+          <p:cNvPr id="17463" name="Picture 17462" descr="LuLeaf_white.png"/>
           <p:cNvPicPr>
             <a:picLocks noChangeAspect="1"/>
           </p:cNvPicPr>
@@ -17646,7 +18041,7 @@
       </p:pic>
       <p:sp>
         <p:nvSpPr>
-          <p:cNvPr id="17458" name="TextBox 17457"/>
+          <p:cNvPr id="17464" name="TextBox 17463"/>
           <p:cNvSpPr txBox="1"/>
           <p:nvPr/>
         </p:nvSpPr>
@@ -17679,7 +18074,7 @@
       </p:sp>
       <p:sp>
         <p:nvSpPr>
-          <p:cNvPr id="17459" name="TextBox 17458"/>
+          <p:cNvPr id="17465" name="TextBox 17464"/>
           <p:cNvSpPr txBox="1"/>
           <p:nvPr/>
         </p:nvSpPr>
@@ -17713,7 +18108,7 @@
       </p:sp>
       <p:sp>
         <p:nvSpPr>
-          <p:cNvPr id="17460" name="Rounded Rectangle 17459"/>
+          <p:cNvPr id="17466" name="Rounded Rectangle 17465"/>
           <p:cNvSpPr/>
           <p:nvPr/>
         </p:nvSpPr>
@@ -17759,7 +18154,7 @@
       </p:sp>
       <p:sp>
         <p:nvSpPr>
-          <p:cNvPr id="17461" name="Oval 17460"/>
+          <p:cNvPr id="17467" name="Oval 17466"/>
           <p:cNvSpPr/>
           <p:nvPr/>
         </p:nvSpPr>
@@ -17801,7 +18196,7 @@
       </p:sp>
       <p:pic>
         <p:nvPicPr>
-          <p:cNvPr id="17462" name="Picture 17461" descr="LuLandmark_white.png"/>
+          <p:cNvPr id="17468" name="Picture 17467" descr="LuLandmark_white.png"/>
           <p:cNvPicPr>
             <a:picLocks noChangeAspect="1"/>
           </p:cNvPicPr>
@@ -17825,7 +18220,7 @@
       </p:pic>
       <p:sp>
         <p:nvSpPr>
-          <p:cNvPr id="17463" name="TextBox 17462"/>
+          <p:cNvPr id="17469" name="TextBox 17468"/>
           <p:cNvSpPr txBox="1"/>
           <p:nvPr/>
         </p:nvSpPr>
@@ -17858,7 +18253,7 @@
       </p:sp>
       <p:sp>
         <p:nvSpPr>
-          <p:cNvPr id="17464" name="TextBox 17463"/>
+          <p:cNvPr id="17470" name="TextBox 17469"/>
           <p:cNvSpPr txBox="1"/>
           <p:nvPr/>
         </p:nvSpPr>
@@ -17892,7 +18287,7 @@
       </p:sp>
       <p:sp>
         <p:nvSpPr>
-          <p:cNvPr id="17465" name="Rounded Rectangle 17464"/>
+          <p:cNvPr id="17471" name="Rounded Rectangle 17470"/>
           <p:cNvSpPr/>
           <p:nvPr/>
         </p:nvSpPr>
@@ -17938,7 +18333,7 @@
       </p:sp>
       <p:pic>
         <p:nvPicPr>
-          <p:cNvPr id="17466" name="Picture 17465" descr="25_certificate.png"/>
+          <p:cNvPr id="17472" name="Picture 17471" descr="25_certificate.png"/>
           <p:cNvPicPr>
             <a:picLocks noChangeAspect="1"/>
           </p:cNvPicPr>
@@ -17963,7 +18358,7 @@
       </p:pic>
       <p:sp>
         <p:nvSpPr>
-          <p:cNvPr id="17467" name="Rounded Rectangle 17466"/>
+          <p:cNvPr id="17473" name="Rounded Rectangle 17472"/>
           <p:cNvSpPr/>
           <p:nvPr/>
         </p:nvSpPr>
@@ -18009,7 +18404,7 @@
       </p:sp>
       <p:pic>
         <p:nvPicPr>
-          <p:cNvPr id="17468" name="Picture 17467" descr="23_public_qr_verified.png"/>
+          <p:cNvPr id="17474" name="Picture 17473" descr="23_public_qr_verified.png"/>
           <p:cNvPicPr>
             <a:picLocks noChangeAspect="1"/>
           </p:cNvPicPr>
@@ -18034,7 +18429,7 @@
       </p:pic>
       <p:sp>
         <p:nvSpPr>
-          <p:cNvPr id="17469" name="TextBox 17468"/>
+          <p:cNvPr id="17475" name="TextBox 17474"/>
           <p:cNvSpPr txBox="1"/>
           <p:nvPr/>
         </p:nvSpPr>
@@ -18067,7 +18462,7 @@
       </p:sp>
       <p:sp>
         <p:nvSpPr>
-          <p:cNvPr id="17470" name="TextBox 17469"/>
+          <p:cNvPr id="17476" name="TextBox 17475"/>
           <p:cNvSpPr txBox="1"/>
           <p:nvPr/>
         </p:nvSpPr>
@@ -20356,7 +20751,7 @@
                 </a:solidFill>
                 <a:latin typeface="Arial"/>
               </a:rPr>
-              <a:t>58 automated tests + browser walkthrough · MIT licence</a:t>
+              <a:t>59 automated tests + browser walkthrough · MIT licence</a:t>
             </a:r>
           </a:p>
         </p:txBody>

</xml_diff>

<commit_message>
Deck: sourced field evidence on slide 5, slot for a real interview quote
The 'Today' box now cites the FORE v AICTE fine, the AISHE publication lag and a
2026 university notice on APAAR mismatches. docs/validation/INTERVIEW_KIT.md is a
10-minute script for an admission cell; a quote recorded with permission in
ppt/field_validation.json appears as one line on slide 6 and in the notes.
</commit_message>
<xml_diff>
--- a/ppt/SIH26263_AI_Riders_Idea.pptx
+++ b/ppt/SIH26263_AI_Riders_Idea.pptx
@@ -1045,7 +1045,7 @@
           <a:lstStyle/>
           <a:p>
             <a:r>
-              <a:t>Everyone gains from one national view: AICTE and regulators catch problems at submission, institutions get explained errors, universities print APAAR on degrees, employers verify in seconds, students control access. The contrast at the bottom is the point: from years late to the same day.</a:t>
+              <a:t>Everyone gains from one national view: AICTE and regulators catch problems at submission, institutions get explained errors, universities print APAAR on degrees, employers verify in seconds, students control access. The contrast at the bottom is the point, and every item on the left is sourced: a ₹23.1 crore fine for 42 excess seats, national statistics years late, and APAAR mismatches universities are struggling with this year.</a:t>
             </a:r>
           </a:p>
         </p:txBody>
@@ -17242,8 +17242,8 @@
         </p:nvSpPr>
         <p:spPr>
           <a:xfrm>
-            <a:off x="393192" y="4754880"/>
-            <a:ext cx="1865376" cy="1389888"/>
+            <a:off x="393192" y="4736592"/>
+            <a:ext cx="1865376" cy="1426464"/>
           </a:xfrm>
           <a:prstGeom prst="rect">
             <a:avLst/>
@@ -17256,11 +17256,11 @@
           <a:p>
             <a:pPr algn="l">
               <a:spcAft>
-                <a:spcPts val="300"/>
+                <a:spcPts val="200"/>
               </a:spcAft>
             </a:pPr>
             <a:r>
-              <a:rPr sz="1000" b="1" i="0">
+              <a:rPr sz="950" b="1" i="0">
                 <a:solidFill>
                   <a:srgbClr val="B42B2B"/>
                 </a:solidFill>
@@ -17269,23 +17269,23 @@
               <a:t>✖ </a:t>
             </a:r>
             <a:r>
-              <a:rPr sz="1000" b="0" i="0">
+              <a:rPr sz="950" b="0" i="0">
                 <a:solidFill>
                   <a:srgbClr val="1A1A1A"/>
                 </a:solidFill>
                 <a:latin typeface="Arial"/>
               </a:rPr>
-              <a:t>Excess admissions surface in annual returns</a:t>
+              <a:t>42 excess seats found late: ₹23.1 cr fine (FORE v AICTE, SC 2019)</a:t>
             </a:r>
           </a:p>
           <a:p>
             <a:pPr algn="l">
               <a:spcAft>
-                <a:spcPts val="300"/>
+                <a:spcPts val="200"/>
               </a:spcAft>
             </a:pPr>
             <a:r>
-              <a:rPr sz="1000" b="1" i="0">
+              <a:rPr sz="950" b="1" i="0">
                 <a:solidFill>
                   <a:srgbClr val="B42B2B"/>
                 </a:solidFill>
@@ -17294,23 +17294,23 @@
               <a:t>✖ </a:t>
             </a:r>
             <a:r>
-              <a:rPr sz="1000" b="0" i="0">
+              <a:rPr sz="950" b="0" i="0">
                 <a:solidFill>
                   <a:srgbClr val="1A1A1A"/>
                 </a:solidFill>
                 <a:latin typeface="Arial"/>
               </a:rPr>
-              <a:t>AISHE figures arrive 2–3 years late</a:t>
+              <a:t>AISHE 2022-23 report published only in 2026</a:t>
             </a:r>
           </a:p>
           <a:p>
             <a:pPr algn="l">
               <a:spcAft>
-                <a:spcPts val="300"/>
+                <a:spcPts val="200"/>
               </a:spcAft>
             </a:pPr>
             <a:r>
-              <a:rPr sz="1000" b="1" i="0">
+              <a:rPr sz="950" b="1" i="0">
                 <a:solidFill>
                   <a:srgbClr val="B42B2B"/>
                 </a:solidFill>
@@ -17319,13 +17319,13 @@
               <a:t>✖ </a:t>
             </a:r>
             <a:r>
-              <a:rPr sz="1000" b="0" i="0">
+              <a:rPr sz="950" b="0" i="0">
                 <a:solidFill>
                   <a:srgbClr val="1A1A1A"/>
                 </a:solidFill>
                 <a:latin typeface="Arial"/>
               </a:rPr>
-              <a:t>Same student at two colleges goes unseen</a:t>
+              <a:t>“a number of students have mismatch in Aadhaar and APAAR ID details” (CU Srinagar, 2026)</a:t>
             </a:r>
           </a:p>
         </p:txBody>
@@ -17417,8 +17417,8 @@
         </p:nvSpPr>
         <p:spPr>
           <a:xfrm>
-            <a:off x="4389120" y="4754880"/>
-            <a:ext cx="1892807" cy="1389888"/>
+            <a:off x="4389120" y="4736592"/>
+            <a:ext cx="1892807" cy="1426464"/>
           </a:xfrm>
           <a:prstGeom prst="rect">
             <a:avLst/>
@@ -17431,11 +17431,11 @@
           <a:p>
             <a:pPr algn="l">
               <a:spcAft>
-                <a:spcPts val="300"/>
+                <a:spcPts val="200"/>
               </a:spcAft>
             </a:pPr>
             <a:r>
-              <a:rPr sz="1000" b="1" i="0">
+              <a:rPr sz="950" b="1" i="0">
                 <a:solidFill>
                   <a:srgbClr val="1E7B3E"/>
                 </a:solidFill>
@@ -17444,23 +17444,23 @@
               <a:t>✔ </a:t>
             </a:r>
             <a:r>
-              <a:rPr sz="1000" b="0" i="0">
+              <a:rPr sz="950" b="0" i="0">
                 <a:solidFill>
                   <a:srgbClr val="1A1A1A"/>
                 </a:solidFill>
                 <a:latin typeface="Arial"/>
               </a:rPr>
-              <a:t>Seat #61 of 60 stopped the day it is uploaded</a:t>
+              <a:t>Seat #61 of 60 stopped the day it is uploaded, before any fine</a:t>
             </a:r>
           </a:p>
           <a:p>
             <a:pPr algn="l">
               <a:spcAft>
-                <a:spcPts val="300"/>
+                <a:spcPts val="200"/>
               </a:spcAft>
             </a:pPr>
             <a:r>
-              <a:rPr sz="1000" b="1" i="0">
+              <a:rPr sz="950" b="1" i="0">
                 <a:solidFill>
                   <a:srgbClr val="1E7B3E"/>
                 </a:solidFill>
@@ -17469,23 +17469,23 @@
               <a:t>✔ </a:t>
             </a:r>
             <a:r>
-              <a:rPr sz="1000" b="0" i="0">
+              <a:rPr sz="950" b="0" i="0">
                 <a:solidFill>
                   <a:srgbClr val="1A1A1A"/>
                 </a:solidFill>
                 <a:latin typeface="Arial"/>
               </a:rPr>
-              <a:t>Duplicates and ghost rings flagged within minutes</a:t>
+              <a:t>Same-day national view; duplicates flagged within minutes</a:t>
             </a:r>
           </a:p>
           <a:p>
             <a:pPr algn="l">
               <a:spcAft>
-                <a:spcPts val="300"/>
+                <a:spcPts val="200"/>
               </a:spcAft>
             </a:pPr>
             <a:r>
-              <a:rPr sz="1000" b="1" i="0">
+              <a:rPr sz="950" b="1" i="0">
                 <a:solidFill>
                   <a:srgbClr val="1E7B3E"/>
                 </a:solidFill>
@@ -17494,13 +17494,13 @@
               <a:t>✔ </a:t>
             </a:r>
             <a:r>
-              <a:rPr sz="1000" b="0" i="0">
+              <a:rPr sz="950" b="0" i="0">
                 <a:solidFill>
                   <a:srgbClr val="1A1A1A"/>
                 </a:solidFill>
                 <a:latin typeface="Arial"/>
               </a:rPr>
-              <a:t>QR check in seconds, even offline</a:t>
+              <a:t>Mismatches returned with the reason, fixed by re-upload</a:t>
             </a:r>
           </a:p>
         </p:txBody>

</xml_diff>

<commit_message>
Final idea deck: sourced figures, verified claims
Slide 2 states AICTE enrolment (Lok Sabha) and APAAR IDs issued (Rajya Sabha);
problem pairs cite the PS and the APH. Slide 5 adds the APAAR opt-out ruling;
slide 6 lists ten references. Speaker notes corrected. CLAIMS.md maps each new
figure to its source.
</commit_message>
<xml_diff>
--- a/ppt/SIH26263_AI_Riders_Idea.pptx
+++ b/ppt/SIH26263_AI_Riders_Idea.pptx
@@ -644,7 +644,7 @@
           <a:lstStyle/>
           <a:p>
             <a:r>
-              <a:t>AICTE today sees totals, late. Excess admission costs five times the fee per student, yet it surfaces in annual returns. Our flow is the one the problem statement asks for: upload, APAAR check, verification, central record, live monitoring, consented verification. What is new: name matching that keeps twins apart, ghost-admission rings, decisions that are remembered, signed audit checkpoints, rules as data, and APAAR on every degree.</a:t>
+              <a:t>29.6 lakh enrolments in AICTE institutions in 2025-26, 24.25 crore APAAR IDs, yet AICTE today sees totals, late. Excess admission costs five times the fee per student, yet it surfaces in annual returns. Our flow is the one the problem statement asks for: upload, APAAR check, verification, central record, live monitoring, consented verification. What is new: name matching that keeps twins apart, ghost-admission rings, decisions that are remembered, signed audit checkpoints, rules as data, and APAAR on every degree.</a:t>
             </a:r>
           </a:p>
         </p:txBody>
@@ -872,7 +872,7 @@
           <a:lstStyle/>
           <a:p>
             <a:r>
-              <a:t>Feasibility is measured, not promised. On name pairs written independently of our data: precision 0.79, recall 0.92, against 0.65 and 0.68 for the usual fuzzy match. No twin is ever merged. Planted cases are regression checks, and we say so. 59 tests on SQLite and PostgreSQL. Each risk has a built answer, and the roadmap goes from one-state pilot to national rollout within a year on open-source software.</a:t>
+              <a:t>Feasibility is measured, not promised. On name pairs written independently of our data: precision 0.79, recall 0.92, against 0.65 and 0.68 for our earlier fuzzy matcher. None of the 80 seeded twin pairs is merged. Planted cases are regression checks, and we say so. 59 tests on SQLite and PostgreSQL. Each risk has a built answer, and the roadmap goes from one-state pilot to national rollout within a year on open-source software.</a:t>
             </a:r>
           </a:p>
         </p:txBody>
@@ -6368,8 +6368,8 @@
         </p:nvSpPr>
         <p:spPr>
           <a:xfrm>
-            <a:off x="2926080" y="731520"/>
-            <a:ext cx="6309360" cy="310896"/>
+            <a:off x="2011680" y="731520"/>
+            <a:ext cx="8138160" cy="310896"/>
           </a:xfrm>
           <a:prstGeom prst="rect">
             <a:avLst/>
@@ -6382,13 +6382,40 @@
           <a:p>
             <a:pPr algn="ctr"/>
             <a:r>
-              <a:rPr sz="1400" b="0" i="0">
+              <a:rPr sz="1200" b="1" i="0">
+                <a:solidFill>
+                  <a:srgbClr val="1F3864"/>
+                </a:solidFill>
+                <a:latin typeface="Arial"/>
+              </a:rPr>
+              <a:t>29.6 lakh</a:t>
+            </a:r>
+            <a:r>
+              <a:rPr sz="1200" b="0" i="0">
                 <a:solidFill>
                   <a:srgbClr val="595959"/>
                 </a:solidFill>
                 <a:latin typeface="Arial"/>
               </a:rPr>
-              <a:t>APAAR-linked student data, validation &amp; verification platform for AICTE</a:t>
+              <a:t> enrolments in AICTE institutions (2025-26)  ·  </a:t>
+            </a:r>
+            <a:r>
+              <a:rPr sz="1200" b="1" i="0">
+                <a:solidFill>
+                  <a:srgbClr val="1F3864"/>
+                </a:solidFill>
+                <a:latin typeface="Arial"/>
+              </a:rPr>
+              <a:t>24.25 crore</a:t>
+            </a:r>
+            <a:r>
+              <a:rPr sz="1200" b="0" i="0">
+                <a:solidFill>
+                  <a:srgbClr val="595959"/>
+                </a:solidFill>
+                <a:latin typeface="Arial"/>
+              </a:rPr>
+              <a:t> APAAR IDs issued (Mar 2026)</a:t>
             </a:r>
           </a:p>
         </p:txBody>
@@ -7596,7 +7623,7 @@
                 </a:solidFill>
                 <a:latin typeface="Arial"/>
               </a:rPr>
-              <a:t>Only totals reach AICTE; AISHE is 2–3 years late</a:t>
+              <a:t>Only total enrolment reaches AICTE (except PGDM), per the PS</a:t>
             </a:r>
           </a:p>
         </p:txBody>
@@ -7764,7 +7791,7 @@
                 </a:solidFill>
                 <a:latin typeface="Arial"/>
               </a:rPr>
-              <a:t>Excess admission = 5× fee fine per student, found late</a:t>
+              <a:t>Excess admission: fine of 5× the fee per student (APH)</a:t>
             </a:r>
           </a:p>
         </p:txBody>
@@ -7932,7 +7959,7 @@
                 </a:solidFill>
                 <a:latin typeface="Arial"/>
               </a:rPr>
-              <a:t>Same student at 2 colleges; agent-filled admissions</a:t>
+              <a:t>Same student enrolled at two colleges goes unseen</a:t>
             </a:r>
           </a:p>
         </p:txBody>
@@ -8100,7 +8127,7 @@
                 </a:solidFill>
                 <a:latin typeface="Arial"/>
               </a:rPr>
-              <a:t>Records can't be verified at source</a:t>
+              <a:t>Records are hard to verify at source (PS)</a:t>
             </a:r>
           </a:p>
         </p:txBody>
@@ -15541,7 +15568,7 @@
                 </a:solidFill>
                 <a:latin typeface="Arial"/>
               </a:rPr>
-              <a:t>open source, no licence fees; est. ₹20–25 lakh/yr MeitY-empanelled cloud</a:t>
+              <a:t>open-source stack, no licence fees; the whole prototype runs on one free 512 MB instance</a:t>
             </a:r>
           </a:p>
         </p:txBody>
@@ -17742,8 +17769,8 @@
                 </a:solidFill>
                 <a:latin typeface="Arial"/>
               </a:rPr>
-              <a:t>fair admissions; no student
-excluded for opting out</a:t>
+              <a:t>APAAR opt-outs never refused,
+as the Supreme Court requires</a:t>
             </a:r>
           </a:p>
         </p:txBody>
@@ -17921,8 +17948,8 @@
                 </a:solidFill>
                 <a:latin typeface="Arial"/>
               </a:rPr>
-              <a:t>no licence cost; one upload
-replaces repeated returns</a:t>
+              <a:t>MIT / BSD / Apache stack: no
+licence fees; one upload, all users</a:t>
             </a:r>
           </a:p>
         </p:txBody>
@@ -18100,8 +18127,8 @@
                 </a:solidFill>
                 <a:latin typeface="Arial"/>
               </a:rPr>
-              <a:t>paperless returns and
-verification; no courier checks</a:t>
+              <a:t>paper returns and verification
+letters replaced by upload + QR</a:t>
             </a:r>
           </a:p>
         </p:txBody>
@@ -20324,7 +20351,7 @@
           <a:p>
             <a:pPr algn="l">
               <a:spcAft>
-                <a:spcPts val="300"/>
+                <a:spcPts val="200"/>
               </a:spcAft>
             </a:pPr>
             <a:r>
@@ -20349,7 +20376,7 @@
           <a:p>
             <a:pPr algn="l">
               <a:spcAft>
-                <a:spcPts val="300"/>
+                <a:spcPts val="200"/>
               </a:spcAft>
             </a:pPr>
             <a:r>
@@ -20374,7 +20401,7 @@
           <a:p>
             <a:pPr algn="l">
               <a:spcAft>
-                <a:spcPts val="300"/>
+                <a:spcPts val="200"/>
               </a:spcAft>
             </a:pPr>
             <a:r>
@@ -20399,7 +20426,7 @@
           <a:p>
             <a:pPr algn="l">
               <a:spcAft>
-                <a:spcPts val="300"/>
+                <a:spcPts val="200"/>
               </a:spcAft>
             </a:pPr>
             <a:r>
@@ -20424,7 +20451,7 @@
           <a:p>
             <a:pPr algn="l">
               <a:spcAft>
-                <a:spcPts val="300"/>
+                <a:spcPts val="200"/>
               </a:spcAft>
             </a:pPr>
             <a:r>
@@ -20449,7 +20476,7 @@
           <a:p>
             <a:pPr algn="l">
               <a:spcAft>
-                <a:spcPts val="300"/>
+                <a:spcPts val="200"/>
               </a:spcAft>
             </a:pPr>
             <a:r>
@@ -20459,7 +20486,7 @@
                 </a:solidFill>
                 <a:latin typeface="Arial"/>
               </a:rPr>
-              <a:t>6. APAAR consent and opt-out: MoE guidance; Supreme Court proceedings 2026  </a:t>
+              <a:t>6. APAAR opt-out: Orissa HC, Rohit Anand Das (Dec 2025); Supreme Court direction (Jul 2026)  </a:t>
             </a:r>
             <a:r>
               <a:rPr sz="950" b="0" i="0">
@@ -20468,13 +20495,13 @@
                 </a:solidFill>
                 <a:latin typeface="Arial"/>
               </a:rPr>
-              <a:t>apaar.education.gov.in</a:t>
+              <a:t>scconline.com · livelaw.in</a:t>
             </a:r>
           </a:p>
           <a:p>
             <a:pPr algn="l">
               <a:spcAft>
-                <a:spcPts val="300"/>
+                <a:spcPts val="200"/>
               </a:spcAft>
             </a:pPr>
             <a:r>
@@ -20484,7 +20511,7 @@
                 </a:solidFill>
                 <a:latin typeface="Arial"/>
               </a:rPr>
-              <a:t>7. Digital Personal Data Protection Act 2023; DPDP Rules 2025  </a:t>
+              <a:t>7. Parliament replies: AICTE enrolment 2025-26 (Lok Sabha); APAAR IDs at 30 Mar 2026 (Rajya Sabha)  </a:t>
             </a:r>
             <a:r>
               <a:rPr sz="950" b="0" i="0">
@@ -20493,13 +20520,13 @@
                 </a:solidFill>
                 <a:latin typeface="Arial"/>
               </a:rPr>
-              <a:t>meity.gov.in</a:t>
+              <a:t>sansad.in</a:t>
             </a:r>
           </a:p>
           <a:p>
             <a:pPr algn="l">
               <a:spcAft>
-                <a:spcPts val="300"/>
+                <a:spcPts val="200"/>
               </a:spcAft>
             </a:pPr>
             <a:r>
@@ -20509,7 +20536,7 @@
                 </a:solidFill>
                 <a:latin typeface="Arial"/>
               </a:rPr>
-              <a:t>8. W3C Verifiable Credentials; RFC 8032 (Ed25519)  </a:t>
+              <a:t>8. Digital Personal Data Protection Act 2023; DPDP Rules 2025  </a:t>
             </a:r>
             <a:r>
               <a:rPr sz="950" b="0" i="0">
@@ -20518,13 +20545,13 @@
                 </a:solidFill>
                 <a:latin typeface="Arial"/>
               </a:rPr>
-              <a:t>w3.org · rfc-editor.org</a:t>
+              <a:t>meity.gov.in</a:t>
             </a:r>
           </a:p>
           <a:p>
             <a:pPr algn="l">
               <a:spcAft>
-                <a:spcPts val="300"/>
+                <a:spcPts val="200"/>
               </a:spcAft>
             </a:pPr>
             <a:r>
@@ -20534,7 +20561,32 @@
                 </a:solidFill>
                 <a:latin typeface="Arial"/>
               </a:rPr>
-              <a:t>9. Liu et al. (2008) Isolation Forest; IDinsight (2021) matching Indian names  </a:t>
+              <a:t>9. W3C Verifiable Credentials; RFC 8032 (Ed25519)  </a:t>
+            </a:r>
+            <a:r>
+              <a:rPr sz="950" b="0" i="0">
+                <a:solidFill>
+                  <a:srgbClr val="0070C0"/>
+                </a:solidFill>
+                <a:latin typeface="Arial"/>
+              </a:rPr>
+              <a:t>w3.org · rfc-editor.org</a:t>
+            </a:r>
+          </a:p>
+          <a:p>
+            <a:pPr algn="l">
+              <a:spcAft>
+                <a:spcPts val="200"/>
+              </a:spcAft>
+            </a:pPr>
+            <a:r>
+              <a:rPr sz="1000" b="0" i="0">
+                <a:solidFill>
+                  <a:srgbClr val="1A1A1A"/>
+                </a:solidFill>
+                <a:latin typeface="Arial"/>
+              </a:rPr>
+              <a:t>10. Liu, Ting &amp; Zhou (2008) Isolation Forest; IDinsight on matching Indian names  </a:t>
             </a:r>
             <a:r>
               <a:rPr sz="950" b="0" i="0">

</xml_diff>

<commit_message>
Deck: answer the review point by point
- What is new, stated against APAAR, NAD / DigiLocker and ABC
- Built / Simulated / Planned line, so no mock reads as a live integration
- Penalty arithmetic shown (42 x 11 lakh x 5 = 23.1 crore)
- Overstatements removed (live, before any fine, instant, within minutes)
- Held-out twin result shown next to the seeded one; synthetic data and
  officer-decides stated on the feasibility slide
- Unconfirmed rule values marked warn-only; benefits marked expected,
  with pilot measures in the roadmap
- Comparison ticks tied to tests; larger minimum text sizes
- Evidence file (coverage, accessibility) feeds the deck; screenshots refreshed
</commit_message>
<xml_diff>
--- a/ppt/SIH26263_AI_Riders_Idea.pptx
+++ b/ppt/SIH26263_AI_Riders_Idea.pptx
@@ -644,7 +644,7 @@
           <a:lstStyle/>
           <a:p>
             <a:r>
-              <a:t>29.6 lakh enrolments in AICTE institutions in 2025-26, 24.25 crore APAAR IDs, yet AICTE today sees totals, late. Excess admission costs five times the fee per student, yet it surfaces in annual returns. Our flow is the one the problem statement asks for: upload, APAAR check, verification, central record, live monitoring, consented verification. What is new: name matching that keeps twins apart, ghost-admission rings, decisions that are remembered, signed audit checkpoints, rules as data, and APAAR on every degree.</a:t>
+              <a:t>29.6 lakh enrolments in AICTE institutions in 2025-26 and 24.25 crore APAAR IDs, yet AICTE today receives totals only. Excess admission costs five times the fee per student, and it surfaces in annual returns or inspections. Our flow is the one the problem statement asks for: upload, APAAR check, verification, central record, monitoring after every submission, consented verification. What is new is the per-student check against approved intake, which no existing national system makes, plus twin-safe name matching, ghost-admission rings, remembered decisions, signed audit checkpoints, sourced rules and APAAR on every degree.</a:t>
             </a:r>
           </a:p>
         </p:txBody>
@@ -758,7 +758,7 @@
           <a:lstStyle/>
           <a:p>
             <a:r>
-              <a:t>Open-source stack, PostgreSQL tested. Every row goes through 31 explained rules; errors come back with reasons; accepted rows trigger a national scan and risk scoring against peers. The screenshot is the real prototype: 77 rows, 65 accepted, 12 returned. Scan the QR to try it.</a:t>
+              <a:t>Open-source stack, PostgreSQL tested. Every row goes through 31 explained rules; errors come back with reasons; accepted rows trigger a national scan and risk scoring against peers. The screenshot is the real prototype: 77 rows, 65 accepted, 12 returned. We are explicit about what is simulated: there is no public APAAR API yet, so the registry lookup is a mock behind an adapter that switches to DigiLocker or API Setu after onboarding.</a:t>
             </a:r>
           </a:p>
         </p:txBody>
@@ -872,7 +872,7 @@
           <a:lstStyle/>
           <a:p>
             <a:r>
-              <a:t>Feasibility is measured, not promised. On name pairs written independently of our data: precision 0.79, recall 0.92, against 0.65 and 0.68 for our earlier fuzzy matcher. None of the 80 seeded twin pairs is merged. Planted cases are regression checks, and we say so. 59 tests on SQLite and PostgreSQL. Each risk has a built answer, and the roadmap goes from one-state pilot to national rollout within a year on open-source software.</a:t>
+              <a:t>These are measurements on synthetic data, and we say so. On 49 held-out name pairs: precision 0.79, recall 0.92, against 0.65 and 0.68 for our earlier matcher. None of the 80 seeded twin pairs is flagged; 2 of 12 held-out twin pairs are, and go to an officer, who decides. Real-world accuracy is the first thing the pilot measures. 65 tests on SQLite and PostgreSQL with 93% coverage, plus security and accessibility checks on every push.</a:t>
             </a:r>
           </a:p>
         </p:txBody>
@@ -1045,7 +1045,7 @@
           <a:lstStyle/>
           <a:p>
             <a:r>
-              <a:t>Everyone gains from one national view: AICTE and regulators catch problems at submission, institutions get explained errors, universities print APAAR on degrees, employers verify in seconds, students control access. The contrast at the bottom is the point, and every item on the left is sourced: a ₹23.1 crore fine for 42 excess seats, national statistics years late, and APAAR mismatches universities are struggling with this year.</a:t>
+              <a:t>Everyone gains from one national view: AICTE and regulators see problems at submission, institutions get explained errors, universities print APAAR on degrees, employers check a QR, students control access. Every item on the left is sourced: 42 excess seats times an 11 lakh fee times five is the 23.1 crore fine the Supreme Court upheld, national statistics arrive years late, and universities report APAAR mismatches this year. The benefits on the right are expected, not yet measured; the pilot measures them.</a:t>
             </a:r>
           </a:p>
         </p:txBody>
@@ -6534,8 +6534,8 @@
         </p:nvSpPr>
         <p:spPr>
           <a:xfrm>
-            <a:off x="1058417" y="1920240"/>
-            <a:ext cx="603504" cy="603504"/>
+            <a:off x="1085849" y="1883664"/>
+            <a:ext cx="548640" cy="548640"/>
           </a:xfrm>
           <a:prstGeom prst="ellipse">
             <a:avLst/>
@@ -6584,8 +6584,8 @@
         </p:blipFill>
         <p:spPr>
           <a:xfrm>
-            <a:off x="1191188" y="2053010"/>
-            <a:ext cx="337962" cy="337962"/>
+            <a:off x="1206550" y="2004364"/>
+            <a:ext cx="307238" cy="307238"/>
           </a:xfrm>
           <a:prstGeom prst="rect">
             <a:avLst/>
@@ -6600,8 +6600,8 @@
         </p:nvCxnSpPr>
         <p:spPr>
           <a:xfrm>
-            <a:off x="1744217" y="2221992"/>
-            <a:ext cx="1129284" cy="0"/>
+            <a:off x="1725929" y="2157984"/>
+            <a:ext cx="1165860" cy="0"/>
           </a:xfrm>
           <a:prstGeom prst="line">
             <a:avLst/>
@@ -6636,7 +6636,7 @@
         </p:nvSpPr>
         <p:spPr>
           <a:xfrm>
-            <a:off x="411479" y="2560320"/>
+            <a:off x="411479" y="2450592"/>
             <a:ext cx="1897379" cy="256032"/>
           </a:xfrm>
           <a:prstGeom prst="rect">
@@ -6669,7 +6669,7 @@
         </p:nvSpPr>
         <p:spPr>
           <a:xfrm>
-            <a:off x="411479" y="2798064"/>
+            <a:off x="411479" y="2679192"/>
             <a:ext cx="1897379" cy="237744"/>
           </a:xfrm>
           <a:prstGeom prst="rect">
@@ -6702,8 +6702,8 @@
         </p:nvSpPr>
         <p:spPr>
           <a:xfrm>
-            <a:off x="2955798" y="1920240"/>
-            <a:ext cx="603504" cy="603504"/>
+            <a:off x="2983230" y="1883664"/>
+            <a:ext cx="548640" cy="548640"/>
           </a:xfrm>
           <a:prstGeom prst="ellipse">
             <a:avLst/>
@@ -6752,8 +6752,8 @@
         </p:blipFill>
         <p:spPr>
           <a:xfrm>
-            <a:off x="3088568" y="2053010"/>
-            <a:ext cx="337962" cy="337962"/>
+            <a:off x="3103930" y="2004364"/>
+            <a:ext cx="307238" cy="307238"/>
           </a:xfrm>
           <a:prstGeom prst="rect">
             <a:avLst/>
@@ -6768,8 +6768,8 @@
         </p:nvCxnSpPr>
         <p:spPr>
           <a:xfrm>
-            <a:off x="3641598" y="2221992"/>
-            <a:ext cx="1129283" cy="0"/>
+            <a:off x="3623310" y="2157984"/>
+            <a:ext cx="1165859" cy="0"/>
           </a:xfrm>
           <a:prstGeom prst="line">
             <a:avLst/>
@@ -6804,7 +6804,7 @@
         </p:nvSpPr>
         <p:spPr>
           <a:xfrm>
-            <a:off x="2308860" y="2560320"/>
+            <a:off x="2308860" y="2450592"/>
             <a:ext cx="1897379" cy="256032"/>
           </a:xfrm>
           <a:prstGeom prst="rect">
@@ -6837,7 +6837,7 @@
         </p:nvSpPr>
         <p:spPr>
           <a:xfrm>
-            <a:off x="2308860" y="2798064"/>
+            <a:off x="2308860" y="2679192"/>
             <a:ext cx="1897379" cy="237744"/>
           </a:xfrm>
           <a:prstGeom prst="rect">
@@ -6870,8 +6870,8 @@
         </p:nvSpPr>
         <p:spPr>
           <a:xfrm>
-            <a:off x="4853177" y="1920240"/>
-            <a:ext cx="603504" cy="603504"/>
+            <a:off x="4880609" y="1883664"/>
+            <a:ext cx="548640" cy="548640"/>
           </a:xfrm>
           <a:prstGeom prst="ellipse">
             <a:avLst/>
@@ -6920,8 +6920,8 @@
         </p:blipFill>
         <p:spPr>
           <a:xfrm>
-            <a:off x="4985948" y="2053010"/>
-            <a:ext cx="337962" cy="337962"/>
+            <a:off x="5001310" y="2004364"/>
+            <a:ext cx="307238" cy="307238"/>
           </a:xfrm>
           <a:prstGeom prst="rect">
             <a:avLst/>
@@ -6936,8 +6936,8 @@
         </p:nvCxnSpPr>
         <p:spPr>
           <a:xfrm>
-            <a:off x="5538977" y="2221992"/>
-            <a:ext cx="1129284" cy="0"/>
+            <a:off x="5520690" y="2157984"/>
+            <a:ext cx="1165859" cy="0"/>
           </a:xfrm>
           <a:prstGeom prst="line">
             <a:avLst/>
@@ -6972,7 +6972,7 @@
         </p:nvSpPr>
         <p:spPr>
           <a:xfrm>
-            <a:off x="4206240" y="2560320"/>
+            <a:off x="4206240" y="2450592"/>
             <a:ext cx="1897379" cy="256032"/>
           </a:xfrm>
           <a:prstGeom prst="rect">
@@ -7005,7 +7005,7 @@
         </p:nvSpPr>
         <p:spPr>
           <a:xfrm>
-            <a:off x="4206240" y="2798064"/>
+            <a:off x="4206240" y="2679192"/>
             <a:ext cx="1897379" cy="237744"/>
           </a:xfrm>
           <a:prstGeom prst="rect">
@@ -7038,8 +7038,8 @@
         </p:nvSpPr>
         <p:spPr>
           <a:xfrm>
-            <a:off x="6750557" y="1920240"/>
-            <a:ext cx="603504" cy="603504"/>
+            <a:off x="6777990" y="1883664"/>
+            <a:ext cx="548640" cy="548640"/>
           </a:xfrm>
           <a:prstGeom prst="ellipse">
             <a:avLst/>
@@ -7088,8 +7088,8 @@
         </p:blipFill>
         <p:spPr>
           <a:xfrm>
-            <a:off x="6883328" y="2053010"/>
-            <a:ext cx="337962" cy="337962"/>
+            <a:off x="6898690" y="2004364"/>
+            <a:ext cx="307238" cy="307238"/>
           </a:xfrm>
           <a:prstGeom prst="rect">
             <a:avLst/>
@@ -7104,8 +7104,8 @@
         </p:nvCxnSpPr>
         <p:spPr>
           <a:xfrm>
-            <a:off x="7436358" y="2221992"/>
-            <a:ext cx="1129284" cy="0"/>
+            <a:off x="7418069" y="2157984"/>
+            <a:ext cx="1165861" cy="0"/>
           </a:xfrm>
           <a:prstGeom prst="line">
             <a:avLst/>
@@ -7140,7 +7140,7 @@
         </p:nvSpPr>
         <p:spPr>
           <a:xfrm>
-            <a:off x="6103620" y="2560320"/>
+            <a:off x="6103620" y="2450592"/>
             <a:ext cx="1897379" cy="256032"/>
           </a:xfrm>
           <a:prstGeom prst="rect">
@@ -7173,7 +7173,7 @@
         </p:nvSpPr>
         <p:spPr>
           <a:xfrm>
-            <a:off x="6103620" y="2798064"/>
+            <a:off x="6103620" y="2679192"/>
             <a:ext cx="1897379" cy="237744"/>
           </a:xfrm>
           <a:prstGeom prst="rect">
@@ -7206,8 +7206,8 @@
         </p:nvSpPr>
         <p:spPr>
           <a:xfrm>
-            <a:off x="8647937" y="1920240"/>
-            <a:ext cx="603504" cy="603504"/>
+            <a:off x="8675369" y="1883664"/>
+            <a:ext cx="548640" cy="548640"/>
           </a:xfrm>
           <a:prstGeom prst="ellipse">
             <a:avLst/>
@@ -7256,8 +7256,8 @@
         </p:blipFill>
         <p:spPr>
           <a:xfrm>
-            <a:off x="8780708" y="2053010"/>
-            <a:ext cx="337962" cy="337962"/>
+            <a:off x="8796070" y="2004364"/>
+            <a:ext cx="307238" cy="307238"/>
           </a:xfrm>
           <a:prstGeom prst="rect">
             <a:avLst/>
@@ -7272,8 +7272,8 @@
         </p:nvCxnSpPr>
         <p:spPr>
           <a:xfrm>
-            <a:off x="9333737" y="2221992"/>
-            <a:ext cx="1129284" cy="0"/>
+            <a:off x="9315449" y="2157984"/>
+            <a:ext cx="1165860" cy="0"/>
           </a:xfrm>
           <a:prstGeom prst="line">
             <a:avLst/>
@@ -7308,7 +7308,7 @@
         </p:nvSpPr>
         <p:spPr>
           <a:xfrm>
-            <a:off x="8000999" y="2560320"/>
+            <a:off x="8000999" y="2450592"/>
             <a:ext cx="1897379" cy="256032"/>
           </a:xfrm>
           <a:prstGeom prst="rect">
@@ -7341,7 +7341,7 @@
         </p:nvSpPr>
         <p:spPr>
           <a:xfrm>
-            <a:off x="8000999" y="2798064"/>
+            <a:off x="8000999" y="2679192"/>
             <a:ext cx="1897379" cy="237744"/>
           </a:xfrm>
           <a:prstGeom prst="rect">
@@ -7361,7 +7361,7 @@
                 </a:solidFill>
                 <a:latin typeface="Arial"/>
               </a:rPr>
-              <a:t>live, case by case</a:t>
+              <a:t>after every submission</a:t>
             </a:r>
           </a:p>
         </p:txBody>
@@ -7374,8 +7374,8 @@
         </p:nvSpPr>
         <p:spPr>
           <a:xfrm>
-            <a:off x="10545317" y="1920240"/>
-            <a:ext cx="603504" cy="603504"/>
+            <a:off x="10572749" y="1883664"/>
+            <a:ext cx="548640" cy="548640"/>
           </a:xfrm>
           <a:prstGeom prst="ellipse">
             <a:avLst/>
@@ -7424,8 +7424,8 @@
         </p:blipFill>
         <p:spPr>
           <a:xfrm>
-            <a:off x="10678088" y="2053010"/>
-            <a:ext cx="337962" cy="337962"/>
+            <a:off x="10693450" y="2004364"/>
+            <a:ext cx="307238" cy="307238"/>
           </a:xfrm>
           <a:prstGeom prst="rect">
             <a:avLst/>
@@ -7440,7 +7440,7 @@
         </p:nvSpPr>
         <p:spPr>
           <a:xfrm>
-            <a:off x="9898379" y="2560320"/>
+            <a:off x="9898379" y="2450592"/>
             <a:ext cx="1897379" cy="256032"/>
           </a:xfrm>
           <a:prstGeom prst="rect">
@@ -7473,7 +7473,7 @@
         </p:nvSpPr>
         <p:spPr>
           <a:xfrm>
-            <a:off x="9898379" y="2798064"/>
+            <a:off x="9898379" y="2679192"/>
             <a:ext cx="1897379" cy="237744"/>
           </a:xfrm>
           <a:prstGeom prst="rect">
@@ -7506,7 +7506,73 @@
         </p:nvSpPr>
         <p:spPr>
           <a:xfrm>
-            <a:off x="320040" y="3200400"/>
+            <a:off x="320040" y="2962656"/>
+            <a:ext cx="11548872" cy="274320"/>
+          </a:xfrm>
+          <a:prstGeom prst="roundRect">
+            <a:avLst>
+              <a:gd name="adj" fmla="val 20000"/>
+            </a:avLst>
+          </a:prstGeom>
+          <a:solidFill>
+            <a:srgbClr val="FDF1E6"/>
+          </a:solidFill>
+          <a:ln w="9525">
+            <a:solidFill>
+              <a:srgbClr val="E46C0A"/>
+            </a:solidFill>
+          </a:ln>
+          <a:effectLst/>
+        </p:spPr>
+        <p:style>
+          <a:lnRef idx="1">
+            <a:schemeClr val="accent1"/>
+          </a:lnRef>
+          <a:fillRef idx="3">
+            <a:schemeClr val="accent1"/>
+          </a:fillRef>
+          <a:effectRef idx="2">
+            <a:schemeClr val="accent1"/>
+          </a:effectRef>
+          <a:fontRef idx="minor">
+            <a:schemeClr val="lt1"/>
+          </a:fontRef>
+        </p:style>
+        <p:txBody>
+          <a:bodyPr rtlCol="0" anchor="ctr" wrap="square" lIns="45720" rIns="45720" tIns="18288" bIns="18288"/>
+          <a:lstStyle/>
+          <a:p>
+            <a:pPr algn="l"/>
+            <a:r>
+              <a:rPr sz="1100" b="1" i="0">
+                <a:solidFill>
+                  <a:srgbClr val="E46C0A"/>
+                </a:solidFill>
+                <a:latin typeface="Arial"/>
+              </a:rPr>
+              <a:t>What is new  </a:t>
+            </a:r>
+            <a:r>
+              <a:rPr sz="1100" b="0" i="0">
+                <a:solidFill>
+                  <a:srgbClr val="1A1A1A"/>
+                </a:solidFill>
+                <a:latin typeface="Arial"/>
+              </a:rPr>
+              <a:t>APAAR, NAD / DigiLocker and ABC hold IDs and awards; none checks each admission against approved intake. We add that check (slide 6).</a:t>
+            </a:r>
+          </a:p>
+        </p:txBody>
+      </p:sp>
+      <p:sp>
+        <p:nvSpPr>
+          <p:cNvPr id="15396" name="Rounded Rectangle 15395"/>
+          <p:cNvSpPr/>
+          <p:nvPr/>
+        </p:nvSpPr>
+        <p:spPr>
+          <a:xfrm>
+            <a:off x="320040" y="3328416"/>
             <a:ext cx="5669280" cy="310896"/>
           </a:xfrm>
           <a:prstGeom prst="roundRect">
@@ -7564,13 +7630,13 @@
       </p:sp>
       <p:sp>
         <p:nvSpPr>
-          <p:cNvPr id="15396" name="Rounded Rectangle 15395"/>
+          <p:cNvPr id="15397" name="Rounded Rectangle 15396"/>
           <p:cNvSpPr/>
           <p:nvPr/>
         </p:nvSpPr>
         <p:spPr>
           <a:xfrm>
-            <a:off x="320040" y="3639312"/>
+            <a:off x="320040" y="3730752"/>
             <a:ext cx="2514600" cy="548640"/>
           </a:xfrm>
           <a:prstGeom prst="roundRect">
@@ -7630,13 +7696,13 @@
       </p:sp>
       <p:cxnSp>
         <p:nvCxnSpPr>
-          <p:cNvPr id="15397" name="Connector 15396"/>
+          <p:cNvPr id="15398" name="Connector 15397"/>
           <p:cNvCxnSpPr/>
           <p:nvPr/>
         </p:nvCxnSpPr>
         <p:spPr>
           <a:xfrm>
-            <a:off x="2880360" y="3913632"/>
+            <a:off x="2880360" y="4005072"/>
             <a:ext cx="457200" cy="0"/>
           </a:xfrm>
           <a:prstGeom prst="line">
@@ -7666,13 +7732,13 @@
       </p:cxnSp>
       <p:sp>
         <p:nvSpPr>
-          <p:cNvPr id="15398" name="Rounded Rectangle 15397"/>
+          <p:cNvPr id="15399" name="Rounded Rectangle 15398"/>
           <p:cNvSpPr/>
           <p:nvPr/>
         </p:nvSpPr>
         <p:spPr>
           <a:xfrm>
-            <a:off x="3383280" y="3639312"/>
+            <a:off x="3383280" y="3730752"/>
             <a:ext cx="2606040" cy="548640"/>
           </a:xfrm>
           <a:prstGeom prst="roundRect">
@@ -7725,20 +7791,20 @@
                 </a:solidFill>
                 <a:latin typeface="Arial"/>
               </a:rPr>
-              <a:t>Student-level records keyed on APAAR, live</a:t>
-            </a:r>
-          </a:p>
-        </p:txBody>
-      </p:sp>
-      <p:sp>
-        <p:nvSpPr>
-          <p:cNvPr id="15399" name="Rounded Rectangle 15398"/>
+              <a:t>Student-level records keyed on APAAR, per upload</a:t>
+            </a:r>
+          </a:p>
+        </p:txBody>
+      </p:sp>
+      <p:sp>
+        <p:nvSpPr>
+          <p:cNvPr id="15400" name="Rounded Rectangle 15399"/>
           <p:cNvSpPr/>
           <p:nvPr/>
         </p:nvSpPr>
         <p:spPr>
           <a:xfrm>
-            <a:off x="320040" y="4297680"/>
+            <a:off x="320040" y="4370832"/>
             <a:ext cx="2514600" cy="548640"/>
           </a:xfrm>
           <a:prstGeom prst="roundRect">
@@ -7798,13 +7864,13 @@
       </p:sp>
       <p:cxnSp>
         <p:nvCxnSpPr>
-          <p:cNvPr id="15400" name="Connector 15399"/>
+          <p:cNvPr id="15401" name="Connector 15400"/>
           <p:cNvCxnSpPr/>
           <p:nvPr/>
         </p:nvCxnSpPr>
         <p:spPr>
           <a:xfrm>
-            <a:off x="2880360" y="4572000"/>
+            <a:off x="2880360" y="4645152"/>
             <a:ext cx="457200" cy="0"/>
           </a:xfrm>
           <a:prstGeom prst="line">
@@ -7834,13 +7900,13 @@
       </p:cxnSp>
       <p:sp>
         <p:nvSpPr>
-          <p:cNvPr id="15401" name="Rounded Rectangle 15400"/>
+          <p:cNvPr id="15402" name="Rounded Rectangle 15401"/>
           <p:cNvSpPr/>
           <p:nvPr/>
         </p:nvSpPr>
         <p:spPr>
           <a:xfrm>
-            <a:off x="3383280" y="4297680"/>
+            <a:off x="3383280" y="4370832"/>
             <a:ext cx="2606040" cy="548640"/>
           </a:xfrm>
           <a:prstGeom prst="roundRect">
@@ -7893,20 +7959,20 @@
                 </a:solidFill>
                 <a:latin typeface="Arial"/>
               </a:rPr>
-              <a:t>Seat #61 of 60 blocked at upload and at submit</a:t>
-            </a:r>
-          </a:p>
-        </p:txBody>
-      </p:sp>
-      <p:sp>
-        <p:nvSpPr>
-          <p:cNvPr id="15402" name="Rounded Rectangle 15401"/>
+              <a:t>Seat #61 of 60 refused at upload and at submit</a:t>
+            </a:r>
+          </a:p>
+        </p:txBody>
+      </p:sp>
+      <p:sp>
+        <p:nvSpPr>
+          <p:cNvPr id="15403" name="Rounded Rectangle 15402"/>
           <p:cNvSpPr/>
           <p:nvPr/>
         </p:nvSpPr>
         <p:spPr>
           <a:xfrm>
-            <a:off x="320040" y="4956048"/>
+            <a:off x="320040" y="5010912"/>
             <a:ext cx="2514600" cy="548640"/>
           </a:xfrm>
           <a:prstGeom prst="roundRect">
@@ -7966,13 +8032,13 @@
       </p:sp>
       <p:cxnSp>
         <p:nvCxnSpPr>
-          <p:cNvPr id="15403" name="Connector 15402"/>
+          <p:cNvPr id="15404" name="Connector 15403"/>
           <p:cNvCxnSpPr/>
           <p:nvPr/>
         </p:nvCxnSpPr>
         <p:spPr>
           <a:xfrm>
-            <a:off x="2880360" y="5230368"/>
+            <a:off x="2880360" y="5285232"/>
             <a:ext cx="457200" cy="0"/>
           </a:xfrm>
           <a:prstGeom prst="line">
@@ -8002,13 +8068,13 @@
       </p:cxnSp>
       <p:sp>
         <p:nvSpPr>
-          <p:cNvPr id="15404" name="Rounded Rectangle 15403"/>
+          <p:cNvPr id="15405" name="Rounded Rectangle 15404"/>
           <p:cNvSpPr/>
           <p:nvPr/>
         </p:nvSpPr>
         <p:spPr>
           <a:xfrm>
-            <a:off x="3383280" y="4956048"/>
+            <a:off x="3383280" y="5010912"/>
             <a:ext cx="2606040" cy="548640"/>
           </a:xfrm>
           <a:prstGeom prst="roundRect">
@@ -8068,13 +8134,13 @@
       </p:sp>
       <p:sp>
         <p:nvSpPr>
-          <p:cNvPr id="15405" name="Rounded Rectangle 15404"/>
+          <p:cNvPr id="15406" name="Rounded Rectangle 15405"/>
           <p:cNvSpPr/>
           <p:nvPr/>
         </p:nvSpPr>
         <p:spPr>
           <a:xfrm>
-            <a:off x="320040" y="5614416"/>
+            <a:off x="320040" y="5650992"/>
             <a:ext cx="2514600" cy="548640"/>
           </a:xfrm>
           <a:prstGeom prst="roundRect">
@@ -8134,13 +8200,13 @@
       </p:sp>
       <p:cxnSp>
         <p:nvCxnSpPr>
-          <p:cNvPr id="15406" name="Connector 15405"/>
+          <p:cNvPr id="15407" name="Connector 15406"/>
           <p:cNvCxnSpPr/>
           <p:nvPr/>
         </p:nvCxnSpPr>
         <p:spPr>
           <a:xfrm>
-            <a:off x="2880360" y="5888736"/>
+            <a:off x="2880360" y="5925312"/>
             <a:ext cx="457200" cy="0"/>
           </a:xfrm>
           <a:prstGeom prst="line">
@@ -8170,13 +8236,13 @@
       </p:cxnSp>
       <p:sp>
         <p:nvSpPr>
-          <p:cNvPr id="15407" name="Rounded Rectangle 15406"/>
+          <p:cNvPr id="15408" name="Rounded Rectangle 15407"/>
           <p:cNvSpPr/>
           <p:nvPr/>
         </p:nvSpPr>
         <p:spPr>
           <a:xfrm>
-            <a:off x="3383280" y="5614416"/>
+            <a:off x="3383280" y="5650992"/>
             <a:ext cx="2606040" cy="548640"/>
           </a:xfrm>
           <a:prstGeom prst="roundRect">
@@ -8229,20 +8295,20 @@
                 </a:solidFill>
                 <a:latin typeface="Arial"/>
               </a:rPr>
-              <a:t>Signed QR (checks offline) + consent for more</a:t>
-            </a:r>
-          </a:p>
-        </p:txBody>
-      </p:sp>
-      <p:sp>
-        <p:nvSpPr>
-          <p:cNvPr id="15408" name="Rounded Rectangle 15407"/>
+              <a:t>Signed QR, checked even offline; consent for more</a:t>
+            </a:r>
+          </a:p>
+        </p:txBody>
+      </p:sp>
+      <p:sp>
+        <p:nvSpPr>
+          <p:cNvPr id="15409" name="Rounded Rectangle 15408"/>
           <p:cNvSpPr/>
           <p:nvPr/>
         </p:nvSpPr>
         <p:spPr>
           <a:xfrm>
-            <a:off x="6217920" y="3200400"/>
+            <a:off x="6217920" y="3328416"/>
             <a:ext cx="5650992" cy="310896"/>
           </a:xfrm>
           <a:prstGeom prst="roundRect">
@@ -8300,18 +8366,18 @@
       </p:sp>
       <p:sp>
         <p:nvSpPr>
-          <p:cNvPr id="15409" name="Rounded Rectangle 15408"/>
+          <p:cNvPr id="15410" name="Rounded Rectangle 15409"/>
           <p:cNvSpPr/>
           <p:nvPr/>
         </p:nvSpPr>
         <p:spPr>
           <a:xfrm>
-            <a:off x="6217920" y="3639312"/>
-            <a:ext cx="1810512" cy="1243584"/>
+            <a:off x="6217920" y="3730752"/>
+            <a:ext cx="1810512" cy="1207008"/>
           </a:xfrm>
           <a:prstGeom prst="roundRect">
             <a:avLst>
-              <a:gd name="adj" fmla="val 8823"/>
+              <a:gd name="adj" fmla="val 9090"/>
             </a:avLst>
           </a:prstGeom>
           <a:solidFill>
@@ -8346,14 +8412,14 @@
       </p:sp>
       <p:sp>
         <p:nvSpPr>
-          <p:cNvPr id="15410" name="Oval 15409"/>
+          <p:cNvPr id="15411" name="Oval 15410"/>
           <p:cNvSpPr/>
           <p:nvPr/>
         </p:nvSpPr>
         <p:spPr>
           <a:xfrm>
-            <a:off x="6876288" y="3730752"/>
-            <a:ext cx="493776" cy="493776"/>
+            <a:off x="6894576" y="3803904"/>
+            <a:ext cx="457200" cy="457200"/>
           </a:xfrm>
           <a:prstGeom prst="ellipse">
             <a:avLst/>
@@ -8388,7 +8454,7 @@
       </p:sp>
       <p:pic>
         <p:nvPicPr>
-          <p:cNvPr id="15411" name="Picture 15410" descr="LuUsers2_white.png"/>
+          <p:cNvPr id="15412" name="Picture 15411" descr="LuUsers2_white.png"/>
           <p:cNvPicPr>
             <a:picLocks noChangeAspect="1"/>
           </p:cNvPicPr>
@@ -8402,47 +8468,14 @@
         </p:blipFill>
         <p:spPr>
           <a:xfrm>
-            <a:off x="6984918" y="3839382"/>
-            <a:ext cx="276514" cy="276514"/>
+            <a:off x="6995160" y="3904488"/>
+            <a:ext cx="256032" cy="256032"/>
           </a:xfrm>
           <a:prstGeom prst="rect">
             <a:avLst/>
           </a:prstGeom>
         </p:spPr>
       </p:pic>
-      <p:sp>
-        <p:nvSpPr>
-          <p:cNvPr id="15412" name="TextBox 15411"/>
-          <p:cNvSpPr txBox="1"/>
-          <p:nvPr/>
-        </p:nvSpPr>
-        <p:spPr>
-          <a:xfrm>
-            <a:off x="6263640" y="4242816"/>
-            <a:ext cx="1719072" cy="256032"/>
-          </a:xfrm>
-          <a:prstGeom prst="rect">
-            <a:avLst/>
-          </a:prstGeom>
-          <a:noFill/>
-        </p:spPr>
-        <p:txBody>
-          <a:bodyPr wrap="square" lIns="45720" rIns="45720" tIns="18288" bIns="18288" anchor="ctr"/>
-          <a:lstStyle/>
-          <a:p>
-            <a:pPr algn="ctr"/>
-            <a:r>
-              <a:rPr sz="1200" b="1" i="0">
-                <a:solidFill>
-                  <a:srgbClr val="1F3864"/>
-                </a:solidFill>
-                <a:latin typeface="Arial"/>
-              </a:rPr>
-              <a:t>Twin-safe matching</a:t>
-            </a:r>
-          </a:p>
-        </p:txBody>
-      </p:sp>
       <p:sp>
         <p:nvSpPr>
           <p:cNvPr id="15413" name="TextBox 15412"/>
@@ -8451,8 +8484,8 @@
         </p:nvSpPr>
         <p:spPr>
           <a:xfrm>
-            <a:off x="6263640" y="4489704"/>
-            <a:ext cx="1719072" cy="365760"/>
+            <a:off x="6263640" y="4279392"/>
+            <a:ext cx="1719072" cy="256032"/>
           </a:xfrm>
           <a:prstGeom prst="rect">
             <a:avLst/>
@@ -8460,12 +8493,45 @@
           <a:noFill/>
         </p:spPr>
         <p:txBody>
+          <a:bodyPr wrap="square" lIns="45720" rIns="45720" tIns="18288" bIns="18288" anchor="ctr"/>
+          <a:lstStyle/>
+          <a:p>
+            <a:pPr algn="ctr"/>
+            <a:r>
+              <a:rPr sz="1200" b="1" i="0">
+                <a:solidFill>
+                  <a:srgbClr val="1F3864"/>
+                </a:solidFill>
+                <a:latin typeface="Arial"/>
+              </a:rPr>
+              <a:t>Twin-safe matching</a:t>
+            </a:r>
+          </a:p>
+        </p:txBody>
+      </p:sp>
+      <p:sp>
+        <p:nvSpPr>
+          <p:cNvPr id="15414" name="TextBox 15413"/>
+          <p:cNvSpPr txBox="1"/>
+          <p:nvPr/>
+        </p:nvSpPr>
+        <p:spPr>
+          <a:xfrm>
+            <a:off x="6263640" y="4526280"/>
+            <a:ext cx="1719072" cy="384048"/>
+          </a:xfrm>
+          <a:prstGeom prst="rect">
+            <a:avLst/>
+          </a:prstGeom>
+          <a:noFill/>
+        </p:spPr>
+        <p:txBody>
           <a:bodyPr wrap="square" lIns="45720" rIns="45720" tIns="18288" bIns="18288" anchor="t"/>
           <a:lstStyle/>
           <a:p>
             <a:pPr algn="ctr"/>
             <a:r>
-              <a:rPr sz="1050" b="0" i="0">
+              <a:rPr sz="1100" b="0" i="0">
                 <a:solidFill>
                   <a:srgbClr val="595959"/>
                 </a:solidFill>
@@ -8479,18 +8545,18 @@
       </p:sp>
       <p:sp>
         <p:nvSpPr>
-          <p:cNvPr id="15414" name="Rounded Rectangle 15413"/>
+          <p:cNvPr id="15415" name="Rounded Rectangle 15414"/>
           <p:cNvSpPr/>
           <p:nvPr/>
         </p:nvSpPr>
         <p:spPr>
           <a:xfrm>
-            <a:off x="8138160" y="3639312"/>
-            <a:ext cx="1810512" cy="1243584"/>
+            <a:off x="8138160" y="3730752"/>
+            <a:ext cx="1810512" cy="1207008"/>
           </a:xfrm>
           <a:prstGeom prst="roundRect">
             <a:avLst>
-              <a:gd name="adj" fmla="val 8823"/>
+              <a:gd name="adj" fmla="val 9090"/>
             </a:avLst>
           </a:prstGeom>
           <a:solidFill>
@@ -8525,14 +8591,14 @@
       </p:sp>
       <p:sp>
         <p:nvSpPr>
-          <p:cNvPr id="15415" name="Oval 15414"/>
+          <p:cNvPr id="15416" name="Oval 15415"/>
           <p:cNvSpPr/>
           <p:nvPr/>
         </p:nvSpPr>
         <p:spPr>
           <a:xfrm>
-            <a:off x="8796528" y="3730752"/>
-            <a:ext cx="493776" cy="493776"/>
+            <a:off x="8814816" y="3803904"/>
+            <a:ext cx="457200" cy="457200"/>
           </a:xfrm>
           <a:prstGeom prst="ellipse">
             <a:avLst/>
@@ -8567,7 +8633,7 @@
       </p:sp>
       <p:pic>
         <p:nvPicPr>
-          <p:cNvPr id="15416" name="Picture 15415" descr="LuNetwork_white.png"/>
+          <p:cNvPr id="15417" name="Picture 15416" descr="LuNetwork_white.png"/>
           <p:cNvPicPr>
             <a:picLocks noChangeAspect="1"/>
           </p:cNvPicPr>
@@ -8581,47 +8647,14 @@
         </p:blipFill>
         <p:spPr>
           <a:xfrm>
-            <a:off x="8905158" y="3839382"/>
-            <a:ext cx="276514" cy="276514"/>
+            <a:off x="8915400" y="3904488"/>
+            <a:ext cx="256032" cy="256032"/>
           </a:xfrm>
           <a:prstGeom prst="rect">
             <a:avLst/>
           </a:prstGeom>
         </p:spPr>
       </p:pic>
-      <p:sp>
-        <p:nvSpPr>
-          <p:cNvPr id="15417" name="TextBox 15416"/>
-          <p:cNvSpPr txBox="1"/>
-          <p:nvPr/>
-        </p:nvSpPr>
-        <p:spPr>
-          <a:xfrm>
-            <a:off x="8183880" y="4242816"/>
-            <a:ext cx="1719072" cy="256032"/>
-          </a:xfrm>
-          <a:prstGeom prst="rect">
-            <a:avLst/>
-          </a:prstGeom>
-          <a:noFill/>
-        </p:spPr>
-        <p:txBody>
-          <a:bodyPr wrap="square" lIns="45720" rIns="45720" tIns="18288" bIns="18288" anchor="ctr"/>
-          <a:lstStyle/>
-          <a:p>
-            <a:pPr algn="ctr"/>
-            <a:r>
-              <a:rPr sz="1200" b="1" i="0">
-                <a:solidFill>
-                  <a:srgbClr val="1F3864"/>
-                </a:solidFill>
-                <a:latin typeface="Arial"/>
-              </a:rPr>
-              <a:t>Ghost-admission map</a:t>
-            </a:r>
-          </a:p>
-        </p:txBody>
-      </p:sp>
       <p:sp>
         <p:nvSpPr>
           <p:cNvPr id="15418" name="TextBox 15417"/>
@@ -8630,8 +8663,8 @@
         </p:nvSpPr>
         <p:spPr>
           <a:xfrm>
-            <a:off x="8183880" y="4489704"/>
-            <a:ext cx="1719072" cy="365760"/>
+            <a:off x="8183880" y="4279392"/>
+            <a:ext cx="1719072" cy="256032"/>
           </a:xfrm>
           <a:prstGeom prst="rect">
             <a:avLst/>
@@ -8639,12 +8672,45 @@
           <a:noFill/>
         </p:spPr>
         <p:txBody>
+          <a:bodyPr wrap="square" lIns="45720" rIns="45720" tIns="18288" bIns="18288" anchor="ctr"/>
+          <a:lstStyle/>
+          <a:p>
+            <a:pPr algn="ctr"/>
+            <a:r>
+              <a:rPr sz="1200" b="1" i="0">
+                <a:solidFill>
+                  <a:srgbClr val="1F3864"/>
+                </a:solidFill>
+                <a:latin typeface="Arial"/>
+              </a:rPr>
+              <a:t>Ghost-admission map</a:t>
+            </a:r>
+          </a:p>
+        </p:txBody>
+      </p:sp>
+      <p:sp>
+        <p:nvSpPr>
+          <p:cNvPr id="15419" name="TextBox 15418"/>
+          <p:cNvSpPr txBox="1"/>
+          <p:nvPr/>
+        </p:nvSpPr>
+        <p:spPr>
+          <a:xfrm>
+            <a:off x="8183880" y="4526280"/>
+            <a:ext cx="1719072" cy="384048"/>
+          </a:xfrm>
+          <a:prstGeom prst="rect">
+            <a:avLst/>
+          </a:prstGeom>
+          <a:noFill/>
+        </p:spPr>
+        <p:txBody>
           <a:bodyPr wrap="square" lIns="45720" rIns="45720" tIns="18288" bIns="18288" anchor="t"/>
           <a:lstStyle/>
           <a:p>
             <a:pPr algn="ctr"/>
             <a:r>
-              <a:rPr sz="1050" b="0" i="0">
+              <a:rPr sz="1100" b="0" i="0">
                 <a:solidFill>
                   <a:srgbClr val="595959"/>
                 </a:solidFill>
@@ -8658,18 +8724,18 @@
       </p:sp>
       <p:sp>
         <p:nvSpPr>
-          <p:cNvPr id="15419" name="Rounded Rectangle 15418"/>
+          <p:cNvPr id="15420" name="Rounded Rectangle 15419"/>
           <p:cNvSpPr/>
           <p:nvPr/>
         </p:nvSpPr>
         <p:spPr>
           <a:xfrm>
-            <a:off x="10058400" y="3639312"/>
-            <a:ext cx="1810512" cy="1243584"/>
+            <a:off x="10058400" y="3730752"/>
+            <a:ext cx="1810512" cy="1207008"/>
           </a:xfrm>
           <a:prstGeom prst="roundRect">
             <a:avLst>
-              <a:gd name="adj" fmla="val 8823"/>
+              <a:gd name="adj" fmla="val 9090"/>
             </a:avLst>
           </a:prstGeom>
           <a:solidFill>
@@ -8704,14 +8770,14 @@
       </p:sp>
       <p:sp>
         <p:nvSpPr>
-          <p:cNvPr id="15420" name="Oval 15419"/>
+          <p:cNvPr id="15421" name="Oval 15420"/>
           <p:cNvSpPr/>
           <p:nvPr/>
         </p:nvSpPr>
         <p:spPr>
           <a:xfrm>
-            <a:off x="10716768" y="3730752"/>
-            <a:ext cx="493776" cy="493776"/>
+            <a:off x="10735056" y="3803904"/>
+            <a:ext cx="457200" cy="457200"/>
           </a:xfrm>
           <a:prstGeom prst="ellipse">
             <a:avLst/>
@@ -8746,7 +8812,7 @@
       </p:sp>
       <p:pic>
         <p:nvPicPr>
-          <p:cNvPr id="15421" name="Picture 15420" descr="LuHistory_white.png"/>
+          <p:cNvPr id="15422" name="Picture 15421" descr="LuHistory_white.png"/>
           <p:cNvPicPr>
             <a:picLocks noChangeAspect="1"/>
           </p:cNvPicPr>
@@ -8760,47 +8826,14 @@
         </p:blipFill>
         <p:spPr>
           <a:xfrm>
-            <a:off x="10825398" y="3839382"/>
-            <a:ext cx="276514" cy="276514"/>
+            <a:off x="10835640" y="3904488"/>
+            <a:ext cx="256032" cy="256032"/>
           </a:xfrm>
           <a:prstGeom prst="rect">
             <a:avLst/>
           </a:prstGeom>
         </p:spPr>
       </p:pic>
-      <p:sp>
-        <p:nvSpPr>
-          <p:cNvPr id="15422" name="TextBox 15421"/>
-          <p:cNvSpPr txBox="1"/>
-          <p:nvPr/>
-        </p:nvSpPr>
-        <p:spPr>
-          <a:xfrm>
-            <a:off x="10104120" y="4242816"/>
-            <a:ext cx="1719072" cy="256032"/>
-          </a:xfrm>
-          <a:prstGeom prst="rect">
-            <a:avLst/>
-          </a:prstGeom>
-          <a:noFill/>
-        </p:spPr>
-        <p:txBody>
-          <a:bodyPr wrap="square" lIns="45720" rIns="45720" tIns="18288" bIns="18288" anchor="ctr"/>
-          <a:lstStyle/>
-          <a:p>
-            <a:pPr algn="ctr"/>
-            <a:r>
-              <a:rPr sz="1200" b="1" i="0">
-                <a:solidFill>
-                  <a:srgbClr val="1F3864"/>
-                </a:solidFill>
-                <a:latin typeface="Arial"/>
-              </a:rPr>
-              <a:t>Decisions kept</a:t>
-            </a:r>
-          </a:p>
-        </p:txBody>
-      </p:sp>
       <p:sp>
         <p:nvSpPr>
           <p:cNvPr id="15423" name="TextBox 15422"/>
@@ -8809,8 +8842,8 @@
         </p:nvSpPr>
         <p:spPr>
           <a:xfrm>
-            <a:off x="10104120" y="4489704"/>
-            <a:ext cx="1719072" cy="365760"/>
+            <a:off x="10104120" y="4279392"/>
+            <a:ext cx="1719072" cy="256032"/>
           </a:xfrm>
           <a:prstGeom prst="rect">
             <a:avLst/>
@@ -8818,12 +8851,45 @@
           <a:noFill/>
         </p:spPr>
         <p:txBody>
+          <a:bodyPr wrap="square" lIns="45720" rIns="45720" tIns="18288" bIns="18288" anchor="ctr"/>
+          <a:lstStyle/>
+          <a:p>
+            <a:pPr algn="ctr"/>
+            <a:r>
+              <a:rPr sz="1200" b="1" i="0">
+                <a:solidFill>
+                  <a:srgbClr val="1F3864"/>
+                </a:solidFill>
+                <a:latin typeface="Arial"/>
+              </a:rPr>
+              <a:t>Decisions kept</a:t>
+            </a:r>
+          </a:p>
+        </p:txBody>
+      </p:sp>
+      <p:sp>
+        <p:nvSpPr>
+          <p:cNvPr id="15424" name="TextBox 15423"/>
+          <p:cNvSpPr txBox="1"/>
+          <p:nvPr/>
+        </p:nvSpPr>
+        <p:spPr>
+          <a:xfrm>
+            <a:off x="10104120" y="4526280"/>
+            <a:ext cx="1719072" cy="384048"/>
+          </a:xfrm>
+          <a:prstGeom prst="rect">
+            <a:avLst/>
+          </a:prstGeom>
+          <a:noFill/>
+        </p:spPr>
+        <p:txBody>
           <a:bodyPr wrap="square" lIns="45720" rIns="45720" tIns="18288" bIns="18288" anchor="t"/>
           <a:lstStyle/>
           <a:p>
             <a:pPr algn="ctr"/>
             <a:r>
-              <a:rPr sz="1050" b="0" i="0">
+              <a:rPr sz="1100" b="0" i="0">
                 <a:solidFill>
                   <a:srgbClr val="595959"/>
                 </a:solidFill>
@@ -8837,18 +8903,18 @@
       </p:sp>
       <p:sp>
         <p:nvSpPr>
-          <p:cNvPr id="15424" name="Rounded Rectangle 15423"/>
+          <p:cNvPr id="15425" name="Rounded Rectangle 15424"/>
           <p:cNvSpPr/>
           <p:nvPr/>
         </p:nvSpPr>
         <p:spPr>
           <a:xfrm>
-            <a:off x="6217920" y="4992624"/>
-            <a:ext cx="1810512" cy="1243584"/>
+            <a:off x="6217920" y="5029200"/>
+            <a:ext cx="1810512" cy="1207008"/>
           </a:xfrm>
           <a:prstGeom prst="roundRect">
             <a:avLst>
-              <a:gd name="adj" fmla="val 8823"/>
+              <a:gd name="adj" fmla="val 9090"/>
             </a:avLst>
           </a:prstGeom>
           <a:solidFill>
@@ -8883,14 +8949,14 @@
       </p:sp>
       <p:sp>
         <p:nvSpPr>
-          <p:cNvPr id="15425" name="Oval 15424"/>
+          <p:cNvPr id="15426" name="Oval 15425"/>
           <p:cNvSpPr/>
           <p:nvPr/>
         </p:nvSpPr>
         <p:spPr>
           <a:xfrm>
-            <a:off x="6876288" y="5084064"/>
-            <a:ext cx="493776" cy="493776"/>
+            <a:off x="6894576" y="5102352"/>
+            <a:ext cx="457200" cy="457200"/>
           </a:xfrm>
           <a:prstGeom prst="ellipse">
             <a:avLst/>
@@ -8925,7 +8991,7 @@
       </p:sp>
       <p:pic>
         <p:nvPicPr>
-          <p:cNvPr id="15426" name="Picture 15425" descr="LuStamp_white.png"/>
+          <p:cNvPr id="15427" name="Picture 15426" descr="LuStamp_white.png"/>
           <p:cNvPicPr>
             <a:picLocks noChangeAspect="1"/>
           </p:cNvPicPr>
@@ -8939,47 +9005,14 @@
         </p:blipFill>
         <p:spPr>
           <a:xfrm>
-            <a:off x="6984918" y="5192694"/>
-            <a:ext cx="276514" cy="276514"/>
+            <a:off x="6995160" y="5202936"/>
+            <a:ext cx="256032" cy="256032"/>
           </a:xfrm>
           <a:prstGeom prst="rect">
             <a:avLst/>
           </a:prstGeom>
         </p:spPr>
       </p:pic>
-      <p:sp>
-        <p:nvSpPr>
-          <p:cNvPr id="15427" name="TextBox 15426"/>
-          <p:cNvSpPr txBox="1"/>
-          <p:nvPr/>
-        </p:nvSpPr>
-        <p:spPr>
-          <a:xfrm>
-            <a:off x="6263640" y="5596128"/>
-            <a:ext cx="1719072" cy="256032"/>
-          </a:xfrm>
-          <a:prstGeom prst="rect">
-            <a:avLst/>
-          </a:prstGeom>
-          <a:noFill/>
-        </p:spPr>
-        <p:txBody>
-          <a:bodyPr wrap="square" lIns="45720" rIns="45720" tIns="18288" bIns="18288" anchor="ctr"/>
-          <a:lstStyle/>
-          <a:p>
-            <a:pPr algn="ctr"/>
-            <a:r>
-              <a:rPr sz="1200" b="1" i="0">
-                <a:solidFill>
-                  <a:srgbClr val="1F3864"/>
-                </a:solidFill>
-                <a:latin typeface="Arial"/>
-              </a:rPr>
-              <a:t>Signed checkpoints</a:t>
-            </a:r>
-          </a:p>
-        </p:txBody>
-      </p:sp>
       <p:sp>
         <p:nvSpPr>
           <p:cNvPr id="15428" name="TextBox 15427"/>
@@ -8988,8 +9021,8 @@
         </p:nvSpPr>
         <p:spPr>
           <a:xfrm>
-            <a:off x="6263640" y="5843016"/>
-            <a:ext cx="1719072" cy="365760"/>
+            <a:off x="6263640" y="5577840"/>
+            <a:ext cx="1719072" cy="256032"/>
           </a:xfrm>
           <a:prstGeom prst="rect">
             <a:avLst/>
@@ -8997,12 +9030,45 @@
           <a:noFill/>
         </p:spPr>
         <p:txBody>
+          <a:bodyPr wrap="square" lIns="45720" rIns="45720" tIns="18288" bIns="18288" anchor="ctr"/>
+          <a:lstStyle/>
+          <a:p>
+            <a:pPr algn="ctr"/>
+            <a:r>
+              <a:rPr sz="1200" b="1" i="0">
+                <a:solidFill>
+                  <a:srgbClr val="1F3864"/>
+                </a:solidFill>
+                <a:latin typeface="Arial"/>
+              </a:rPr>
+              <a:t>Signed checkpoints</a:t>
+            </a:r>
+          </a:p>
+        </p:txBody>
+      </p:sp>
+      <p:sp>
+        <p:nvSpPr>
+          <p:cNvPr id="15429" name="TextBox 15428"/>
+          <p:cNvSpPr txBox="1"/>
+          <p:nvPr/>
+        </p:nvSpPr>
+        <p:spPr>
+          <a:xfrm>
+            <a:off x="6263640" y="5824728"/>
+            <a:ext cx="1719072" cy="384048"/>
+          </a:xfrm>
+          <a:prstGeom prst="rect">
+            <a:avLst/>
+          </a:prstGeom>
+          <a:noFill/>
+        </p:spPr>
+        <p:txBody>
           <a:bodyPr wrap="square" lIns="45720" rIns="45720" tIns="18288" bIns="18288" anchor="t"/>
           <a:lstStyle/>
           <a:p>
             <a:pPr algn="ctr"/>
             <a:r>
-              <a:rPr sz="1050" b="0" i="0">
+              <a:rPr sz="1100" b="0" i="0">
                 <a:solidFill>
                   <a:srgbClr val="595959"/>
                 </a:solidFill>
@@ -9016,18 +9082,18 @@
       </p:sp>
       <p:sp>
         <p:nvSpPr>
-          <p:cNvPr id="15429" name="Rounded Rectangle 15428"/>
+          <p:cNvPr id="15430" name="Rounded Rectangle 15429"/>
           <p:cNvSpPr/>
           <p:nvPr/>
         </p:nvSpPr>
         <p:spPr>
           <a:xfrm>
-            <a:off x="8138160" y="4992624"/>
-            <a:ext cx="1810512" cy="1243584"/>
+            <a:off x="8138160" y="5029200"/>
+            <a:ext cx="1810512" cy="1207008"/>
           </a:xfrm>
           <a:prstGeom prst="roundRect">
             <a:avLst>
-              <a:gd name="adj" fmla="val 8823"/>
+              <a:gd name="adj" fmla="val 9090"/>
             </a:avLst>
           </a:prstGeom>
           <a:solidFill>
@@ -9062,14 +9128,14 @@
       </p:sp>
       <p:sp>
         <p:nvSpPr>
-          <p:cNvPr id="15430" name="Oval 15429"/>
+          <p:cNvPr id="15431" name="Oval 15430"/>
           <p:cNvSpPr/>
           <p:nvPr/>
         </p:nvSpPr>
         <p:spPr>
           <a:xfrm>
-            <a:off x="8796528" y="5084064"/>
-            <a:ext cx="493776" cy="493776"/>
+            <a:off x="8814816" y="5102352"/>
+            <a:ext cx="457200" cy="457200"/>
           </a:xfrm>
           <a:prstGeom prst="ellipse">
             <a:avLst/>
@@ -9104,7 +9170,7 @@
       </p:sp>
       <p:pic>
         <p:nvPicPr>
-          <p:cNvPr id="15431" name="Picture 15430" descr="LuScale_white.png"/>
+          <p:cNvPr id="15432" name="Picture 15431" descr="LuScale_white.png"/>
           <p:cNvPicPr>
             <a:picLocks noChangeAspect="1"/>
           </p:cNvPicPr>
@@ -9118,47 +9184,14 @@
         </p:blipFill>
         <p:spPr>
           <a:xfrm>
-            <a:off x="8905158" y="5192694"/>
-            <a:ext cx="276514" cy="276514"/>
+            <a:off x="8915400" y="5202936"/>
+            <a:ext cx="256032" cy="256032"/>
           </a:xfrm>
           <a:prstGeom prst="rect">
             <a:avLst/>
           </a:prstGeom>
         </p:spPr>
       </p:pic>
-      <p:sp>
-        <p:nvSpPr>
-          <p:cNvPr id="15432" name="TextBox 15431"/>
-          <p:cNvSpPr txBox="1"/>
-          <p:nvPr/>
-        </p:nvSpPr>
-        <p:spPr>
-          <a:xfrm>
-            <a:off x="8183880" y="5596128"/>
-            <a:ext cx="1719072" cy="256032"/>
-          </a:xfrm>
-          <a:prstGeom prst="rect">
-            <a:avLst/>
-          </a:prstGeom>
-          <a:noFill/>
-        </p:spPr>
-        <p:txBody>
-          <a:bodyPr wrap="square" lIns="45720" rIns="45720" tIns="18288" bIns="18288" anchor="ctr"/>
-          <a:lstStyle/>
-          <a:p>
-            <a:pPr algn="ctr"/>
-            <a:r>
-              <a:rPr sz="1200" b="1" i="0">
-                <a:solidFill>
-                  <a:srgbClr val="1F3864"/>
-                </a:solidFill>
-                <a:latin typeface="Arial"/>
-              </a:rPr>
-              <a:t>Rules as data</a:t>
-            </a:r>
-          </a:p>
-        </p:txBody>
-      </p:sp>
       <p:sp>
         <p:nvSpPr>
           <p:cNvPr id="15433" name="TextBox 15432"/>
@@ -9167,8 +9200,8 @@
         </p:nvSpPr>
         <p:spPr>
           <a:xfrm>
-            <a:off x="8183880" y="5843016"/>
-            <a:ext cx="1719072" cy="365760"/>
+            <a:off x="8183880" y="5577840"/>
+            <a:ext cx="1719072" cy="256032"/>
           </a:xfrm>
           <a:prstGeom prst="rect">
             <a:avLst/>
@@ -9176,37 +9209,70 @@
           <a:noFill/>
         </p:spPr>
         <p:txBody>
+          <a:bodyPr wrap="square" lIns="45720" rIns="45720" tIns="18288" bIns="18288" anchor="ctr"/>
+          <a:lstStyle/>
+          <a:p>
+            <a:pPr algn="ctr"/>
+            <a:r>
+              <a:rPr sz="1200" b="1" i="0">
+                <a:solidFill>
+                  <a:srgbClr val="1F3864"/>
+                </a:solidFill>
+                <a:latin typeface="Arial"/>
+              </a:rPr>
+              <a:t>Rules as data</a:t>
+            </a:r>
+          </a:p>
+        </p:txBody>
+      </p:sp>
+      <p:sp>
+        <p:nvSpPr>
+          <p:cNvPr id="15434" name="TextBox 15433"/>
+          <p:cNvSpPr txBox="1"/>
+          <p:nvPr/>
+        </p:nvSpPr>
+        <p:spPr>
+          <a:xfrm>
+            <a:off x="8183880" y="5824728"/>
+            <a:ext cx="1719072" cy="384048"/>
+          </a:xfrm>
+          <a:prstGeom prst="rect">
+            <a:avLst/>
+          </a:prstGeom>
+          <a:noFill/>
+        </p:spPr>
+        <p:txBody>
           <a:bodyPr wrap="square" lIns="45720" rIns="45720" tIns="18288" bIns="18288" anchor="t"/>
           <a:lstStyle/>
           <a:p>
             <a:pPr algn="ctr"/>
             <a:r>
-              <a:rPr sz="1050" b="0" i="0">
+              <a:rPr sz="1100" b="0" i="0">
                 <a:solidFill>
                   <a:srgbClr val="595959"/>
                 </a:solidFill>
                 <a:latin typeface="Arial"/>
               </a:rPr>
-              <a:t>2026-27 caps by level,
-each with its source</a:t>
-            </a:r>
-          </a:p>
-        </p:txBody>
-      </p:sp>
-      <p:sp>
-        <p:nvSpPr>
-          <p:cNvPr id="15434" name="Rounded Rectangle 15433"/>
+              <a:t>each value sourced;
+unconfirmed: warn only</a:t>
+            </a:r>
+          </a:p>
+        </p:txBody>
+      </p:sp>
+      <p:sp>
+        <p:nvSpPr>
+          <p:cNvPr id="15435" name="Rounded Rectangle 15434"/>
           <p:cNvSpPr/>
           <p:nvPr/>
         </p:nvSpPr>
         <p:spPr>
           <a:xfrm>
-            <a:off x="10058400" y="4992624"/>
-            <a:ext cx="1810512" cy="1243584"/>
+            <a:off x="10058400" y="5029200"/>
+            <a:ext cx="1810512" cy="1207008"/>
           </a:xfrm>
           <a:prstGeom prst="roundRect">
             <a:avLst>
-              <a:gd name="adj" fmla="val 8823"/>
+              <a:gd name="adj" fmla="val 9090"/>
             </a:avLst>
           </a:prstGeom>
           <a:solidFill>
@@ -9241,14 +9307,14 @@
       </p:sp>
       <p:sp>
         <p:nvSpPr>
-          <p:cNvPr id="15435" name="Oval 15434"/>
+          <p:cNvPr id="15436" name="Oval 15435"/>
           <p:cNvSpPr/>
           <p:nvPr/>
         </p:nvSpPr>
         <p:spPr>
           <a:xfrm>
-            <a:off x="10716768" y="5084064"/>
-            <a:ext cx="493776" cy="493776"/>
+            <a:off x="10735056" y="5102352"/>
+            <a:ext cx="457200" cy="457200"/>
           </a:xfrm>
           <a:prstGeom prst="ellipse">
             <a:avLst/>
@@ -9283,7 +9349,7 @@
       </p:sp>
       <p:pic>
         <p:nvPicPr>
-          <p:cNvPr id="15436" name="Picture 15435" descr="LuGraduationCap_white.png"/>
+          <p:cNvPr id="15437" name="Picture 15436" descr="LuGraduationCap_white.png"/>
           <p:cNvPicPr>
             <a:picLocks noChangeAspect="1"/>
           </p:cNvPicPr>
@@ -9297,47 +9363,14 @@
         </p:blipFill>
         <p:spPr>
           <a:xfrm>
-            <a:off x="10825398" y="5192694"/>
-            <a:ext cx="276514" cy="276514"/>
+            <a:off x="10835640" y="5202936"/>
+            <a:ext cx="256032" cy="256032"/>
           </a:xfrm>
           <a:prstGeom prst="rect">
             <a:avLst/>
           </a:prstGeom>
         </p:spPr>
       </p:pic>
-      <p:sp>
-        <p:nvSpPr>
-          <p:cNvPr id="15437" name="TextBox 15436"/>
-          <p:cNvSpPr txBox="1"/>
-          <p:nvPr/>
-        </p:nvSpPr>
-        <p:spPr>
-          <a:xfrm>
-            <a:off x="10104120" y="5596128"/>
-            <a:ext cx="1719072" cy="256032"/>
-          </a:xfrm>
-          <a:prstGeom prst="rect">
-            <a:avLst/>
-          </a:prstGeom>
-          <a:noFill/>
-        </p:spPr>
-        <p:txBody>
-          <a:bodyPr wrap="square" lIns="45720" rIns="45720" tIns="18288" bIns="18288" anchor="ctr"/>
-          <a:lstStyle/>
-          <a:p>
-            <a:pPr algn="ctr"/>
-            <a:r>
-              <a:rPr sz="1200" b="1" i="0">
-                <a:solidFill>
-                  <a:srgbClr val="1F3864"/>
-                </a:solidFill>
-                <a:latin typeface="Arial"/>
-              </a:rPr>
-              <a:t>APAAR on degrees</a:t>
-            </a:r>
-          </a:p>
-        </p:txBody>
-      </p:sp>
       <p:sp>
         <p:nvSpPr>
           <p:cNvPr id="15438" name="TextBox 15437"/>
@@ -9346,8 +9379,8 @@
         </p:nvSpPr>
         <p:spPr>
           <a:xfrm>
-            <a:off x="10104120" y="5843016"/>
-            <a:ext cx="1719072" cy="365760"/>
+            <a:off x="10104120" y="5577840"/>
+            <a:ext cx="1719072" cy="256032"/>
           </a:xfrm>
           <a:prstGeom prst="rect">
             <a:avLst/>
@@ -9355,12 +9388,45 @@
           <a:noFill/>
         </p:spPr>
         <p:txBody>
+          <a:bodyPr wrap="square" lIns="45720" rIns="45720" tIns="18288" bIns="18288" anchor="ctr"/>
+          <a:lstStyle/>
+          <a:p>
+            <a:pPr algn="ctr"/>
+            <a:r>
+              <a:rPr sz="1200" b="1" i="0">
+                <a:solidFill>
+                  <a:srgbClr val="1F3864"/>
+                </a:solidFill>
+                <a:latin typeface="Arial"/>
+              </a:rPr>
+              <a:t>APAAR on degrees</a:t>
+            </a:r>
+          </a:p>
+        </p:txBody>
+      </p:sp>
+      <p:sp>
+        <p:nvSpPr>
+          <p:cNvPr id="15439" name="TextBox 15438"/>
+          <p:cNvSpPr txBox="1"/>
+          <p:nvPr/>
+        </p:nvSpPr>
+        <p:spPr>
+          <a:xfrm>
+            <a:off x="10104120" y="5824728"/>
+            <a:ext cx="1719072" cy="384048"/>
+          </a:xfrm>
+          <a:prstGeom prst="rect">
+            <a:avLst/>
+          </a:prstGeom>
+          <a:noFill/>
+        </p:spPr>
+        <p:txBody>
           <a:bodyPr wrap="square" lIns="45720" rIns="45720" tIns="18288" bIns="18288" anchor="t"/>
           <a:lstStyle/>
           <a:p>
             <a:pPr algn="ctr"/>
             <a:r>
-              <a:rPr sz="1050" b="0" i="0">
+              <a:rPr sz="1100" b="0" i="0">
                 <a:solidFill>
                   <a:srgbClr val="595959"/>
                 </a:solidFill>
@@ -10767,7 +10833,7 @@
                 </a:solidFill>
                 <a:latin typeface="Arial"/>
               </a:rPr>
-              <a:t>signed QR + audit</a:t>
+              <a:t>did:web · AES-GCM</a:t>
             </a:r>
           </a:p>
         </p:txBody>
@@ -11968,12 +12034,12 @@
         </p:nvSpPr>
         <p:spPr>
           <a:xfrm>
-            <a:off x="6601968" y="2825496"/>
-            <a:ext cx="5266944" cy="2361304"/>
+            <a:off x="6601968" y="2788920"/>
+            <a:ext cx="5266944" cy="1687601"/>
           </a:xfrm>
           <a:prstGeom prst="roundRect">
             <a:avLst>
-              <a:gd name="adj" fmla="val 1548"/>
+              <a:gd name="adj" fmla="val 2167"/>
             </a:avLst>
           </a:prstGeom>
           <a:solidFill>
@@ -12016,15 +12082,15 @@
         </p:nvPicPr>
         <p:blipFill>
           <a:blip r:embed="rId10"/>
-          <a:srcRect l="17800" t="5800" b="36000"/>
+          <a:srcRect l="17800" t="5800" b="53000"/>
           <a:stretch>
             <a:fillRect/>
           </a:stretch>
         </p:blipFill>
         <p:spPr>
           <a:xfrm>
-            <a:off x="6629400" y="2852928"/>
-            <a:ext cx="5212080" cy="2306440"/>
+            <a:off x="6629400" y="2816352"/>
+            <a:ext cx="5212080" cy="1632737"/>
           </a:xfrm>
           <a:prstGeom prst="rect">
             <a:avLst/>
@@ -12039,7 +12105,7 @@
         </p:nvSpPr>
         <p:spPr>
           <a:xfrm>
-            <a:off x="6629400" y="5214232"/>
+            <a:off x="6629400" y="4494809"/>
             <a:ext cx="5212080" cy="237744"/>
           </a:xfrm>
           <a:prstGeom prst="rect">
@@ -12072,12 +12138,184 @@
         </p:nvSpPr>
         <p:spPr>
           <a:xfrm>
-            <a:off x="6601968" y="5506840"/>
-            <a:ext cx="5266944" cy="756799"/>
+            <a:off x="6601968" y="4778273"/>
+            <a:ext cx="5266944" cy="822960"/>
           </a:xfrm>
           <a:prstGeom prst="roundRect">
             <a:avLst>
-              <a:gd name="adj" fmla="val 14498"/>
+              <a:gd name="adj" fmla="val 13333"/>
+            </a:avLst>
+          </a:prstGeom>
+          <a:solidFill>
+            <a:srgbClr val="FFFFFF"/>
+          </a:solidFill>
+          <a:ln w="9525">
+            <a:solidFill>
+              <a:srgbClr val="C9D3E3"/>
+            </a:solidFill>
+          </a:ln>
+          <a:effectLst/>
+        </p:spPr>
+        <p:style>
+          <a:lnRef idx="1">
+            <a:schemeClr val="accent1"/>
+          </a:lnRef>
+          <a:fillRef idx="3">
+            <a:schemeClr val="accent1"/>
+          </a:fillRef>
+          <a:effectRef idx="2">
+            <a:schemeClr val="accent1"/>
+          </a:effectRef>
+          <a:fontRef idx="minor">
+            <a:schemeClr val="lt1"/>
+          </a:fontRef>
+        </p:style>
+        <p:txBody>
+          <a:bodyPr rtlCol="0" anchor="ctr"/>
+          <a:lstStyle/>
+          <a:p/>
+        </p:txBody>
+      </p:sp>
+      <p:sp>
+        <p:nvSpPr>
+          <p:cNvPr id="17470" name="TextBox 17469"/>
+          <p:cNvSpPr txBox="1"/>
+          <p:nvPr/>
+        </p:nvSpPr>
+        <p:spPr>
+          <a:xfrm>
+            <a:off x="6675120" y="4814849"/>
+            <a:ext cx="5138928" cy="256032"/>
+          </a:xfrm>
+          <a:prstGeom prst="rect">
+            <a:avLst/>
+          </a:prstGeom>
+          <a:noFill/>
+        </p:spPr>
+        <p:txBody>
+          <a:bodyPr wrap="square" lIns="45720" rIns="45720" tIns="18288" bIns="18288" anchor="ctr"/>
+          <a:lstStyle/>
+          <a:p>
+            <a:pPr algn="l"/>
+            <a:r>
+              <a:rPr sz="1050" b="1" i="0">
+                <a:solidFill>
+                  <a:srgbClr val="1E7B3E"/>
+                </a:solidFill>
+                <a:latin typeface="Arial"/>
+              </a:rPr>
+              <a:t>Built: </a:t>
+            </a:r>
+            <a:r>
+              <a:rPr sz="1050" b="0" i="0">
+                <a:solidFill>
+                  <a:srgbClr val="1A1A1A"/>
+                </a:solidFill>
+                <a:latin typeface="Arial"/>
+              </a:rPr>
+              <a:t>upload, 31 rules, scan, risk score, consent, signed QR, audit</a:t>
+            </a:r>
+          </a:p>
+        </p:txBody>
+      </p:sp>
+      <p:sp>
+        <p:nvSpPr>
+          <p:cNvPr id="17471" name="TextBox 17470"/>
+          <p:cNvSpPr txBox="1"/>
+          <p:nvPr/>
+        </p:nvSpPr>
+        <p:spPr>
+          <a:xfrm>
+            <a:off x="6675120" y="5070881"/>
+            <a:ext cx="5138928" cy="256032"/>
+          </a:xfrm>
+          <a:prstGeom prst="rect">
+            <a:avLst/>
+          </a:prstGeom>
+          <a:noFill/>
+        </p:spPr>
+        <p:txBody>
+          <a:bodyPr wrap="square" lIns="45720" rIns="45720" tIns="18288" bIns="18288" anchor="ctr"/>
+          <a:lstStyle/>
+          <a:p>
+            <a:pPr algn="l"/>
+            <a:r>
+              <a:rPr sz="1050" b="1" i="0">
+                <a:solidFill>
+                  <a:srgbClr val="E46C0A"/>
+                </a:solidFill>
+                <a:latin typeface="Arial"/>
+              </a:rPr>
+              <a:t>Simulated (no public API yet): </a:t>
+            </a:r>
+            <a:r>
+              <a:rPr sz="1050" b="0" i="0">
+                <a:solidFill>
+                  <a:srgbClr val="1A1A1A"/>
+                </a:solidFill>
+                <a:latin typeface="Arial"/>
+              </a:rPr>
+              <a:t>APAAR lookup, DigiLocker, portal sign-in</a:t>
+            </a:r>
+          </a:p>
+        </p:txBody>
+      </p:sp>
+      <p:sp>
+        <p:nvSpPr>
+          <p:cNvPr id="17472" name="TextBox 17471"/>
+          <p:cNvSpPr txBox="1"/>
+          <p:nvPr/>
+        </p:nvSpPr>
+        <p:spPr>
+          <a:xfrm>
+            <a:off x="6675120" y="5326913"/>
+            <a:ext cx="5138928" cy="256032"/>
+          </a:xfrm>
+          <a:prstGeom prst="rect">
+            <a:avLst/>
+          </a:prstGeom>
+          <a:noFill/>
+        </p:spPr>
+        <p:txBody>
+          <a:bodyPr wrap="square" lIns="45720" rIns="45720" tIns="18288" bIns="18288" anchor="ctr"/>
+          <a:lstStyle/>
+          <a:p>
+            <a:pPr algn="l"/>
+            <a:r>
+              <a:rPr sz="1050" b="1" i="0">
+                <a:solidFill>
+                  <a:srgbClr val="0070C0"/>
+                </a:solidFill>
+                <a:latin typeface="Arial"/>
+              </a:rPr>
+              <a:t>Planned: </a:t>
+            </a:r>
+            <a:r>
+              <a:rPr sz="1050" b="0" i="0">
+                <a:solidFill>
+                  <a:srgbClr val="1A1A1A"/>
+                </a:solidFill>
+                <a:latin typeface="Arial"/>
+              </a:rPr>
+              <a:t>API Setu / DigiLocker partner access, govt SSO, STQC audit</a:t>
+            </a:r>
+          </a:p>
+        </p:txBody>
+      </p:sp>
+      <p:sp>
+        <p:nvSpPr>
+          <p:cNvPr id="17473" name="Rounded Rectangle 17472"/>
+          <p:cNvSpPr/>
+          <p:nvPr/>
+        </p:nvSpPr>
+        <p:spPr>
+          <a:xfrm>
+            <a:off x="6601968" y="5674385"/>
+            <a:ext cx="5266944" cy="589254"/>
+          </a:xfrm>
+          <a:prstGeom prst="roundRect">
+            <a:avLst>
+              <a:gd name="adj" fmla="val 18621"/>
             </a:avLst>
           </a:prstGeom>
           <a:solidFill>
@@ -12112,7 +12350,7 @@
       </p:sp>
       <p:pic>
         <p:nvPicPr>
-          <p:cNvPr id="17470" name="Picture 17469" descr="qr_live.png"/>
+          <p:cNvPr id="17474" name="Picture 17473" descr="qr_live.png"/>
           <p:cNvPicPr>
             <a:picLocks noChangeAspect="1"/>
           </p:cNvPicPr>
@@ -12126,8 +12364,8 @@
         </p:blipFill>
         <p:spPr>
           <a:xfrm>
-            <a:off x="6693408" y="5570848"/>
-            <a:ext cx="628783" cy="628783"/>
+            <a:off x="6693408" y="5729249"/>
+            <a:ext cx="479526" cy="479526"/>
           </a:xfrm>
           <a:prstGeom prst="rect">
             <a:avLst/>
@@ -12136,14 +12374,14 @@
       </p:pic>
       <p:sp>
         <p:nvSpPr>
-          <p:cNvPr id="17471" name="TextBox 17470"/>
+          <p:cNvPr id="17475" name="TextBox 17474"/>
           <p:cNvSpPr txBox="1"/>
           <p:nvPr/>
         </p:nvSpPr>
         <p:spPr>
           <a:xfrm>
-            <a:off x="7431919" y="5552560"/>
-            <a:ext cx="4206240" cy="665359"/>
+            <a:off x="7282662" y="5701817"/>
+            <a:ext cx="4389120" cy="534390"/>
           </a:xfrm>
           <a:prstGeom prst="rect">
             <a:avLst/>
@@ -12177,13 +12415,13 @@
           <a:p>
             <a:pPr algn="l"/>
             <a:r>
-              <a:rPr sz="1100" b="0" i="0">
+              <a:rPr sz="1050" b="0" i="0">
                 <a:solidFill>
                   <a:srgbClr val="595959"/>
                 </a:solidFill>
                 <a:latin typeface="Arial"/>
               </a:rPr>
-              <a:t>7 demo roles · synthetic data · installable on phones</a:t>
+              <a:t>7 demo roles · synthetic data · first load can take a minute (free server)</a:t>
             </a:r>
           </a:p>
         </p:txBody>
@@ -12931,13 +13169,13 @@
           <a:p>
             <a:pPr algn="l"/>
             <a:r>
-              <a:rPr sz="2100" b="1" i="0">
+              <a:rPr sz="1800" b="1" i="0">
                 <a:solidFill>
                   <a:srgbClr val="1F3864"/>
                 </a:solidFill>
                 <a:latin typeface="Arial"/>
               </a:rPr>
-              <a:t>0 / 80</a:t>
+              <a:t>0/80 · 2/12</a:t>
             </a:r>
           </a:p>
         </p:txBody>
@@ -12970,8 +13208,8 @@
                 </a:solidFill>
                 <a:latin typeface="Arial"/>
               </a:rPr>
-              <a:t>same-day twins
-wrongly merged</a:t>
+              <a:t>twins flagged: seeded ·
+held-out (sent for review)</a:t>
             </a:r>
           </a:p>
         </p:txBody>
@@ -13508,7 +13746,7 @@
                 <a:latin typeface="Arial"/>
               </a:rPr>
               <a:t>top-ranked colleges
-truly anomalous</a:t>
+were planted anomalies</a:t>
             </a:r>
           </a:p>
         </p:txBody>
@@ -13653,7 +13891,7 @@
                 </a:solidFill>
                 <a:latin typeface="Arial"/>
               </a:rPr>
-              <a:t>59 tests</a:t>
+              <a:t>65 tests</a:t>
             </a:r>
           </a:p>
         </p:txBody>
@@ -13686,187 +13924,26 @@
                 </a:solidFill>
                 <a:latin typeface="Arial"/>
               </a:rPr>
-              <a:t>SQLite + PostgreSQL 16;
-7-role browser walkthrough</a:t>
-            </a:r>
-          </a:p>
-        </p:txBody>
-      </p:sp>
-      <p:sp>
-        <p:nvSpPr>
-          <p:cNvPr id="17441" name="TextBox 17440"/>
-          <p:cNvSpPr txBox="1"/>
-          <p:nvPr/>
-        </p:nvSpPr>
-        <p:spPr>
-          <a:xfrm>
-            <a:off x="320040" y="2615184"/>
-            <a:ext cx="11548872" cy="274320"/>
-          </a:xfrm>
-          <a:prstGeom prst="rect">
-            <a:avLst/>
-          </a:prstGeom>
-          <a:noFill/>
-        </p:spPr>
-        <p:txBody>
-          <a:bodyPr wrap="square" lIns="45720" rIns="45720" tIns="18288" bIns="18288" anchor="ctr"/>
-          <a:lstStyle/>
-          <a:p>
-            <a:pPr algn="ctr"/>
-            <a:r>
-              <a:rPr sz="1050" b="0" i="0">
-                <a:solidFill>
-                  <a:srgbClr val="595959"/>
-                </a:solidFill>
-                <a:latin typeface="Arial"/>
-              </a:rPr>
-              <a:t>Planted cases are regression checks on synthetic data, not real-world accuracy · precision / recall come from independent hand-labelled name pairs</a:t>
-            </a:r>
-          </a:p>
-        </p:txBody>
-      </p:sp>
-      <p:sp>
-        <p:nvSpPr>
-          <p:cNvPr id="17442" name="Rounded Rectangle 17441"/>
+              <a:t>93% coverage; security
+and WCAG checks in CI</a:t>
+            </a:r>
+          </a:p>
+        </p:txBody>
+      </p:sp>
+      <p:sp>
+        <p:nvSpPr>
+          <p:cNvPr id="17441" name="Rounded Rectangle 17440"/>
           <p:cNvSpPr/>
           <p:nvPr/>
         </p:nvSpPr>
         <p:spPr>
           <a:xfrm>
-            <a:off x="320040" y="3035808"/>
-            <a:ext cx="5486400" cy="310896"/>
+            <a:off x="320040" y="2624328"/>
+            <a:ext cx="11548872" cy="292608"/>
           </a:xfrm>
           <a:prstGeom prst="roundRect">
             <a:avLst>
-              <a:gd name="adj" fmla="val 23529"/>
-            </a:avLst>
-          </a:prstGeom>
-          <a:solidFill>
-            <a:srgbClr val="1F3864"/>
-          </a:solidFill>
-          <a:ln>
-            <a:noFill/>
-          </a:ln>
-          <a:effectLst/>
-        </p:spPr>
-        <p:style>
-          <a:lnRef idx="1">
-            <a:schemeClr val="accent1"/>
-          </a:lnRef>
-          <a:fillRef idx="3">
-            <a:schemeClr val="accent1"/>
-          </a:fillRef>
-          <a:effectRef idx="2">
-            <a:schemeClr val="accent1"/>
-          </a:effectRef>
-          <a:fontRef idx="minor">
-            <a:schemeClr val="lt1"/>
-          </a:fontRef>
-        </p:style>
-        <p:txBody>
-          <a:bodyPr rtlCol="0" anchor="ctr" wrap="square" lIns="45720" rIns="45720" tIns="18288" bIns="18288"/>
-          <a:lstStyle/>
-          <a:p>
-            <a:pPr algn="l"/>
-            <a:r>
-              <a:rPr sz="1200" b="1" i="0">
-                <a:solidFill>
-                  <a:srgbClr val="E46C0A"/>
-                </a:solidFill>
-                <a:latin typeface="Arial"/>
-              </a:rPr>
-              <a:t>❖ </a:t>
-            </a:r>
-            <a:r>
-              <a:rPr sz="1200" b="1" i="0">
-                <a:solidFill>
-                  <a:srgbClr val="FFFFFF"/>
-                </a:solidFill>
-                <a:latin typeface="Arial"/>
-              </a:rPr>
-              <a:t>Potential challenges and risks</a:t>
-            </a:r>
-          </a:p>
-        </p:txBody>
-      </p:sp>
-      <p:sp>
-        <p:nvSpPr>
-          <p:cNvPr id="17443" name="Rounded Rectangle 17442"/>
-          <p:cNvSpPr/>
-          <p:nvPr/>
-        </p:nvSpPr>
-        <p:spPr>
-          <a:xfrm>
-            <a:off x="6382512" y="3035808"/>
-            <a:ext cx="5486400" cy="310896"/>
-          </a:xfrm>
-          <a:prstGeom prst="roundRect">
-            <a:avLst>
-              <a:gd name="adj" fmla="val 23529"/>
-            </a:avLst>
-          </a:prstGeom>
-          <a:solidFill>
-            <a:srgbClr val="1F3864"/>
-          </a:solidFill>
-          <a:ln>
-            <a:noFill/>
-          </a:ln>
-          <a:effectLst/>
-        </p:spPr>
-        <p:style>
-          <a:lnRef idx="1">
-            <a:schemeClr val="accent1"/>
-          </a:lnRef>
-          <a:fillRef idx="3">
-            <a:schemeClr val="accent1"/>
-          </a:fillRef>
-          <a:effectRef idx="2">
-            <a:schemeClr val="accent1"/>
-          </a:effectRef>
-          <a:fontRef idx="minor">
-            <a:schemeClr val="lt1"/>
-          </a:fontRef>
-        </p:style>
-        <p:txBody>
-          <a:bodyPr rtlCol="0" anchor="ctr" wrap="square" lIns="45720" rIns="45720" tIns="18288" bIns="18288"/>
-          <a:lstStyle/>
-          <a:p>
-            <a:pPr algn="l"/>
-            <a:r>
-              <a:rPr sz="1200" b="1" i="0">
-                <a:solidFill>
-                  <a:srgbClr val="E46C0A"/>
-                </a:solidFill>
-                <a:latin typeface="Arial"/>
-              </a:rPr>
-              <a:t>❖ </a:t>
-            </a:r>
-            <a:r>
-              <a:rPr sz="1200" b="1" i="0">
-                <a:solidFill>
-                  <a:srgbClr val="FFFFFF"/>
-                </a:solidFill>
-                <a:latin typeface="Arial"/>
-              </a:rPr>
-              <a:t>Strategies for overcoming these challenges</a:t>
-            </a:r>
-          </a:p>
-        </p:txBody>
-      </p:sp>
-      <p:sp>
-        <p:nvSpPr>
-          <p:cNvPr id="17444" name="Rounded Rectangle 17443"/>
-          <p:cNvSpPr/>
-          <p:nvPr/>
-        </p:nvSpPr>
-        <p:spPr>
-          <a:xfrm>
-            <a:off x="320040" y="3419856"/>
-            <a:ext cx="5486400" cy="374904"/>
-          </a:xfrm>
-          <a:prstGeom prst="roundRect">
-            <a:avLst>
-              <a:gd name="adj" fmla="val 29268"/>
+              <a:gd name="adj" fmla="val 18750"/>
             </a:avLst>
           </a:prstGeom>
           <a:solidFill>
@@ -13894,6 +13971,200 @@
           </a:fontRef>
         </p:style>
         <p:txBody>
+          <a:bodyPr rtlCol="0" anchor="ctr" wrap="square" lIns="45720" rIns="45720" tIns="18288" bIns="18288"/>
+          <a:lstStyle/>
+          <a:p>
+            <a:pPr algn="ctr"/>
+            <a:r>
+              <a:rPr sz="1100" b="1" i="0">
+                <a:solidFill>
+                  <a:srgbClr val="B42B2B"/>
+                </a:solidFill>
+                <a:latin typeface="Arial"/>
+              </a:rPr>
+              <a:t>All synthetic data: </a:t>
+            </a:r>
+            <a:r>
+              <a:rPr sz="1100" b="0" i="0">
+                <a:solidFill>
+                  <a:srgbClr val="1A1A1A"/>
+                </a:solidFill>
+                <a:latin typeface="Arial"/>
+              </a:rPr>
+              <a:t>regression checks, not real-world accuracy, which the pilot will measure. A flag never acts on its own: an officer decides, with a recorded reason.</a:t>
+            </a:r>
+          </a:p>
+        </p:txBody>
+      </p:sp>
+      <p:sp>
+        <p:nvSpPr>
+          <p:cNvPr id="17442" name="Rounded Rectangle 17441"/>
+          <p:cNvSpPr/>
+          <p:nvPr/>
+        </p:nvSpPr>
+        <p:spPr>
+          <a:xfrm>
+            <a:off x="320040" y="3035808"/>
+            <a:ext cx="5486400" cy="310896"/>
+          </a:xfrm>
+          <a:prstGeom prst="roundRect">
+            <a:avLst>
+              <a:gd name="adj" fmla="val 23529"/>
+            </a:avLst>
+          </a:prstGeom>
+          <a:solidFill>
+            <a:srgbClr val="1F3864"/>
+          </a:solidFill>
+          <a:ln>
+            <a:noFill/>
+          </a:ln>
+          <a:effectLst/>
+        </p:spPr>
+        <p:style>
+          <a:lnRef idx="1">
+            <a:schemeClr val="accent1"/>
+          </a:lnRef>
+          <a:fillRef idx="3">
+            <a:schemeClr val="accent1"/>
+          </a:fillRef>
+          <a:effectRef idx="2">
+            <a:schemeClr val="accent1"/>
+          </a:effectRef>
+          <a:fontRef idx="minor">
+            <a:schemeClr val="lt1"/>
+          </a:fontRef>
+        </p:style>
+        <p:txBody>
+          <a:bodyPr rtlCol="0" anchor="ctr" wrap="square" lIns="45720" rIns="45720" tIns="18288" bIns="18288"/>
+          <a:lstStyle/>
+          <a:p>
+            <a:pPr algn="l"/>
+            <a:r>
+              <a:rPr sz="1200" b="1" i="0">
+                <a:solidFill>
+                  <a:srgbClr val="E46C0A"/>
+                </a:solidFill>
+                <a:latin typeface="Arial"/>
+              </a:rPr>
+              <a:t>❖ </a:t>
+            </a:r>
+            <a:r>
+              <a:rPr sz="1200" b="1" i="0">
+                <a:solidFill>
+                  <a:srgbClr val="FFFFFF"/>
+                </a:solidFill>
+                <a:latin typeface="Arial"/>
+              </a:rPr>
+              <a:t>Potential challenges and risks</a:t>
+            </a:r>
+          </a:p>
+        </p:txBody>
+      </p:sp>
+      <p:sp>
+        <p:nvSpPr>
+          <p:cNvPr id="17443" name="Rounded Rectangle 17442"/>
+          <p:cNvSpPr/>
+          <p:nvPr/>
+        </p:nvSpPr>
+        <p:spPr>
+          <a:xfrm>
+            <a:off x="6382512" y="3035808"/>
+            <a:ext cx="5486400" cy="310896"/>
+          </a:xfrm>
+          <a:prstGeom prst="roundRect">
+            <a:avLst>
+              <a:gd name="adj" fmla="val 23529"/>
+            </a:avLst>
+          </a:prstGeom>
+          <a:solidFill>
+            <a:srgbClr val="1F3864"/>
+          </a:solidFill>
+          <a:ln>
+            <a:noFill/>
+          </a:ln>
+          <a:effectLst/>
+        </p:spPr>
+        <p:style>
+          <a:lnRef idx="1">
+            <a:schemeClr val="accent1"/>
+          </a:lnRef>
+          <a:fillRef idx="3">
+            <a:schemeClr val="accent1"/>
+          </a:fillRef>
+          <a:effectRef idx="2">
+            <a:schemeClr val="accent1"/>
+          </a:effectRef>
+          <a:fontRef idx="minor">
+            <a:schemeClr val="lt1"/>
+          </a:fontRef>
+        </p:style>
+        <p:txBody>
+          <a:bodyPr rtlCol="0" anchor="ctr" wrap="square" lIns="45720" rIns="45720" tIns="18288" bIns="18288"/>
+          <a:lstStyle/>
+          <a:p>
+            <a:pPr algn="l"/>
+            <a:r>
+              <a:rPr sz="1200" b="1" i="0">
+                <a:solidFill>
+                  <a:srgbClr val="E46C0A"/>
+                </a:solidFill>
+                <a:latin typeface="Arial"/>
+              </a:rPr>
+              <a:t>❖ </a:t>
+            </a:r>
+            <a:r>
+              <a:rPr sz="1200" b="1" i="0">
+                <a:solidFill>
+                  <a:srgbClr val="FFFFFF"/>
+                </a:solidFill>
+                <a:latin typeface="Arial"/>
+              </a:rPr>
+              <a:t>Strategies for overcoming these challenges</a:t>
+            </a:r>
+          </a:p>
+        </p:txBody>
+      </p:sp>
+      <p:sp>
+        <p:nvSpPr>
+          <p:cNvPr id="17444" name="Rounded Rectangle 17443"/>
+          <p:cNvSpPr/>
+          <p:nvPr/>
+        </p:nvSpPr>
+        <p:spPr>
+          <a:xfrm>
+            <a:off x="320040" y="3419856"/>
+            <a:ext cx="5486400" cy="374904"/>
+          </a:xfrm>
+          <a:prstGeom prst="roundRect">
+            <a:avLst>
+              <a:gd name="adj" fmla="val 29268"/>
+            </a:avLst>
+          </a:prstGeom>
+          <a:solidFill>
+            <a:srgbClr val="FCECEA"/>
+          </a:solidFill>
+          <a:ln w="9525">
+            <a:solidFill>
+              <a:srgbClr val="F0C4C0"/>
+            </a:solidFill>
+          </a:ln>
+          <a:effectLst/>
+        </p:spPr>
+        <p:style>
+          <a:lnRef idx="1">
+            <a:schemeClr val="accent1"/>
+          </a:lnRef>
+          <a:fillRef idx="3">
+            <a:schemeClr val="accent1"/>
+          </a:fillRef>
+          <a:effectRef idx="2">
+            <a:schemeClr val="accent1"/>
+          </a:effectRef>
+          <a:fontRef idx="minor">
+            <a:schemeClr val="lt1"/>
+          </a:fontRef>
+        </p:style>
+        <p:txBody>
           <a:bodyPr rtlCol="0" anchor="ctr"/>
           <a:lstStyle/>
           <a:p/>
@@ -14655,7 +14926,7 @@
                 </a:solidFill>
                 <a:latin typeface="Arial"/>
               </a:rPr>
-              <a:t>Consent per field, masked IDs, no Aadhaar stored, access log</a:t>
+              <a:t>Consent per field, contacts encrypted at rest, no Aadhaar stored</a:t>
             </a:r>
           </a:p>
         </p:txBody>
@@ -14800,7 +15071,7 @@
                 </a:solidFill>
                 <a:latin typeface="Arial"/>
               </a:rPr>
-              <a:t>Wrong flags: twins, spelling variants</a:t>
+              <a:t>Wrong flags: twins, spelling variants, bad data</a:t>
             </a:r>
           </a:p>
         </p:txBody>
@@ -14924,7 +15195,7 @@
                 </a:solidFill>
                 <a:latin typeface="Arial"/>
               </a:rPr>
-              <a:t>Twin-safe matcher; officer decides with a reason; decision remembered</a:t>
+              <a:t>Rejected rows never reach risk scores; reasons shown; officer decides</a:t>
             </a:r>
           </a:p>
         </p:txBody>
@@ -15069,7 +15340,7 @@
                 </a:solidFill>
                 <a:latin typeface="Arial"/>
               </a:rPr>
-              <a:t>Rules change every year by circular</a:t>
+              <a:t>Rules change; some values not yet confirmed</a:t>
             </a:r>
           </a:p>
         </p:txBody>
@@ -15193,7 +15464,7 @@
                 </a:solidFill>
                 <a:latin typeface="Arial"/>
               </a:rPr>
-              <a:t>Rules file per academic year, each value with its source</a:t>
+              <a:t>Rules file per year; unconfirmed values warn, never reject</a:t>
             </a:r>
           </a:p>
         </p:txBody>
@@ -15535,7 +15806,7 @@
           <a:p>
             <a:pPr algn="l"/>
             <a:r>
-              <a:rPr sz="1000" b="1" i="0">
+              <a:rPr sz="1050" b="1" i="0">
                 <a:solidFill>
                   <a:srgbClr val="E46C0A"/>
                 </a:solidFill>
@@ -15544,16 +15815,16 @@
               <a:t>Roadmap  </a:t>
             </a:r>
             <a:r>
-              <a:rPr sz="1000" b="0" i="0">
+              <a:rPr sz="1050" b="0" i="0">
                 <a:solidFill>
                   <a:srgbClr val="1A1A1A"/>
                 </a:solidFill>
                 <a:latin typeface="Arial"/>
               </a:rPr>
-              <a:t>M1–3 pilot: 1 state, 50 colleges → M4–6 API Setu, SSO, STQC audit → M7–12 national   </a:t>
-            </a:r>
-            <a:r>
-              <a:rPr sz="1000" b="1" i="0">
+              <a:t>M1–3 pilot, 1 state, 50 colleges: measure hours saved and false flags → M4–6 API Setu, SSO, STQC → M7–12 national   </a:t>
+            </a:r>
+            <a:r>
+              <a:rPr sz="1050" b="1" i="0">
                 <a:solidFill>
                   <a:srgbClr val="E46C0A"/>
                 </a:solidFill>
@@ -15562,13 +15833,13 @@
               <a:t>Cost  </a:t>
             </a:r>
             <a:r>
-              <a:rPr sz="1000" b="0" i="0">
+              <a:rPr sz="1050" b="0" i="0">
                 <a:solidFill>
                   <a:srgbClr val="1A1A1A"/>
                 </a:solidFill>
                 <a:latin typeface="Arial"/>
               </a:rPr>
-              <a:t>open-source stack, no licence fees; the whole prototype runs on one free 512 MB instance</a:t>
+              <a:t>no licence fees</a:t>
             </a:r>
           </a:p>
         </p:txBody>
@@ -16997,8 +17268,8 @@
                 </a:solidFill>
                 <a:latin typeface="Arial"/>
               </a:rPr>
-              <a:t>instant QR check, even
-offline; consent for more</a:t>
+              <a:t>QR check on a phone;
+consent for more</a:t>
             </a:r>
           </a:p>
         </p:txBody>
@@ -17269,8 +17540,8 @@
         </p:nvSpPr>
         <p:spPr>
           <a:xfrm>
-            <a:off x="393192" y="4736592"/>
-            <a:ext cx="1865376" cy="1426464"/>
+            <a:off x="393192" y="4718304"/>
+            <a:ext cx="1865376" cy="1444752"/>
           </a:xfrm>
           <a:prstGeom prst="rect">
             <a:avLst/>
@@ -17287,7 +17558,7 @@
               </a:spcAft>
             </a:pPr>
             <a:r>
-              <a:rPr sz="950" b="1" i="0">
+              <a:rPr sz="1000" b="1" i="0">
                 <a:solidFill>
                   <a:srgbClr val="B42B2B"/>
                 </a:solidFill>
@@ -17296,13 +17567,13 @@
               <a:t>✖ </a:t>
             </a:r>
             <a:r>
-              <a:rPr sz="950" b="0" i="0">
+              <a:rPr sz="1000" b="0" i="0">
                 <a:solidFill>
                   <a:srgbClr val="1A1A1A"/>
                 </a:solidFill>
                 <a:latin typeface="Arial"/>
               </a:rPr>
-              <a:t>42 excess seats found late: ₹23.1 cr fine (FORE v AICTE, SC 2019)</a:t>
+              <a:t>₹23.1 cr fine = 42 excess seats × ₹11 lakh fee × 5 (FORE v AICTE, SC 2019)</a:t>
             </a:r>
           </a:p>
           <a:p>
@@ -17312,7 +17583,7 @@
               </a:spcAft>
             </a:pPr>
             <a:r>
-              <a:rPr sz="950" b="1" i="0">
+              <a:rPr sz="1000" b="1" i="0">
                 <a:solidFill>
                   <a:srgbClr val="B42B2B"/>
                 </a:solidFill>
@@ -17321,13 +17592,13 @@
               <a:t>✖ </a:t>
             </a:r>
             <a:r>
-              <a:rPr sz="950" b="0" i="0">
+              <a:rPr sz="1000" b="0" i="0">
                 <a:solidFill>
                   <a:srgbClr val="1A1A1A"/>
                 </a:solidFill>
                 <a:latin typeface="Arial"/>
               </a:rPr>
-              <a:t>AISHE 2022-23 report published only in 2026</a:t>
+              <a:t>AISHE 2022-23 data published in 2026</a:t>
             </a:r>
           </a:p>
           <a:p>
@@ -17337,7 +17608,7 @@
               </a:spcAft>
             </a:pPr>
             <a:r>
-              <a:rPr sz="950" b="1" i="0">
+              <a:rPr sz="1000" b="1" i="0">
                 <a:solidFill>
                   <a:srgbClr val="B42B2B"/>
                 </a:solidFill>
@@ -17346,7 +17617,7 @@
               <a:t>✖ </a:t>
             </a:r>
             <a:r>
-              <a:rPr sz="950" b="0" i="0">
+              <a:rPr sz="1000" b="0" i="0">
                 <a:solidFill>
                   <a:srgbClr val="1A1A1A"/>
                 </a:solidFill>
@@ -17444,8 +17715,8 @@
         </p:nvSpPr>
         <p:spPr>
           <a:xfrm>
-            <a:off x="4389120" y="4736592"/>
-            <a:ext cx="1892807" cy="1426464"/>
+            <a:off x="4389120" y="4718304"/>
+            <a:ext cx="1892807" cy="1444752"/>
           </a:xfrm>
           <a:prstGeom prst="rect">
             <a:avLst/>
@@ -17462,7 +17733,7 @@
               </a:spcAft>
             </a:pPr>
             <a:r>
-              <a:rPr sz="950" b="1" i="0">
+              <a:rPr sz="1000" b="1" i="0">
                 <a:solidFill>
                   <a:srgbClr val="1E7B3E"/>
                 </a:solidFill>
@@ -17471,13 +17742,13 @@
               <a:t>✔ </a:t>
             </a:r>
             <a:r>
-              <a:rPr sz="950" b="0" i="0">
+              <a:rPr sz="1000" b="0" i="0">
                 <a:solidFill>
                   <a:srgbClr val="1A1A1A"/>
                 </a:solidFill>
                 <a:latin typeface="Arial"/>
               </a:rPr>
-              <a:t>Seat #61 of 60 stopped the day it is uploaded, before any fine</a:t>
+              <a:t>Seat #61 of 60 refused at upload, the same day</a:t>
             </a:r>
           </a:p>
           <a:p>
@@ -17487,7 +17758,7 @@
               </a:spcAft>
             </a:pPr>
             <a:r>
-              <a:rPr sz="950" b="1" i="0">
+              <a:rPr sz="1000" b="1" i="0">
                 <a:solidFill>
                   <a:srgbClr val="1E7B3E"/>
                 </a:solidFill>
@@ -17496,13 +17767,13 @@
               <a:t>✔ </a:t>
             </a:r>
             <a:r>
-              <a:rPr sz="950" b="0" i="0">
+              <a:rPr sz="1000" b="0" i="0">
                 <a:solidFill>
                   <a:srgbClr val="1A1A1A"/>
                 </a:solidFill>
                 <a:latin typeface="Arial"/>
               </a:rPr>
-              <a:t>Same-day national view; duplicates flagged within minutes</a:t>
+              <a:t>National view refreshed after each submission</a:t>
             </a:r>
           </a:p>
           <a:p>
@@ -17512,7 +17783,7 @@
               </a:spcAft>
             </a:pPr>
             <a:r>
-              <a:rPr sz="950" b="1" i="0">
+              <a:rPr sz="1000" b="1" i="0">
                 <a:solidFill>
                   <a:srgbClr val="1E7B3E"/>
                 </a:solidFill>
@@ -17521,13 +17792,13 @@
               <a:t>✔ </a:t>
             </a:r>
             <a:r>
-              <a:rPr sz="950" b="0" i="0">
+              <a:rPr sz="1000" b="0" i="0">
                 <a:solidFill>
                   <a:srgbClr val="1A1A1A"/>
                 </a:solidFill>
                 <a:latin typeface="Arial"/>
               </a:rPr>
-              <a:t>Mismatches returned with the reason, fixed by re-upload</a:t>
+              <a:t>Mismatch returned with its reason; fixed by re-upload</a:t>
             </a:r>
           </a:p>
         </p:txBody>
@@ -17604,12 +17875,12 @@
         </p:nvSpPr>
         <p:spPr>
           <a:xfrm>
-            <a:off x="6583680" y="1508760"/>
-            <a:ext cx="2587752" cy="1261872"/>
+            <a:off x="6583680" y="1481328"/>
+            <a:ext cx="2587752" cy="1188720"/>
           </a:xfrm>
           <a:prstGeom prst="roundRect">
             <a:avLst>
-              <a:gd name="adj" fmla="val 8695"/>
+              <a:gd name="adj" fmla="val 9230"/>
             </a:avLst>
           </a:prstGeom>
           <a:solidFill>
@@ -17650,7 +17921,7 @@
         </p:nvSpPr>
         <p:spPr>
           <a:xfrm>
-            <a:off x="6693408" y="1618488"/>
+            <a:off x="6693408" y="1572768"/>
             <a:ext cx="457200" cy="457200"/>
           </a:xfrm>
           <a:prstGeom prst="ellipse">
@@ -17700,7 +17971,7 @@
         </p:blipFill>
         <p:spPr>
           <a:xfrm>
-            <a:off x="6793992" y="1719072"/>
+            <a:off x="6793992" y="1673352"/>
             <a:ext cx="256032" cy="256032"/>
           </a:xfrm>
           <a:prstGeom prst="rect">
@@ -17716,7 +17987,7 @@
         </p:nvSpPr>
         <p:spPr>
           <a:xfrm>
-            <a:off x="7242048" y="1618488"/>
+            <a:off x="7242048" y="1572768"/>
             <a:ext cx="1856232" cy="457200"/>
           </a:xfrm>
           <a:prstGeom prst="rect">
@@ -17749,8 +18020,8 @@
         </p:nvSpPr>
         <p:spPr>
           <a:xfrm>
-            <a:off x="6693408" y="2148839"/>
-            <a:ext cx="2404872" cy="566928"/>
+            <a:off x="6693408" y="2084832"/>
+            <a:ext cx="2404872" cy="548640"/>
           </a:xfrm>
           <a:prstGeom prst="rect">
             <a:avLst/>
@@ -17783,12 +18054,12 @@
         </p:nvSpPr>
         <p:spPr>
           <a:xfrm>
-            <a:off x="9281160" y="1508760"/>
-            <a:ext cx="2587752" cy="1261872"/>
+            <a:off x="9281160" y="1481328"/>
+            <a:ext cx="2587752" cy="1188720"/>
           </a:xfrm>
           <a:prstGeom prst="roundRect">
             <a:avLst>
-              <a:gd name="adj" fmla="val 8695"/>
+              <a:gd name="adj" fmla="val 9230"/>
             </a:avLst>
           </a:prstGeom>
           <a:solidFill>
@@ -17829,7 +18100,7 @@
         </p:nvSpPr>
         <p:spPr>
           <a:xfrm>
-            <a:off x="9390888" y="1618488"/>
+            <a:off x="9390888" y="1572768"/>
             <a:ext cx="457200" cy="457200"/>
           </a:xfrm>
           <a:prstGeom prst="ellipse">
@@ -17879,7 +18150,7 @@
         </p:blipFill>
         <p:spPr>
           <a:xfrm>
-            <a:off x="9491472" y="1719072"/>
+            <a:off x="9491472" y="1673352"/>
             <a:ext cx="256032" cy="256032"/>
           </a:xfrm>
           <a:prstGeom prst="rect">
@@ -17895,7 +18166,7 @@
         </p:nvSpPr>
         <p:spPr>
           <a:xfrm>
-            <a:off x="9939528" y="1618488"/>
+            <a:off x="9939528" y="1572768"/>
             <a:ext cx="1856232" cy="457200"/>
           </a:xfrm>
           <a:prstGeom prst="rect">
@@ -17928,8 +18199,8 @@
         </p:nvSpPr>
         <p:spPr>
           <a:xfrm>
-            <a:off x="9390888" y="2148839"/>
-            <a:ext cx="2404872" cy="566928"/>
+            <a:off x="9390888" y="2084832"/>
+            <a:ext cx="2404872" cy="548640"/>
           </a:xfrm>
           <a:prstGeom prst="rect">
             <a:avLst/>
@@ -17948,8 +18219,8 @@
                 </a:solidFill>
                 <a:latin typeface="Arial"/>
               </a:rPr>
-              <a:t>MIT / BSD / Apache stack: no
-licence fees; one upload, all users</a:t>
+              <a:t>no licence fees; one upload
+serves AICTE and university</a:t>
             </a:r>
           </a:p>
         </p:txBody>
@@ -17962,12 +18233,12 @@
         </p:nvSpPr>
         <p:spPr>
           <a:xfrm>
-            <a:off x="6583680" y="2862072"/>
-            <a:ext cx="2587752" cy="1261872"/>
+            <a:off x="6583680" y="2743200"/>
+            <a:ext cx="2587752" cy="1188720"/>
           </a:xfrm>
           <a:prstGeom prst="roundRect">
             <a:avLst>
-              <a:gd name="adj" fmla="val 8695"/>
+              <a:gd name="adj" fmla="val 9230"/>
             </a:avLst>
           </a:prstGeom>
           <a:solidFill>
@@ -18008,7 +18279,7 @@
         </p:nvSpPr>
         <p:spPr>
           <a:xfrm>
-            <a:off x="6693408" y="2971800"/>
+            <a:off x="6693408" y="2834640"/>
             <a:ext cx="457200" cy="457200"/>
           </a:xfrm>
           <a:prstGeom prst="ellipse">
@@ -18058,7 +18329,7 @@
         </p:blipFill>
         <p:spPr>
           <a:xfrm>
-            <a:off x="6793992" y="3072384"/>
+            <a:off x="6793992" y="2935224"/>
             <a:ext cx="256032" cy="256032"/>
           </a:xfrm>
           <a:prstGeom prst="rect">
@@ -18074,7 +18345,7 @@
         </p:nvSpPr>
         <p:spPr>
           <a:xfrm>
-            <a:off x="7242048" y="2971800"/>
+            <a:off x="7242048" y="2834640"/>
             <a:ext cx="1856232" cy="457200"/>
           </a:xfrm>
           <a:prstGeom prst="rect">
@@ -18107,8 +18378,8 @@
         </p:nvSpPr>
         <p:spPr>
           <a:xfrm>
-            <a:off x="6693408" y="3502152"/>
-            <a:ext cx="2404872" cy="566928"/>
+            <a:off x="6693408" y="3346704"/>
+            <a:ext cx="2404872" cy="548640"/>
           </a:xfrm>
           <a:prstGeom prst="rect">
             <a:avLst/>
@@ -18127,8 +18398,8 @@
                 </a:solidFill>
                 <a:latin typeface="Arial"/>
               </a:rPr>
-              <a:t>paper returns and verification
-letters replaced by upload + QR</a:t>
+              <a:t>fewer paper returns and
+verification letters</a:t>
             </a:r>
           </a:p>
         </p:txBody>
@@ -18141,12 +18412,12 @@
         </p:nvSpPr>
         <p:spPr>
           <a:xfrm>
-            <a:off x="9281160" y="2862072"/>
-            <a:ext cx="2587752" cy="1261872"/>
+            <a:off x="9281160" y="2743200"/>
+            <a:ext cx="2587752" cy="1188720"/>
           </a:xfrm>
           <a:prstGeom prst="roundRect">
             <a:avLst>
-              <a:gd name="adj" fmla="val 8695"/>
+              <a:gd name="adj" fmla="val 9230"/>
             </a:avLst>
           </a:prstGeom>
           <a:solidFill>
@@ -18187,7 +18458,7 @@
         </p:nvSpPr>
         <p:spPr>
           <a:xfrm>
-            <a:off x="9390888" y="2971800"/>
+            <a:off x="9390888" y="2834640"/>
             <a:ext cx="457200" cy="457200"/>
           </a:xfrm>
           <a:prstGeom prst="ellipse">
@@ -18237,7 +18508,7 @@
         </p:blipFill>
         <p:spPr>
           <a:xfrm>
-            <a:off x="9491472" y="3072384"/>
+            <a:off x="9491472" y="2935224"/>
             <a:ext cx="256032" cy="256032"/>
           </a:xfrm>
           <a:prstGeom prst="rect">
@@ -18253,7 +18524,7 @@
         </p:nvSpPr>
         <p:spPr>
           <a:xfrm>
-            <a:off x="9939528" y="2971800"/>
+            <a:off x="9939528" y="2834640"/>
             <a:ext cx="1856232" cy="457200"/>
           </a:xfrm>
           <a:prstGeom prst="rect">
@@ -18286,8 +18557,8 @@
         </p:nvSpPr>
         <p:spPr>
           <a:xfrm>
-            <a:off x="9390888" y="3502152"/>
-            <a:ext cx="2404872" cy="566928"/>
+            <a:off x="9390888" y="3346704"/>
+            <a:ext cx="2404872" cy="548640"/>
           </a:xfrm>
           <a:prstGeom prst="rect">
             <a:avLst/>
@@ -18314,13 +18585,46 @@
       </p:sp>
       <p:sp>
         <p:nvSpPr>
-          <p:cNvPr id="17471" name="Rounded Rectangle 17470"/>
+          <p:cNvPr id="17471" name="TextBox 17470"/>
+          <p:cNvSpPr txBox="1"/>
+          <p:nvPr/>
+        </p:nvSpPr>
+        <p:spPr>
+          <a:xfrm>
+            <a:off x="6583680" y="3931920"/>
+            <a:ext cx="5285232" cy="237744"/>
+          </a:xfrm>
+          <a:prstGeom prst="rect">
+            <a:avLst/>
+          </a:prstGeom>
+          <a:noFill/>
+        </p:spPr>
+        <p:txBody>
+          <a:bodyPr wrap="square" lIns="45720" rIns="45720" tIns="18288" bIns="18288" anchor="ctr"/>
+          <a:lstStyle/>
+          <a:p>
+            <a:pPr algn="ctr"/>
+            <a:r>
+              <a:rPr sz="1050" b="0" i="0">
+                <a:solidFill>
+                  <a:srgbClr val="595959"/>
+                </a:solidFill>
+                <a:latin typeface="Arial"/>
+              </a:rPr>
+              <a:t>Expected benefits; the pilot measures hours saved and flags confirmed.</a:t>
+            </a:r>
+          </a:p>
+        </p:txBody>
+      </p:sp>
+      <p:sp>
+        <p:nvSpPr>
+          <p:cNvPr id="17472" name="Rounded Rectangle 17471"/>
           <p:cNvSpPr/>
           <p:nvPr/>
         </p:nvSpPr>
         <p:spPr>
           <a:xfrm>
-            <a:off x="6601968" y="4288536"/>
+            <a:off x="6601968" y="4306824"/>
             <a:ext cx="2340864" cy="1671227"/>
           </a:xfrm>
           <a:prstGeom prst="roundRect">
@@ -18360,7 +18664,7 @@
       </p:sp>
       <p:pic>
         <p:nvPicPr>
-          <p:cNvPr id="17472" name="Picture 17471" descr="25_certificate.png"/>
+          <p:cNvPr id="17473" name="Picture 17472" descr="25_certificate.png"/>
           <p:cNvPicPr>
             <a:picLocks noChangeAspect="1"/>
           </p:cNvPicPr>
@@ -18375,7 +18679,7 @@
         </p:blipFill>
         <p:spPr>
           <a:xfrm>
-            <a:off x="6629400" y="4315968"/>
+            <a:off x="6629400" y="4334256"/>
             <a:ext cx="2286000" cy="1616363"/>
           </a:xfrm>
           <a:prstGeom prst="rect">
@@ -18385,13 +18689,13 @@
       </p:pic>
       <p:sp>
         <p:nvSpPr>
-          <p:cNvPr id="17473" name="Rounded Rectangle 17472"/>
+          <p:cNvPr id="17474" name="Rounded Rectangle 17473"/>
           <p:cNvSpPr/>
           <p:nvPr/>
         </p:nvSpPr>
         <p:spPr>
           <a:xfrm>
-            <a:off x="9235440" y="4288536"/>
+            <a:off x="9235440" y="4306824"/>
             <a:ext cx="2633472" cy="1313949"/>
           </a:xfrm>
           <a:prstGeom prst="roundRect">
@@ -18431,7 +18735,7 @@
       </p:sp>
       <p:pic>
         <p:nvPicPr>
-          <p:cNvPr id="17474" name="Picture 17473" descr="23_public_qr_verified.png"/>
+          <p:cNvPr id="17475" name="Picture 17474" descr="23_public_qr_verified.png"/>
           <p:cNvPicPr>
             <a:picLocks noChangeAspect="1"/>
           </p:cNvPicPr>
@@ -18446,7 +18750,7 @@
         </p:blipFill>
         <p:spPr>
           <a:xfrm>
-            <a:off x="9262872" y="4315968"/>
+            <a:off x="9262872" y="4334256"/>
             <a:ext cx="2578608" cy="1259085"/>
           </a:xfrm>
           <a:prstGeom prst="rect">
@@ -18454,39 +18758,6 @@
           </a:prstGeom>
         </p:spPr>
       </p:pic>
-      <p:sp>
-        <p:nvSpPr>
-          <p:cNvPr id="17475" name="TextBox 17474"/>
-          <p:cNvSpPr txBox="1"/>
-          <p:nvPr/>
-        </p:nvSpPr>
-        <p:spPr>
-          <a:xfrm>
-            <a:off x="6583680" y="5978051"/>
-            <a:ext cx="2468880" cy="237744"/>
-          </a:xfrm>
-          <a:prstGeom prst="rect">
-            <a:avLst/>
-          </a:prstGeom>
-          <a:noFill/>
-        </p:spPr>
-        <p:txBody>
-          <a:bodyPr wrap="square" lIns="45720" rIns="45720" tIns="18288" bIns="18288" anchor="ctr"/>
-          <a:lstStyle/>
-          <a:p>
-            <a:pPr algn="ctr"/>
-            <a:r>
-              <a:rPr sz="1050" b="0" i="0">
-                <a:solidFill>
-                  <a:srgbClr val="595959"/>
-                </a:solidFill>
-                <a:latin typeface="Arial"/>
-              </a:rPr>
-              <a:t>Certificate: APAAR ID + student ID + QR</a:t>
-            </a:r>
-          </a:p>
-        </p:txBody>
-      </p:sp>
       <p:sp>
         <p:nvSpPr>
           <p:cNvPr id="17476" name="TextBox 17475"/>
@@ -18495,7 +18766,40 @@
         </p:nvSpPr>
         <p:spPr>
           <a:xfrm>
-            <a:off x="9235440" y="5620773"/>
+            <a:off x="6583680" y="5996339"/>
+            <a:ext cx="2468880" cy="237744"/>
+          </a:xfrm>
+          <a:prstGeom prst="rect">
+            <a:avLst/>
+          </a:prstGeom>
+          <a:noFill/>
+        </p:spPr>
+        <p:txBody>
+          <a:bodyPr wrap="square" lIns="45720" rIns="45720" tIns="18288" bIns="18288" anchor="ctr"/>
+          <a:lstStyle/>
+          <a:p>
+            <a:pPr algn="ctr"/>
+            <a:r>
+              <a:rPr sz="1050" b="0" i="0">
+                <a:solidFill>
+                  <a:srgbClr val="595959"/>
+                </a:solidFill>
+                <a:latin typeface="Arial"/>
+              </a:rPr>
+              <a:t>Certificate: APAAR ID + student ID + QR</a:t>
+            </a:r>
+          </a:p>
+        </p:txBody>
+      </p:sp>
+      <p:sp>
+        <p:nvSpPr>
+          <p:cNvPr id="17477" name="TextBox 17476"/>
+          <p:cNvSpPr txBox="1"/>
+          <p:nvPr/>
+        </p:nvSpPr>
+        <p:spPr>
+          <a:xfrm>
+            <a:off x="9235440" y="5639061"/>
             <a:ext cx="2633472" cy="237744"/>
           </a:xfrm>
           <a:prstGeom prst="rect">
@@ -18515,7 +18819,7 @@
                 </a:solidFill>
                 <a:latin typeface="Arial"/>
               </a:rPr>
-              <a:t>QR scan: verified, also on the device</a:t>
+              <a:t>QR: on-device check + revocation list</a:t>
             </a:r>
           </a:p>
         </p:txBody>
@@ -19375,13 +19679,13 @@
           <a:p>
             <a:pPr algn="ctr"/>
             <a:r>
-              <a:rPr sz="900" b="0" i="0">
+              <a:rPr sz="950" b="0" i="0">
                 <a:solidFill>
                   <a:srgbClr val="595959"/>
                 </a:solidFill>
                 <a:latin typeface="Arial"/>
               </a:rPr>
-              <a:t>aggregate, 2–3 yr lag</a:t>
+              <a:t>totals, 2–3 yrs late</a:t>
             </a:r>
           </a:p>
         </p:txBody>
@@ -19408,13 +19712,13 @@
           <a:p>
             <a:pPr algn="ctr"/>
             <a:r>
-              <a:rPr sz="1050" b="1" i="0">
+              <a:rPr sz="950" b="1" i="0">
                 <a:solidFill>
                   <a:srgbClr val="1E7B3E"/>
                 </a:solidFill>
                 <a:latin typeface="Arial"/>
               </a:rPr>
-              <a:t>✔ live</a:t>
+              <a:t>✔ per upload</a:t>
             </a:r>
           </a:p>
         </p:txBody>
@@ -20041,7 +20345,7 @@
           <a:p>
             <a:pPr algn="ctr"/>
             <a:r>
-              <a:rPr sz="900" b="1" i="0">
+              <a:rPr sz="950" b="1" i="0">
                 <a:solidFill>
                   <a:srgbClr val="1E7B3E"/>
                 </a:solidFill>
@@ -20153,7 +20457,7 @@
           <a:p>
             <a:pPr algn="ctr"/>
             <a:r>
-              <a:rPr sz="900" b="0" i="0">
+              <a:rPr sz="950" b="0" i="0">
                 <a:solidFill>
                   <a:srgbClr val="595959"/>
                 </a:solidFill>
@@ -20186,7 +20490,7 @@
           <a:p>
             <a:pPr algn="ctr"/>
             <a:r>
-              <a:rPr sz="900" b="0" i="0">
+              <a:rPr sz="950" b="0" i="0">
                 <a:solidFill>
                   <a:srgbClr val="595959"/>
                 </a:solidFill>
@@ -20272,7 +20576,7 @@
         <p:spPr>
           <a:xfrm>
             <a:off x="320040" y="4352544"/>
-            <a:ext cx="6400800" cy="384048"/>
+            <a:ext cx="6400800" cy="566928"/>
           </a:xfrm>
           <a:prstGeom prst="rect">
             <a:avLst/>
@@ -20285,13 +20589,22 @@
           <a:p>
             <a:pPr algn="l"/>
             <a:r>
-              <a:rPr sz="1000" b="0" i="0">
+              <a:rPr sz="1050" b="1" i="0">
+                <a:solidFill>
+                  <a:srgbClr val="1F3864"/>
+                </a:solidFill>
+                <a:latin typeface="Arial"/>
+              </a:rPr>
+              <a:t>✔ = built and covered by a test (docs/CLAIMS.md); other columns from public documentation (refs 4–5). </a:t>
+            </a:r>
+            <a:r>
+              <a:rPr sz="1050" b="0" i="0">
                 <a:solidFill>
                   <a:srgbClr val="595959"/>
                 </a:solidFill>
                 <a:latin typeface="Arial"/>
               </a:rPr>
-              <a:t>Vidya Pramaan consumes APAAR and feeds NAD / ABC and AISHE: no new ID, no parallel credential store, no invented APAAR checksum (none is published), and no student rejected for opting out.</a:t>
+              <a:t>Vidya Pramaan reuses APAAR and feeds NAD / ABC and AISHE: no new ID, no parallel credential store, no student rejected for opting out.</a:t>
             </a:r>
           </a:p>
         </p:txBody>
@@ -20561,7 +20874,7 @@
                 </a:solidFill>
                 <a:latin typeface="Arial"/>
               </a:rPr>
-              <a:t>9. W3C Verifiable Credentials; RFC 8032 (Ed25519)  </a:t>
+              <a:t>9. W3C Verifiable Credentials and did:web; RFC 8032 (Ed25519)  </a:t>
             </a:r>
             <a:r>
               <a:rPr sz="950" b="0" i="0">
@@ -20803,7 +21116,7 @@
                 </a:solidFill>
                 <a:latin typeface="Arial"/>
               </a:rPr>
-              <a:t>59 automated tests + browser walkthrough · MIT licence</a:t>
+              <a:t>65 tests · 93% coverage · MIT licence</a:t>
             </a:r>
           </a:p>
         </p:txBody>

</xml_diff>

<commit_message>
Deck: lighter slides 2, 4, 5 and 6
Shorter labels and problem/solution pairs, larger text (12 pt in the pairs,
risk rows and benefits; 11 pt minimum outside the reference list), same facts
and the same caveats.
</commit_message>
<xml_diff>
--- a/ppt/SIH26263_AI_Riders_Idea.pptx
+++ b/ppt/SIH26263_AI_Riders_Idea.pptx
@@ -7542,9 +7542,9 @@
           <a:bodyPr rtlCol="0" anchor="ctr" wrap="square" lIns="45720" rIns="45720" tIns="18288" bIns="18288"/>
           <a:lstStyle/>
           <a:p>
-            <a:pPr algn="l"/>
-            <a:r>
-              <a:rPr sz="1100" b="1" i="0">
+            <a:pPr algn="ctr"/>
+            <a:r>
+              <a:rPr sz="1200" b="1" i="0">
                 <a:solidFill>
                   <a:srgbClr val="E46C0A"/>
                 </a:solidFill>
@@ -7553,13 +7553,13 @@
               <a:t>What is new  </a:t>
             </a:r>
             <a:r>
-              <a:rPr sz="1100" b="0" i="0">
+              <a:rPr sz="1200" b="0" i="0">
                 <a:solidFill>
                   <a:srgbClr val="1A1A1A"/>
                 </a:solidFill>
                 <a:latin typeface="Arial"/>
               </a:rPr>
-              <a:t>APAAR, NAD / DigiLocker and ABC hold IDs and awards; none checks each admission against approved intake. We add that check (slide 6).</a:t>
+              <a:t>no national system checks each admission against approved intake. We add that check, on top of APAAR.</a:t>
             </a:r>
           </a:p>
         </p:txBody>
@@ -7674,7 +7674,7 @@
           <a:p>
             <a:pPr algn="l"/>
             <a:r>
-              <a:rPr sz="1100" b="1" i="0">
+              <a:rPr sz="1200" b="1" i="0">
                 <a:solidFill>
                   <a:srgbClr val="B42B2B"/>
                 </a:solidFill>
@@ -7683,13 +7683,13 @@
               <a:t>✖  </a:t>
             </a:r>
             <a:r>
-              <a:rPr sz="1100" b="0" i="0">
+              <a:rPr sz="1200" b="0" i="0">
                 <a:solidFill>
                   <a:srgbClr val="1A1A1A"/>
                 </a:solidFill>
                 <a:latin typeface="Arial"/>
               </a:rPr>
-              <a:t>Only total enrolment reaches AICTE (except PGDM), per the PS</a:t>
+              <a:t>AICTE gets only totals (PS)</a:t>
             </a:r>
           </a:p>
         </p:txBody>
@@ -7776,7 +7776,7 @@
           <a:p>
             <a:pPr algn="l"/>
             <a:r>
-              <a:rPr sz="1100" b="1" i="0">
+              <a:rPr sz="1200" b="1" i="0">
                 <a:solidFill>
                   <a:srgbClr val="1E7B3E"/>
                 </a:solidFill>
@@ -7785,13 +7785,13 @@
               <a:t>✔  </a:t>
             </a:r>
             <a:r>
-              <a:rPr sz="1100" b="0" i="0">
+              <a:rPr sz="1200" b="0" i="0">
                 <a:solidFill>
                   <a:srgbClr val="1A1A1A"/>
                 </a:solidFill>
                 <a:latin typeface="Arial"/>
               </a:rPr>
-              <a:t>Student-level records keyed on APAAR, per upload</a:t>
+              <a:t>Student-level records on APAAR</a:t>
             </a:r>
           </a:p>
         </p:txBody>
@@ -7842,7 +7842,7 @@
           <a:p>
             <a:pPr algn="l"/>
             <a:r>
-              <a:rPr sz="1100" b="1" i="0">
+              <a:rPr sz="1200" b="1" i="0">
                 <a:solidFill>
                   <a:srgbClr val="B42B2B"/>
                 </a:solidFill>
@@ -7851,13 +7851,13 @@
               <a:t>✖  </a:t>
             </a:r>
             <a:r>
-              <a:rPr sz="1100" b="0" i="0">
+              <a:rPr sz="1200" b="0" i="0">
                 <a:solidFill>
                   <a:srgbClr val="1A1A1A"/>
                 </a:solidFill>
                 <a:latin typeface="Arial"/>
               </a:rPr>
-              <a:t>Excess admission: fine of 5× the fee per student (APH)</a:t>
+              <a:t>Excess seat: 5× fee fine each (APH)</a:t>
             </a:r>
           </a:p>
         </p:txBody>
@@ -7944,7 +7944,7 @@
           <a:p>
             <a:pPr algn="l"/>
             <a:r>
-              <a:rPr sz="1100" b="1" i="0">
+              <a:rPr sz="1200" b="1" i="0">
                 <a:solidFill>
                   <a:srgbClr val="1E7B3E"/>
                 </a:solidFill>
@@ -7953,13 +7953,13 @@
               <a:t>✔  </a:t>
             </a:r>
             <a:r>
-              <a:rPr sz="1100" b="0" i="0">
+              <a:rPr sz="1200" b="0" i="0">
                 <a:solidFill>
                   <a:srgbClr val="1A1A1A"/>
                 </a:solidFill>
                 <a:latin typeface="Arial"/>
               </a:rPr>
-              <a:t>Seat #61 of 60 refused at upload and at submit</a:t>
+              <a:t>Seat #61 of 60 refused at upload</a:t>
             </a:r>
           </a:p>
         </p:txBody>
@@ -8010,7 +8010,7 @@
           <a:p>
             <a:pPr algn="l"/>
             <a:r>
-              <a:rPr sz="1100" b="1" i="0">
+              <a:rPr sz="1200" b="1" i="0">
                 <a:solidFill>
                   <a:srgbClr val="B42B2B"/>
                 </a:solidFill>
@@ -8019,13 +8019,13 @@
               <a:t>✖  </a:t>
             </a:r>
             <a:r>
-              <a:rPr sz="1100" b="0" i="0">
+              <a:rPr sz="1200" b="0" i="0">
                 <a:solidFill>
                   <a:srgbClr val="1A1A1A"/>
                 </a:solidFill>
                 <a:latin typeface="Arial"/>
               </a:rPr>
-              <a:t>Same student enrolled at two colleges goes unseen</a:t>
+              <a:t>Same student at two colleges</a:t>
             </a:r>
           </a:p>
         </p:txBody>
@@ -8112,7 +8112,7 @@
           <a:p>
             <a:pPr algn="l"/>
             <a:r>
-              <a:rPr sz="1100" b="1" i="0">
+              <a:rPr sz="1200" b="1" i="0">
                 <a:solidFill>
                   <a:srgbClr val="1E7B3E"/>
                 </a:solidFill>
@@ -8121,13 +8121,13 @@
               <a:t>✔  </a:t>
             </a:r>
             <a:r>
-              <a:rPr sz="1100" b="0" i="0">
+              <a:rPr sz="1200" b="0" i="0">
                 <a:solidFill>
                   <a:srgbClr val="1A1A1A"/>
                 </a:solidFill>
                 <a:latin typeface="Arial"/>
               </a:rPr>
-              <a:t>Cross-college match + shared-contact rings</a:t>
+              <a:t>Cross-college match + contact rings</a:t>
             </a:r>
           </a:p>
         </p:txBody>
@@ -8178,7 +8178,7 @@
           <a:p>
             <a:pPr algn="l"/>
             <a:r>
-              <a:rPr sz="1100" b="1" i="0">
+              <a:rPr sz="1200" b="1" i="0">
                 <a:solidFill>
                   <a:srgbClr val="B42B2B"/>
                 </a:solidFill>
@@ -8187,13 +8187,13 @@
               <a:t>✖  </a:t>
             </a:r>
             <a:r>
-              <a:rPr sz="1100" b="0" i="0">
+              <a:rPr sz="1200" b="0" i="0">
                 <a:solidFill>
                   <a:srgbClr val="1A1A1A"/>
                 </a:solidFill>
                 <a:latin typeface="Arial"/>
               </a:rPr>
-              <a:t>Records are hard to verify at source (PS)</a:t>
+              <a:t>Hard to verify at source (PS)</a:t>
             </a:r>
           </a:p>
         </p:txBody>
@@ -8280,7 +8280,7 @@
           <a:p>
             <a:pPr algn="l"/>
             <a:r>
-              <a:rPr sz="1100" b="1" i="0">
+              <a:rPr sz="1200" b="1" i="0">
                 <a:solidFill>
                   <a:srgbClr val="1E7B3E"/>
                 </a:solidFill>
@@ -8289,13 +8289,13 @@
               <a:t>✔  </a:t>
             </a:r>
             <a:r>
-              <a:rPr sz="1100" b="0" i="0">
+              <a:rPr sz="1200" b="0" i="0">
                 <a:solidFill>
                   <a:srgbClr val="1A1A1A"/>
                 </a:solidFill>
                 <a:latin typeface="Arial"/>
               </a:rPr>
-              <a:t>Signed QR, checked even offline; consent for more</a:t>
+              <a:t>Signed QR, checks offline</a:t>
             </a:r>
           </a:p>
         </p:txBody>
@@ -8537,8 +8537,8 @@
                 </a:solidFill>
                 <a:latin typeface="Arial"/>
               </a:rPr>
-              <a:t>Mohd = Mohammed,
-but Rohit ≠ Mohit</a:t>
+              <a:t>Mohd = Mohammed
+Rohit ≠ Mohit</a:t>
             </a:r>
           </a:p>
         </p:txBody>
@@ -8717,7 +8717,7 @@
                 <a:latin typeface="Arial"/>
               </a:rPr>
               <a:t>1 phone, 8 students,
-2 colleges: flagged</a:t>
+2 colleges</a:t>
             </a:r>
           </a:p>
         </p:txBody>
@@ -8895,7 +8895,7 @@
                 </a:solidFill>
                 <a:latin typeface="Arial"/>
               </a:rPr>
-              <a:t>reason required;
+              <a:t>with a reason;
 never re-flagged</a:t>
             </a:r>
           </a:p>
@@ -9074,8 +9074,8 @@
                 </a:solidFill>
                 <a:latin typeface="Arial"/>
               </a:rPr>
-              <a:t>even a full history
-rewrite is caught</a:t>
+              <a:t>history rewrites
+detected</a:t>
             </a:r>
           </a:p>
         </p:txBody>
@@ -9253,8 +9253,8 @@
                 </a:solidFill>
                 <a:latin typeface="Arial"/>
               </a:rPr>
-              <a:t>each value sourced;
-unconfirmed: warn only</a:t>
+              <a:t>sourced; unconfirmed
+values only warn</a:t>
             </a:r>
           </a:p>
         </p:txBody>
@@ -9432,8 +9432,8 @@
                 </a:solidFill>
                 <a:latin typeface="Arial"/>
               </a:rPr>
-              <a:t>university print feed
-with verification QR</a:t>
+              <a:t>university print
+feed + QR</a:t>
             </a:r>
           </a:p>
         </p:txBody>
@@ -13009,8 +13009,8 @@
         </p:nvSpPr>
         <p:spPr>
           <a:xfrm>
-            <a:off x="457200" y="2048256"/>
-            <a:ext cx="1696212" cy="512064"/>
+            <a:off x="457200" y="2029968"/>
+            <a:ext cx="1696212" cy="530352"/>
           </a:xfrm>
           <a:prstGeom prst="rect">
             <a:avLst/>
@@ -13023,7 +13023,7 @@
           <a:p>
             <a:pPr algn="l"/>
             <a:r>
-              <a:rPr sz="1050" b="0" i="0">
+              <a:rPr sz="1100" b="0" i="0">
                 <a:solidFill>
                   <a:srgbClr val="1A1A1A"/>
                 </a:solidFill>
@@ -13188,8 +13188,8 @@
         </p:nvSpPr>
         <p:spPr>
           <a:xfrm>
-            <a:off x="2382012" y="2048256"/>
-            <a:ext cx="1696212" cy="512064"/>
+            <a:off x="2382012" y="2029968"/>
+            <a:ext cx="1696212" cy="530352"/>
           </a:xfrm>
           <a:prstGeom prst="rect">
             <a:avLst/>
@@ -13202,14 +13202,14 @@
           <a:p>
             <a:pPr algn="l"/>
             <a:r>
-              <a:rPr sz="1050" b="0" i="0">
+              <a:rPr sz="1100" b="0" i="0">
                 <a:solidFill>
                   <a:srgbClr val="1A1A1A"/>
                 </a:solidFill>
                 <a:latin typeface="Arial"/>
               </a:rPr>
-              <a:t>twins flagged: seeded ·
-held-out (sent for review)</a:t>
+              <a:t>twins flagged:
+seeded · held-out</a:t>
             </a:r>
           </a:p>
         </p:txBody>
@@ -13367,8 +13367,8 @@
         </p:nvSpPr>
         <p:spPr>
           <a:xfrm>
-            <a:off x="4306824" y="2048256"/>
-            <a:ext cx="1696212" cy="512064"/>
+            <a:off x="4306824" y="2029968"/>
+            <a:ext cx="1696212" cy="530352"/>
           </a:xfrm>
           <a:prstGeom prst="rect">
             <a:avLst/>
@@ -13381,14 +13381,14 @@
           <a:p>
             <a:pPr algn="l"/>
             <a:r>
-              <a:rPr sz="1050" b="0" i="0">
+              <a:rPr sz="1100" b="0" i="0">
                 <a:solidFill>
                   <a:srgbClr val="1A1A1A"/>
                 </a:solidFill>
                 <a:latin typeface="Arial"/>
               </a:rPr>
-              <a:t>planted error types; 0 false
-flags on 56 clean rows</a:t>
+              <a:t>error types caught;
+0 false flags (56 rows)</a:t>
             </a:r>
           </a:p>
         </p:txBody>
@@ -13546,8 +13546,8 @@
         </p:nvSpPr>
         <p:spPr>
           <a:xfrm>
-            <a:off x="6231636" y="2048256"/>
-            <a:ext cx="1696212" cy="512064"/>
+            <a:off x="6231636" y="2029968"/>
+            <a:ext cx="1696212" cy="530352"/>
           </a:xfrm>
           <a:prstGeom prst="rect">
             <a:avLst/>
@@ -13560,14 +13560,14 @@
           <a:p>
             <a:pPr algn="l"/>
             <a:r>
-              <a:rPr sz="1050" b="0" i="0">
+              <a:rPr sz="1100" b="0" i="0">
                 <a:solidFill>
                   <a:srgbClr val="1A1A1A"/>
                 </a:solidFill>
                 <a:latin typeface="Arial"/>
               </a:rPr>
-              <a:t>planted dual enrolments,
-identity dupes, contact rings</a:t>
+              <a:t>dual enrolments · ID
+dupes · contact rings</a:t>
             </a:r>
           </a:p>
         </p:txBody>
@@ -13725,8 +13725,8 @@
         </p:nvSpPr>
         <p:spPr>
           <a:xfrm>
-            <a:off x="8156448" y="2048256"/>
-            <a:ext cx="1696212" cy="512064"/>
+            <a:off x="8156448" y="2029968"/>
+            <a:ext cx="1696212" cy="530352"/>
           </a:xfrm>
           <a:prstGeom prst="rect">
             <a:avLst/>
@@ -13739,14 +13739,14 @@
           <a:p>
             <a:pPr algn="l"/>
             <a:r>
-              <a:rPr sz="1050" b="0" i="0">
+              <a:rPr sz="1100" b="0" i="0">
                 <a:solidFill>
                   <a:srgbClr val="1A1A1A"/>
                 </a:solidFill>
                 <a:latin typeface="Arial"/>
               </a:rPr>
               <a:t>top-ranked colleges
-were planted anomalies</a:t>
+were planted ones</a:t>
             </a:r>
           </a:p>
         </p:txBody>
@@ -13904,8 +13904,8 @@
         </p:nvSpPr>
         <p:spPr>
           <a:xfrm>
-            <a:off x="10081260" y="2048256"/>
-            <a:ext cx="1696212" cy="512064"/>
+            <a:off x="10081260" y="2029968"/>
+            <a:ext cx="1696212" cy="530352"/>
           </a:xfrm>
           <a:prstGeom prst="rect">
             <a:avLst/>
@@ -13918,14 +13918,14 @@
           <a:p>
             <a:pPr algn="l"/>
             <a:r>
-              <a:rPr sz="1050" b="0" i="0">
+              <a:rPr sz="1100" b="0" i="0">
                 <a:solidFill>
                   <a:srgbClr val="1A1A1A"/>
                 </a:solidFill>
                 <a:latin typeface="Arial"/>
               </a:rPr>
-              <a:t>93% coverage; security
-and WCAG checks in CI</a:t>
+              <a:t>93% coverage;
+security + WCAG in CI</a:t>
             </a:r>
           </a:p>
         </p:txBody>
@@ -13976,7 +13976,7 @@
           <a:p>
             <a:pPr algn="ctr"/>
             <a:r>
-              <a:rPr sz="1100" b="1" i="0">
+              <a:rPr sz="1200" b="1" i="0">
                 <a:solidFill>
                   <a:srgbClr val="B42B2B"/>
                 </a:solidFill>
@@ -13985,13 +13985,13 @@
               <a:t>All synthetic data: </a:t>
             </a:r>
             <a:r>
-              <a:rPr sz="1100" b="0" i="0">
+              <a:rPr sz="1200" b="0" i="0">
                 <a:solidFill>
                   <a:srgbClr val="1A1A1A"/>
                 </a:solidFill>
                 <a:latin typeface="Arial"/>
               </a:rPr>
-              <a:t>regression checks, not real-world accuracy, which the pilot will measure. A flag never acts on its own: an officer decides, with a recorded reason.</a:t>
+              <a:t>regression checks, not real-world accuracy (the pilot measures that). An officer decides every flag.</a:t>
             </a:r>
           </a:p>
         </p:txBody>
@@ -14258,7 +14258,7 @@
           <a:p>
             <a:pPr algn="l"/>
             <a:r>
-              <a:rPr sz="1150" b="1" i="0">
+              <a:rPr sz="1200" b="1" i="0">
                 <a:solidFill>
                   <a:srgbClr val="1A1A1A"/>
                 </a:solidFill>
@@ -14373,7 +14373,7 @@
           <a:p>
             <a:pPr algn="l"/>
             <a:r>
-              <a:rPr sz="1100" b="1" i="0">
+              <a:rPr sz="1200" b="1" i="0">
                 <a:solidFill>
                   <a:srgbClr val="1E7B3E"/>
                 </a:solidFill>
@@ -14382,13 +14382,13 @@
               <a:t>✔  </a:t>
             </a:r>
             <a:r>
-              <a:rPr sz="1100" b="0" i="0">
+              <a:rPr sz="1200" b="0" i="0">
                 <a:solidFill>
                   <a:srgbClr val="1A1A1A"/>
                 </a:solidFill>
                 <a:latin typeface="Arial"/>
               </a:rPr>
-              <a:t>Registry adapter: mock now → DigiLocker / API Setu after partner onboarding</a:t>
+              <a:t>Adapter: mock now → DigiLocker / API Setu</a:t>
             </a:r>
           </a:p>
         </p:txBody>
@@ -14527,7 +14527,7 @@
           <a:p>
             <a:pPr algn="l"/>
             <a:r>
-              <a:rPr sz="1150" b="1" i="0">
+              <a:rPr sz="1200" b="1" i="0">
                 <a:solidFill>
                   <a:srgbClr val="1A1A1A"/>
                 </a:solidFill>
@@ -14642,7 +14642,7 @@
           <a:p>
             <a:pPr algn="l"/>
             <a:r>
-              <a:rPr sz="1100" b="1" i="0">
+              <a:rPr sz="1200" b="1" i="0">
                 <a:solidFill>
                   <a:srgbClr val="1E7B3E"/>
                 </a:solidFill>
@@ -14651,13 +14651,13 @@
               <a:t>✔  </a:t>
             </a:r>
             <a:r>
-              <a:rPr sz="1100" b="0" i="0">
+              <a:rPr sz="1200" b="0" i="0">
                 <a:solidFill>
                   <a:srgbClr val="1A1A1A"/>
                 </a:solidFill>
                 <a:latin typeface="Arial"/>
               </a:rPr>
-              <a:t>Provisional ID, never rejected; mother's or guardian's name accepted</a:t>
+              <a:t>Provisional ID; never rejected</a:t>
             </a:r>
           </a:p>
         </p:txBody>
@@ -14796,13 +14796,13 @@
           <a:p>
             <a:pPr algn="l"/>
             <a:r>
-              <a:rPr sz="1150" b="1" i="0">
+              <a:rPr sz="1200" b="1" i="0">
                 <a:solidFill>
                   <a:srgbClr val="1A1A1A"/>
                 </a:solidFill>
                 <a:latin typeface="Arial"/>
               </a:rPr>
-              <a:t>Student privacy (DPDP Act; APAAR is voluntary)</a:t>
+              <a:t>Privacy (DPDP Act; APAAR is voluntary)</a:t>
             </a:r>
           </a:p>
         </p:txBody>
@@ -14911,7 +14911,7 @@
           <a:p>
             <a:pPr algn="l"/>
             <a:r>
-              <a:rPr sz="1100" b="1" i="0">
+              <a:rPr sz="1200" b="1" i="0">
                 <a:solidFill>
                   <a:srgbClr val="1E7B3E"/>
                 </a:solidFill>
@@ -14920,13 +14920,13 @@
               <a:t>✔  </a:t>
             </a:r>
             <a:r>
-              <a:rPr sz="1100" b="0" i="0">
+              <a:rPr sz="1200" b="0" i="0">
                 <a:solidFill>
                   <a:srgbClr val="1A1A1A"/>
                 </a:solidFill>
                 <a:latin typeface="Arial"/>
               </a:rPr>
-              <a:t>Consent per field, contacts encrypted at rest, no Aadhaar stored</a:t>
+              <a:t>Field-level consent; contacts encrypted; no Aadhaar</a:t>
             </a:r>
           </a:p>
         </p:txBody>
@@ -15065,13 +15065,13 @@
           <a:p>
             <a:pPr algn="l"/>
             <a:r>
-              <a:rPr sz="1150" b="1" i="0">
+              <a:rPr sz="1200" b="1" i="0">
                 <a:solidFill>
                   <a:srgbClr val="1A1A1A"/>
                 </a:solidFill>
                 <a:latin typeface="Arial"/>
               </a:rPr>
-              <a:t>Wrong flags: twins, spelling variants, bad data</a:t>
+              <a:t>Wrong flags: twins, spellings, bad data</a:t>
             </a:r>
           </a:p>
         </p:txBody>
@@ -15180,7 +15180,7 @@
           <a:p>
             <a:pPr algn="l"/>
             <a:r>
-              <a:rPr sz="1100" b="1" i="0">
+              <a:rPr sz="1200" b="1" i="0">
                 <a:solidFill>
                   <a:srgbClr val="1E7B3E"/>
                 </a:solidFill>
@@ -15189,13 +15189,13 @@
               <a:t>✔  </a:t>
             </a:r>
             <a:r>
-              <a:rPr sz="1100" b="0" i="0">
+              <a:rPr sz="1200" b="0" i="0">
                 <a:solidFill>
                   <a:srgbClr val="1A1A1A"/>
                 </a:solidFill>
                 <a:latin typeface="Arial"/>
               </a:rPr>
-              <a:t>Rejected rows never reach risk scores; reasons shown; officer decides</a:t>
+              <a:t>Reasons shown; officer decides; decision kept</a:t>
             </a:r>
           </a:p>
         </p:txBody>
@@ -15334,13 +15334,13 @@
           <a:p>
             <a:pPr algn="l"/>
             <a:r>
-              <a:rPr sz="1150" b="1" i="0">
+              <a:rPr sz="1200" b="1" i="0">
                 <a:solidFill>
                   <a:srgbClr val="1A1A1A"/>
                 </a:solidFill>
                 <a:latin typeface="Arial"/>
               </a:rPr>
-              <a:t>Rules change; some values not yet confirmed</a:t>
+              <a:t>Rules change; some values unconfirmed</a:t>
             </a:r>
           </a:p>
         </p:txBody>
@@ -15449,7 +15449,7 @@
           <a:p>
             <a:pPr algn="l"/>
             <a:r>
-              <a:rPr sz="1100" b="1" i="0">
+              <a:rPr sz="1200" b="1" i="0">
                 <a:solidFill>
                   <a:srgbClr val="1E7B3E"/>
                 </a:solidFill>
@@ -15458,13 +15458,13 @@
               <a:t>✔  </a:t>
             </a:r>
             <a:r>
-              <a:rPr sz="1100" b="0" i="0">
+              <a:rPr sz="1200" b="0" i="0">
                 <a:solidFill>
                   <a:srgbClr val="1A1A1A"/>
                 </a:solidFill>
                 <a:latin typeface="Arial"/>
               </a:rPr>
-              <a:t>Rules file per year; unconfirmed values warn, never reject</a:t>
+              <a:t>Rules file per year; unconfirmed values only warn</a:t>
             </a:r>
           </a:p>
         </p:txBody>
@@ -15603,13 +15603,13 @@
           <a:p>
             <a:pPr algn="l"/>
             <a:r>
-              <a:rPr sz="1150" b="1" i="0">
+              <a:rPr sz="1200" b="1" i="0">
                 <a:solidFill>
                   <a:srgbClr val="1A1A1A"/>
                 </a:solidFill>
                 <a:latin typeface="Arial"/>
               </a:rPr>
-              <a:t>ERP formats, low digital readiness</a:t>
+              <a:t>Varied ERP formats, low digital readiness</a:t>
             </a:r>
           </a:p>
         </p:txBody>
@@ -15718,7 +15718,7 @@
           <a:p>
             <a:pPr algn="l"/>
             <a:r>
-              <a:rPr sz="1100" b="1" i="0">
+              <a:rPr sz="1200" b="1" i="0">
                 <a:solidFill>
                   <a:srgbClr val="1E7B3E"/>
                 </a:solidFill>
@@ -15727,13 +15727,13 @@
               <a:t>✔  </a:t>
             </a:r>
             <a:r>
-              <a:rPr sz="1100" b="0" i="0">
+              <a:rPr sz="1200" b="0" i="0">
                 <a:solidFill>
                   <a:srgbClr val="1A1A1A"/>
                 </a:solidFill>
                 <a:latin typeface="Arial"/>
               </a:rPr>
-              <a:t>ERP headers auto-mapped, Excel template, API keys, Hindi, phone app</a:t>
+              <a:t>Headers auto-mapped; Excel template; Hindi; phone</a:t>
             </a:r>
           </a:p>
         </p:txBody>
@@ -15806,7 +15806,7 @@
           <a:p>
             <a:pPr algn="l"/>
             <a:r>
-              <a:rPr sz="1050" b="1" i="0">
+              <a:rPr sz="1100" b="1" i="0">
                 <a:solidFill>
                   <a:srgbClr val="E46C0A"/>
                 </a:solidFill>
@@ -15815,16 +15815,16 @@
               <a:t>Roadmap  </a:t>
             </a:r>
             <a:r>
-              <a:rPr sz="1050" b="0" i="0">
+              <a:rPr sz="1100" b="0" i="0">
                 <a:solidFill>
                   <a:srgbClr val="1A1A1A"/>
                 </a:solidFill>
                 <a:latin typeface="Arial"/>
               </a:rPr>
-              <a:t>M1–3 pilot, 1 state, 50 colleges: measure hours saved and false flags → M4–6 API Setu, SSO, STQC → M7–12 national   </a:t>
-            </a:r>
-            <a:r>
-              <a:rPr sz="1050" b="1" i="0">
+              <a:t>M1–3 pilot: 1 state, 50 colleges, measure hours saved → M4–6 API Setu, SSO, STQC → M7–12 national   </a:t>
+            </a:r>
+            <a:r>
+              <a:rPr sz="1100" b="1" i="0">
                 <a:solidFill>
                   <a:srgbClr val="E46C0A"/>
                 </a:solidFill>
@@ -15833,7 +15833,7 @@
               <a:t>Cost  </a:t>
             </a:r>
             <a:r>
-              <a:rPr sz="1050" b="0" i="0">
+              <a:rPr sz="1100" b="0" i="0">
                 <a:solidFill>
                   <a:srgbClr val="1A1A1A"/>
                 </a:solidFill>
@@ -16725,14 +16725,14 @@
           <a:p>
             <a:pPr algn="l"/>
             <a:r>
-              <a:rPr sz="1050" b="0" i="0">
+              <a:rPr sz="1100" b="0" i="0">
                 <a:solidFill>
                   <a:srgbClr val="1A1A1A"/>
                 </a:solidFill>
                 <a:latin typeface="Arial"/>
               </a:rPr>
-              <a:t>excess &amp; dual enrolment
-caught at submission</a:t>
+              <a:t>excess and dual
+enrolment at submission</a:t>
             </a:r>
           </a:p>
         </p:txBody>
@@ -16904,14 +16904,14 @@
           <a:p>
             <a:pPr algn="l"/>
             <a:r>
-              <a:rPr sz="1050" b="0" i="0">
+              <a:rPr sz="1100" b="0" i="0">
                 <a:solidFill>
                   <a:srgbClr val="1A1A1A"/>
                 </a:solidFill>
                 <a:latin typeface="Arial"/>
               </a:rPr>
-              <a:t>one upload; errors and
-corrections explained</a:t>
+              <a:t>one upload;
+errors explained</a:t>
             </a:r>
           </a:p>
         </p:txBody>
@@ -17083,14 +17083,14 @@
           <a:p>
             <a:pPr algn="l"/>
             <a:r>
-              <a:rPr sz="1050" b="0" i="0">
+              <a:rPr sz="1100" b="0" i="0">
                 <a:solidFill>
                   <a:srgbClr val="1A1A1A"/>
                 </a:solidFill>
                 <a:latin typeface="Arial"/>
               </a:rPr>
-              <a:t>APAAR + student ID
-printed on degrees</a:t>
+              <a:t>APAAR printed
+on degrees</a:t>
             </a:r>
           </a:p>
         </p:txBody>
@@ -17262,13 +17262,13 @@
           <a:p>
             <a:pPr algn="l"/>
             <a:r>
-              <a:rPr sz="1050" b="0" i="0">
+              <a:rPr sz="1100" b="0" i="0">
                 <a:solidFill>
                   <a:srgbClr val="1A1A1A"/>
                 </a:solidFill>
                 <a:latin typeface="Arial"/>
               </a:rPr>
-              <a:t>QR check on a phone;
+              <a:t>QR check;
 consent for more</a:t>
             </a:r>
           </a:p>
@@ -17441,14 +17441,14 @@
           <a:p>
             <a:pPr algn="l"/>
             <a:r>
-              <a:rPr sz="1050" b="0" i="0">
+              <a:rPr sz="1100" b="0" i="0">
                 <a:solidFill>
                   <a:srgbClr val="1A1A1A"/>
                 </a:solidFill>
                 <a:latin typeface="Arial"/>
               </a:rPr>
-              <a:t>own record; control
-over who sees it</a:t>
+              <a:t>control who
+sees their record</a:t>
             </a:r>
           </a:p>
         </p:txBody>
@@ -17521,7 +17521,7 @@
           <a:p>
             <a:pPr algn="l"/>
             <a:r>
-              <a:rPr sz="1150" b="1" i="0">
+              <a:rPr sz="1200" b="1" i="0">
                 <a:solidFill>
                   <a:srgbClr val="B42B2B"/>
                 </a:solidFill>
@@ -17540,8 +17540,8 @@
         </p:nvSpPr>
         <p:spPr>
           <a:xfrm>
-            <a:off x="393192" y="4718304"/>
-            <a:ext cx="1865376" cy="1444752"/>
+            <a:off x="393192" y="4736592"/>
+            <a:ext cx="1865376" cy="1426464"/>
           </a:xfrm>
           <a:prstGeom prst="rect">
             <a:avLst/>
@@ -17554,11 +17554,11 @@
           <a:p>
             <a:pPr algn="l">
               <a:spcAft>
-                <a:spcPts val="200"/>
+                <a:spcPts val="400"/>
               </a:spcAft>
             </a:pPr>
             <a:r>
-              <a:rPr sz="1000" b="1" i="0">
+              <a:rPr sz="1100" b="1" i="0">
                 <a:solidFill>
                   <a:srgbClr val="B42B2B"/>
                 </a:solidFill>
@@ -17567,23 +17567,23 @@
               <a:t>✖ </a:t>
             </a:r>
             <a:r>
-              <a:rPr sz="1000" b="0" i="0">
+              <a:rPr sz="1100" b="0" i="0">
                 <a:solidFill>
                   <a:srgbClr val="1A1A1A"/>
                 </a:solidFill>
                 <a:latin typeface="Arial"/>
               </a:rPr>
-              <a:t>₹23.1 cr fine = 42 excess seats × ₹11 lakh fee × 5 (FORE v AICTE, SC 2019)</a:t>
+              <a:t>₹23.1 cr fine: 42 seats × ₹11 lakh × 5 (SC, 2019)</a:t>
             </a:r>
           </a:p>
           <a:p>
             <a:pPr algn="l">
               <a:spcAft>
-                <a:spcPts val="200"/>
+                <a:spcPts val="400"/>
               </a:spcAft>
             </a:pPr>
             <a:r>
-              <a:rPr sz="1000" b="1" i="0">
+              <a:rPr sz="1100" b="1" i="0">
                 <a:solidFill>
                   <a:srgbClr val="B42B2B"/>
                 </a:solidFill>
@@ -17592,23 +17592,23 @@
               <a:t>✖ </a:t>
             </a:r>
             <a:r>
-              <a:rPr sz="1000" b="0" i="0">
+              <a:rPr sz="1100" b="0" i="0">
                 <a:solidFill>
                   <a:srgbClr val="1A1A1A"/>
                 </a:solidFill>
                 <a:latin typeface="Arial"/>
               </a:rPr>
-              <a:t>AISHE 2022-23 data published in 2026</a:t>
+              <a:t>AISHE 2022-23 data out in 2026</a:t>
             </a:r>
           </a:p>
           <a:p>
             <a:pPr algn="l">
               <a:spcAft>
-                <a:spcPts val="200"/>
+                <a:spcPts val="400"/>
               </a:spcAft>
             </a:pPr>
             <a:r>
-              <a:rPr sz="1000" b="1" i="0">
+              <a:rPr sz="1100" b="1" i="0">
                 <a:solidFill>
                   <a:srgbClr val="B42B2B"/>
                 </a:solidFill>
@@ -17617,13 +17617,13 @@
               <a:t>✖ </a:t>
             </a:r>
             <a:r>
-              <a:rPr sz="1000" b="0" i="0">
+              <a:rPr sz="1100" b="0" i="0">
                 <a:solidFill>
                   <a:srgbClr val="1A1A1A"/>
                 </a:solidFill>
                 <a:latin typeface="Arial"/>
               </a:rPr>
-              <a:t>“a number of students have mismatch in Aadhaar and APAAR ID details” (CU Srinagar, 2026)</a:t>
+              <a:t>APAAR–Aadhaar mismatches (CU Srinagar, 2026)</a:t>
             </a:r>
           </a:p>
         </p:txBody>
@@ -17696,7 +17696,7 @@
           <a:p>
             <a:pPr algn="l"/>
             <a:r>
-              <a:rPr sz="1150" b="1" i="0">
+              <a:rPr sz="1200" b="1" i="0">
                 <a:solidFill>
                   <a:srgbClr val="1E7B3E"/>
                 </a:solidFill>
@@ -17715,8 +17715,8 @@
         </p:nvSpPr>
         <p:spPr>
           <a:xfrm>
-            <a:off x="4389120" y="4718304"/>
-            <a:ext cx="1892807" cy="1444752"/>
+            <a:off x="4389120" y="4736592"/>
+            <a:ext cx="1892807" cy="1426464"/>
           </a:xfrm>
           <a:prstGeom prst="rect">
             <a:avLst/>
@@ -17729,11 +17729,11 @@
           <a:p>
             <a:pPr algn="l">
               <a:spcAft>
-                <a:spcPts val="200"/>
+                <a:spcPts val="400"/>
               </a:spcAft>
             </a:pPr>
             <a:r>
-              <a:rPr sz="1000" b="1" i="0">
+              <a:rPr sz="1100" b="1" i="0">
                 <a:solidFill>
                   <a:srgbClr val="1E7B3E"/>
                 </a:solidFill>
@@ -17742,23 +17742,23 @@
               <a:t>✔ </a:t>
             </a:r>
             <a:r>
-              <a:rPr sz="1000" b="0" i="0">
+              <a:rPr sz="1100" b="0" i="0">
                 <a:solidFill>
                   <a:srgbClr val="1A1A1A"/>
                 </a:solidFill>
                 <a:latin typeface="Arial"/>
               </a:rPr>
-              <a:t>Seat #61 of 60 refused at upload, the same day</a:t>
+              <a:t>Seat #61 of 60 refused at upload</a:t>
             </a:r>
           </a:p>
           <a:p>
             <a:pPr algn="l">
               <a:spcAft>
-                <a:spcPts val="200"/>
+                <a:spcPts val="400"/>
               </a:spcAft>
             </a:pPr>
             <a:r>
-              <a:rPr sz="1000" b="1" i="0">
+              <a:rPr sz="1100" b="1" i="0">
                 <a:solidFill>
                   <a:srgbClr val="1E7B3E"/>
                 </a:solidFill>
@@ -17767,23 +17767,23 @@
               <a:t>✔ </a:t>
             </a:r>
             <a:r>
-              <a:rPr sz="1000" b="0" i="0">
+              <a:rPr sz="1100" b="0" i="0">
                 <a:solidFill>
                   <a:srgbClr val="1A1A1A"/>
                 </a:solidFill>
                 <a:latin typeface="Arial"/>
               </a:rPr>
-              <a:t>National view refreshed after each submission</a:t>
+              <a:t>National view after each submission</a:t>
             </a:r>
           </a:p>
           <a:p>
             <a:pPr algn="l">
               <a:spcAft>
-                <a:spcPts val="200"/>
+                <a:spcPts val="400"/>
               </a:spcAft>
             </a:pPr>
             <a:r>
-              <a:rPr sz="1000" b="1" i="0">
+              <a:rPr sz="1100" b="1" i="0">
                 <a:solidFill>
                   <a:srgbClr val="1E7B3E"/>
                 </a:solidFill>
@@ -17792,13 +17792,13 @@
               <a:t>✔ </a:t>
             </a:r>
             <a:r>
-              <a:rPr sz="1000" b="0" i="0">
+              <a:rPr sz="1100" b="0" i="0">
                 <a:solidFill>
                   <a:srgbClr val="1A1A1A"/>
                 </a:solidFill>
                 <a:latin typeface="Arial"/>
               </a:rPr>
-              <a:t>Mismatch returned with its reason; fixed by re-upload</a:t>
+              <a:t>Mismatch returned with its reason</a:t>
             </a:r>
           </a:p>
         </p:txBody>
@@ -18034,14 +18034,14 @@
           <a:p>
             <a:pPr algn="l"/>
             <a:r>
-              <a:rPr sz="1100" b="0" i="0">
+              <a:rPr sz="1200" b="0" i="0">
                 <a:solidFill>
                   <a:srgbClr val="1A1A1A"/>
                 </a:solidFill>
                 <a:latin typeface="Arial"/>
               </a:rPr>
-              <a:t>APAAR opt-outs never refused,
-as the Supreme Court requires</a:t>
+              <a:t>APAAR opt-outs never
+refused (SC, 2026)</a:t>
             </a:r>
           </a:p>
         </p:txBody>
@@ -18213,14 +18213,14 @@
           <a:p>
             <a:pPr algn="l"/>
             <a:r>
-              <a:rPr sz="1100" b="0" i="0">
+              <a:rPr sz="1200" b="0" i="0">
                 <a:solidFill>
                   <a:srgbClr val="1A1A1A"/>
                 </a:solidFill>
                 <a:latin typeface="Arial"/>
               </a:rPr>
               <a:t>no licence fees; one upload
-serves AICTE and university</a:t>
+serves AICTE + university</a:t>
             </a:r>
           </a:p>
         </p:txBody>
@@ -18392,14 +18392,14 @@
           <a:p>
             <a:pPr algn="l"/>
             <a:r>
-              <a:rPr sz="1100" b="0" i="0">
+              <a:rPr sz="1200" b="0" i="0">
                 <a:solidFill>
                   <a:srgbClr val="1A1A1A"/>
                 </a:solidFill>
                 <a:latin typeface="Arial"/>
               </a:rPr>
-              <a:t>fewer paper returns and
-verification letters</a:t>
+              <a:t>fewer paper returns
+and letters</a:t>
             </a:r>
           </a:p>
         </p:txBody>
@@ -18571,14 +18571,14 @@
           <a:p>
             <a:pPr algn="l"/>
             <a:r>
-              <a:rPr sz="1100" b="0" i="0">
+              <a:rPr sz="1200" b="0" i="0">
                 <a:solidFill>
                   <a:srgbClr val="1A1A1A"/>
                 </a:solidFill>
                 <a:latin typeface="Arial"/>
               </a:rPr>
-              <a:t>audited evidence pack for
-review and show-cause</a:t>
+              <a:t>audited evidence
+pack for show-cause</a:t>
             </a:r>
           </a:p>
         </p:txBody>
@@ -18605,13 +18605,13 @@
           <a:p>
             <a:pPr algn="ctr"/>
             <a:r>
-              <a:rPr sz="1050" b="0" i="0">
+              <a:rPr sz="1100" b="0" i="0">
                 <a:solidFill>
                   <a:srgbClr val="595959"/>
                 </a:solidFill>
                 <a:latin typeface="Arial"/>
               </a:rPr>
-              <a:t>Expected benefits; the pilot measures hours saved and flags confirmed.</a:t>
+              <a:t>Expected benefits; the pilot measures them.</a:t>
             </a:r>
           </a:p>
         </p:txBody>
@@ -20589,22 +20589,22 @@
           <a:p>
             <a:pPr algn="l"/>
             <a:r>
-              <a:rPr sz="1050" b="1" i="0">
+              <a:rPr sz="1100" b="1" i="0">
                 <a:solidFill>
                   <a:srgbClr val="1F3864"/>
                 </a:solidFill>
                 <a:latin typeface="Arial"/>
               </a:rPr>
-              <a:t>✔ = built and covered by a test (docs/CLAIMS.md); other columns from public documentation (refs 4–5). </a:t>
-            </a:r>
-            <a:r>
-              <a:rPr sz="1050" b="0" i="0">
+              <a:t>✔ = built and tested (docs/CLAIMS.md). </a:t>
+            </a:r>
+            <a:r>
+              <a:rPr sz="1100" b="0" i="0">
                 <a:solidFill>
                   <a:srgbClr val="595959"/>
                 </a:solidFill>
                 <a:latin typeface="Arial"/>
               </a:rPr>
-              <a:t>Vidya Pramaan reuses APAAR and feeds NAD / ABC and AISHE: no new ID, no parallel credential store, no student rejected for opting out.</a:t>
+              <a:t>Reuses APAAR; no new ID.</a:t>
             </a:r>
           </a:p>
         </p:txBody>

</xml_diff>

<commit_message>
Link the demo video from the deck, README and sign-in page
Slide 6 gets a third QR (demo video) beside the prototype and the code;
slides 1 and 3 carry the link; every URL in the deck is clickable.
</commit_message>
<xml_diff>
--- a/ppt/SIH26263_AI_Riders_Idea.pptx
+++ b/ppt/SIH26263_AI_Riders_Idea.pptx
@@ -1218,7 +1218,7 @@
           <a:lstStyle/>
           <a:p>
             <a:r>
-              <a:t>We do not replace NAD, ABC or AISHE; we fill the gap none of them covers: student-level reconciliation of admissions against approved intake. Sources are on the right. Both QR codes work: the live prototype and the code with its tests.</a:t>
+              <a:t>We do not replace NAD, ABC or AISHE; we fill the gap none of them covers: student-level reconciliation of admissions against approved intake. Sources are on the right. The three QR codes open the five-minute demo video, the live prototype, and the code with its tests.</a:t>
             </a:r>
           </a:p>
         </p:txBody>
@@ -1371,7 +1371,7 @@
           <a:lstStyle/>
           <a:p>
             <a:r>
-              <a:t>Vidya Pramaan: one student, one APAAR ID, one verifiable record. A working prototype for SIH26263, live at the link on this slide, with seven demo roles and synthetic data only.</a:t>
+              <a:t>Vidya Pramaan: one student, one APAAR ID, one verifiable record. A working prototype for SIH26263, live at the link on this slide, with seven demo roles and synthetic data only. The five-minute narrated demo video shows every role end to end.</a:t>
             </a:r>
           </a:p>
         </p:txBody>
@@ -5923,12 +5923,12 @@
         </p:nvSpPr>
         <p:spPr>
           <a:xfrm>
-            <a:off x="411480" y="5394960"/>
-            <a:ext cx="5760720" cy="1005840"/>
+            <a:off x="411480" y="5413248"/>
+            <a:ext cx="5760720" cy="1188720"/>
           </a:xfrm>
           <a:prstGeom prst="roundRect">
             <a:avLst>
-              <a:gd name="adj" fmla="val 10909"/>
+              <a:gd name="adj" fmla="val 9230"/>
             </a:avLst>
           </a:prstGeom>
           <a:solidFill>
@@ -5969,7 +5969,7 @@
         </p:nvSpPr>
         <p:spPr>
           <a:xfrm>
-            <a:off x="548640" y="5550408"/>
+            <a:off x="548640" y="5660136"/>
             <a:ext cx="694944" cy="694944"/>
           </a:xfrm>
           <a:prstGeom prst="ellipse">
@@ -6019,7 +6019,7 @@
         </p:blipFill>
         <p:spPr>
           <a:xfrm>
-            <a:off x="701527" y="5703295"/>
+            <a:off x="701527" y="5813023"/>
             <a:ext cx="389168" cy="389168"/>
           </a:xfrm>
           <a:prstGeom prst="rect">
@@ -6035,8 +6035,8 @@
         </p:nvSpPr>
         <p:spPr>
           <a:xfrm>
-            <a:off x="1389888" y="5440680"/>
-            <a:ext cx="4709160" cy="914400"/>
+            <a:off x="1389888" y="5449824"/>
+            <a:ext cx="4709160" cy="1115568"/>
           </a:xfrm>
           <a:prstGeom prst="rect">
             <a:avLst/>
@@ -6087,8 +6087,31 @@
                   <a:srgbClr val="0070C0"/>
                 </a:solidFill>
                 <a:latin typeface="Arial"/>
-              </a:rPr>
-              <a:t>https://vidya-pramaan-sih26263.onrender.com</a:t>
+                <a:hlinkClick r:id="rId5"/>
+              </a:rPr>
+              <a:t>vidya-pramaan-sih26263.onrender.com</a:t>
+            </a:r>
+          </a:p>
+          <a:p>
+            <a:pPr algn="l"/>
+            <a:r>
+              <a:rPr sz="1100" b="0" i="0">
+                <a:solidFill>
+                  <a:srgbClr val="595959"/>
+                </a:solidFill>
+                <a:latin typeface="Arial"/>
+              </a:rPr>
+              <a:t>Demo video (5 min): </a:t>
+            </a:r>
+            <a:r>
+              <a:rPr sz="1100" b="0" i="0">
+                <a:solidFill>
+                  <a:srgbClr val="0070C0"/>
+                </a:solidFill>
+                <a:latin typeface="Arial"/>
+                <a:hlinkClick r:id="rId6"/>
+              </a:rPr>
+              <a:t>youtu.be/eBwySqMs63Q</a:t>
             </a:r>
           </a:p>
         </p:txBody>
@@ -12408,6 +12431,7 @@
                   <a:srgbClr val="0070C0"/>
                 </a:solidFill>
                 <a:latin typeface="Arial"/>
+                <a:hlinkClick r:id="rId12"/>
               </a:rPr>
               <a:t>https://vidya-pramaan-sih26263.onrender.com</a:t>
             </a:r>
@@ -12421,7 +12445,26 @@
                 </a:solidFill>
                 <a:latin typeface="Arial"/>
               </a:rPr>
-              <a:t>7 demo roles · synthetic data · first load can take a minute (free server)</a:t>
+              <a:t>Demo video (5 min): </a:t>
+            </a:r>
+            <a:r>
+              <a:rPr sz="1050" b="0" i="0">
+                <a:solidFill>
+                  <a:srgbClr val="0070C0"/>
+                </a:solidFill>
+                <a:latin typeface="Arial"/>
+                <a:hlinkClick r:id="rId13"/>
+              </a:rPr>
+              <a:t>youtu.be/eBwySqMs63Q</a:t>
+            </a:r>
+            <a:r>
+              <a:rPr sz="1050" b="0" i="0">
+                <a:solidFill>
+                  <a:srgbClr val="595959"/>
+                </a:solidFill>
+                <a:latin typeface="Arial"/>
+              </a:rPr>
+              <a:t> · 7 roles · synthetic data</a:t>
             </a:r>
           </a:p>
         </p:txBody>
@@ -20961,7 +21004,7 @@
       </p:sp>
       <p:pic>
         <p:nvPicPr>
-          <p:cNvPr id="17450" name="Picture 17449" descr="qr_live.png"/>
+          <p:cNvPr id="17450" name="Picture 17449" descr="qr_video.png"/>
           <p:cNvPicPr>
             <a:picLocks noChangeAspect="1"/>
           </p:cNvPicPr>
@@ -20975,8 +21018,8 @@
         </p:blipFill>
         <p:spPr>
           <a:xfrm>
-            <a:off x="457200" y="5074920"/>
-            <a:ext cx="1078992" cy="1078992"/>
+            <a:off x="429768" y="5093208"/>
+            <a:ext cx="1042415" cy="1042415"/>
           </a:xfrm>
           <a:prstGeom prst="rect">
             <a:avLst/>
@@ -20991,8 +21034,8 @@
         </p:nvSpPr>
         <p:spPr>
           <a:xfrm>
-            <a:off x="1664208" y="5093208"/>
-            <a:ext cx="4389120" cy="1042415"/>
+            <a:off x="1563624" y="5093208"/>
+            <a:ext cx="2569464" cy="1042415"/>
           </a:xfrm>
           <a:prstGeom prst="rect">
             <a:avLst/>
@@ -21011,19 +21054,20 @@
                 </a:solidFill>
                 <a:latin typeface="Arial"/>
               </a:rPr>
-              <a:t>Live prototype</a:t>
+              <a:t>Demo video, 5 min</a:t>
             </a:r>
           </a:p>
           <a:p>
             <a:pPr algn="l"/>
             <a:r>
-              <a:rPr sz="1200" b="0" i="0">
+              <a:rPr sz="1050" b="0" i="0">
                 <a:solidFill>
                   <a:srgbClr val="0070C0"/>
                 </a:solidFill>
                 <a:latin typeface="Arial"/>
-              </a:rPr>
-              <a:t>https://vidya-pramaan-sih26263.onrender.com</a:t>
+                <a:hlinkClick r:id="rId5"/>
+              </a:rPr>
+              <a:t>youtu.be/eBwySqMs63Q</a:t>
             </a:r>
           </a:p>
           <a:p>
@@ -21035,29 +21079,29 @@
                 </a:solidFill>
                 <a:latin typeface="Arial"/>
               </a:rPr>
-              <a:t>Synthetic data only · 7 demo roles · works on phones</a:t>
+              <a:t>every role, narrated, captioned</a:t>
             </a:r>
           </a:p>
         </p:txBody>
       </p:sp>
       <p:pic>
         <p:nvPicPr>
-          <p:cNvPr id="17452" name="Picture 17451" descr="qr_repo.png"/>
+          <p:cNvPr id="17452" name="Picture 17451" descr="qr_live.png"/>
           <p:cNvPicPr>
             <a:picLocks noChangeAspect="1"/>
           </p:cNvPicPr>
           <p:nvPr/>
         </p:nvPicPr>
         <p:blipFill>
-          <a:blip r:embed="rId5"/>
+          <a:blip r:embed="rId6"/>
           <a:stretch>
             <a:fillRect/>
           </a:stretch>
         </p:blipFill>
         <p:spPr>
           <a:xfrm>
-            <a:off x="6217920" y="5074920"/>
-            <a:ext cx="1078992" cy="1078992"/>
+            <a:off x="4279392" y="5093208"/>
+            <a:ext cx="1042415" cy="1042415"/>
           </a:xfrm>
           <a:prstGeom prst="rect">
             <a:avLst/>
@@ -21072,8 +21116,8 @@
         </p:nvSpPr>
         <p:spPr>
           <a:xfrm>
-            <a:off x="7424927" y="5093208"/>
-            <a:ext cx="4389120" cy="1042415"/>
+            <a:off x="5413248" y="5093208"/>
+            <a:ext cx="2569464" cy="1042415"/>
           </a:xfrm>
           <a:prstGeom prst="rect">
             <a:avLst/>
@@ -21092,19 +21136,102 @@
                 </a:solidFill>
                 <a:latin typeface="Arial"/>
               </a:rPr>
+              <a:t>Live prototype</a:t>
+            </a:r>
+          </a:p>
+          <a:p>
+            <a:pPr algn="l"/>
+            <a:r>
+              <a:rPr sz="1050" b="0" i="0">
+                <a:solidFill>
+                  <a:srgbClr val="0070C0"/>
+                </a:solidFill>
+                <a:latin typeface="Arial"/>
+                <a:hlinkClick r:id="rId7"/>
+              </a:rPr>
+              <a:t>vidya-pramaan-sih26263.onrender.com</a:t>
+            </a:r>
+          </a:p>
+          <a:p>
+            <a:pPr algn="l"/>
+            <a:r>
+              <a:rPr sz="1050" b="0" i="0">
+                <a:solidFill>
+                  <a:srgbClr val="595959"/>
+                </a:solidFill>
+                <a:latin typeface="Arial"/>
+              </a:rPr>
+              <a:t>7 demo roles · synthetic data</a:t>
+            </a:r>
+          </a:p>
+        </p:txBody>
+      </p:sp>
+      <p:pic>
+        <p:nvPicPr>
+          <p:cNvPr id="17454" name="Picture 17453" descr="qr_repo.png"/>
+          <p:cNvPicPr>
+            <a:picLocks noChangeAspect="1"/>
+          </p:cNvPicPr>
+          <p:nvPr/>
+        </p:nvPicPr>
+        <p:blipFill>
+          <a:blip r:embed="rId8"/>
+          <a:stretch>
+            <a:fillRect/>
+          </a:stretch>
+        </p:blipFill>
+        <p:spPr>
+          <a:xfrm>
+            <a:off x="8129015" y="5093208"/>
+            <a:ext cx="1042415" cy="1042415"/>
+          </a:xfrm>
+          <a:prstGeom prst="rect">
+            <a:avLst/>
+          </a:prstGeom>
+        </p:spPr>
+      </p:pic>
+      <p:sp>
+        <p:nvSpPr>
+          <p:cNvPr id="17455" name="TextBox 17454"/>
+          <p:cNvSpPr txBox="1"/>
+          <p:nvPr/>
+        </p:nvSpPr>
+        <p:spPr>
+          <a:xfrm>
+            <a:off x="9262872" y="5093208"/>
+            <a:ext cx="2569464" cy="1042415"/>
+          </a:xfrm>
+          <a:prstGeom prst="rect">
+            <a:avLst/>
+          </a:prstGeom>
+          <a:noFill/>
+        </p:spPr>
+        <p:txBody>
+          <a:bodyPr wrap="square" lIns="45720" rIns="45720" tIns="18288" bIns="18288" anchor="ctr"/>
+          <a:lstStyle/>
+          <a:p>
+            <a:pPr algn="l"/>
+            <a:r>
+              <a:rPr sz="1300" b="1" i="0">
+                <a:solidFill>
+                  <a:srgbClr val="E46C0A"/>
+                </a:solidFill>
+                <a:latin typeface="Arial"/>
+              </a:rPr>
               <a:t>Source code &amp; tests</a:t>
             </a:r>
           </a:p>
           <a:p>
             <a:pPr algn="l"/>
             <a:r>
-              <a:rPr sz="1200" b="0" i="0">
+              <a:rPr sz="1050" b="0" i="0">
                 <a:solidFill>
                   <a:srgbClr val="0070C0"/>
                 </a:solidFill>
                 <a:latin typeface="Arial"/>
-              </a:rPr>
-              <a:t>https://github.com/Pulkitkh/VidyaPramaan</a:t>
+                <a:hlinkClick r:id="rId9"/>
+              </a:rPr>
+              <a:t>github.com/Pulkitkh/VidyaPramaan</a:t>
             </a:r>
           </a:p>
           <a:p>
@@ -21116,7 +21243,7 @@
                 </a:solidFill>
                 <a:latin typeface="Arial"/>
               </a:rPr>
-              <a:t>65 tests · 93% coverage · MIT licence</a:t>
+              <a:t>65 tests · 93% coverage · MIT</a:t>
             </a:r>
           </a:p>
         </p:txBody>

</xml_diff>

<commit_message>
Deck: prototype screenshots on the title slide, plainer feasibility tiles
Slide 1: the template's large SIH illustration gives way to four screens
of the working prototype (national view, phone, duplicate review with
reasons, shared-contact graph), plus a QR to the live demo and a
7 roles / 31 rules / 65 tests line. The corner SIH logo and template
text stay.

Slide 4: each tile reads as a sentence ("0 of 80 seeded twin pairs
wrongly merged", "225 of 225 planted cases found: 164 dual enrolments,
57 ID duplicates, 4 contact rings").

Co-Authored-By: Claude Opus 5.5 <noreply@anthropic.com>
Claude-Session: https://claude.ai/code/session_01L1iLoXsmofstzCCRfoNYLY
</commit_message>
<xml_diff>
--- a/ppt/SIH26263_AI_Riders_Idea.pptx
+++ b/ppt/SIH26263_AI_Riders_Idea.pptx
@@ -1371,7 +1371,7 @@
           <a:lstStyle/>
           <a:p>
             <a:r>
-              <a:t>Vidya Pramaan: one student, one APAAR ID, one verifiable record. A working prototype for SIH26263, live at the link on this slide, with seven demo roles and synthetic data only. The five-minute narrated demo video shows every role end to end.</a:t>
+              <a:t>Vidya Pramaan: one student, one APAAR ID, one verifiable record. A working prototype for SIH26263, live at the link and QR on this slide, with seven demo roles and synthetic data only. The screenshots are the prototype: the AICTE national view, where each college's headline reason is the rule it broke; the same app on a phone; a probable duplicate under two APAAR IDs with the matcher's reasons; and one phone number shared by eight students at two colleges. The five-minute narrated demo video shows every role end to end.</a:t>
             </a:r>
           </a:p>
         </p:txBody>
@@ -4772,809 +4772,6 @@
       </p:sp>
       <p:sp>
         <p:nvSpPr>
-          <p:cNvPr id="37" name="Freeform: Shape 26">
-            <a:extLst>
-              <a:ext uri="{FF2B5EF4-FFF2-40B4-BE49-F238E27FC236}">
-                <a16:creationId xmlns:a16="http://schemas.microsoft.com/office/drawing/2014/main" id="{C04BE0EF-3561-49B4-9A29-F283168A91C7}"/>
-              </a:ext>
-              <a:ext uri="{C183D7F6-B498-43B3-948B-1728B52AA6E4}">
-                <adec:decorative xmlns:adec="http://schemas.microsoft.com/office/drawing/2017/decorative" xmlns="" val="1"/>
-              </a:ext>
-            </a:extLst>
-          </p:cNvPr>
-          <p:cNvSpPr>
-            <a:spLocks noGrp="1" noRot="1" noChangeAspect="1" noMove="1" noResize="1" noEditPoints="1" noAdjustHandles="1" noChangeArrowheads="1" noChangeShapeType="1" noTextEdit="1"/>
-          </p:cNvSpPr>
-          <p:nvPr>
-            <p:extLst>
-              <p:ext uri="{386F3935-93C4-4BCD-93E2-E3B085C9AB24}">
-                <p16:designElem xmlns:p16="http://schemas.microsoft.com/office/powerpoint/2015/main" val="1"/>
-              </p:ext>
-            </p:extLst>
-          </p:nvPr>
-        </p:nvSpPr>
-        <p:spPr>
-          <a:xfrm>
-            <a:off x="5656780" y="851521"/>
-            <a:ext cx="4638605" cy="5154967"/>
-          </a:xfrm>
-          <a:custGeom>
-            <a:avLst/>
-            <a:gdLst>
-              <a:gd name="connsiteX0" fmla="*/ 363179 w 6184806"/>
-              <a:gd name="connsiteY0" fmla="*/ 3125191 h 5154967"/>
-              <a:gd name="connsiteX1" fmla="*/ 898270 w 6184806"/>
-              <a:gd name="connsiteY1" fmla="*/ 3125191 h 5154967"/>
-              <a:gd name="connsiteX2" fmla="*/ 980326 w 6184806"/>
-              <a:gd name="connsiteY2" fmla="*/ 3173551 h 5154967"/>
-              <a:gd name="connsiteX3" fmla="*/ 1248448 w 6184806"/>
-              <a:gd name="connsiteY3" fmla="*/ 3635277 h 5154967"/>
-              <a:gd name="connsiteX4" fmla="*/ 1248448 w 6184806"/>
-              <a:gd name="connsiteY4" fmla="*/ 3729695 h 5154967"/>
-              <a:gd name="connsiteX5" fmla="*/ 980326 w 6184806"/>
-              <a:gd name="connsiteY5" fmla="*/ 4191421 h 5154967"/>
-              <a:gd name="connsiteX6" fmla="*/ 898270 w 6184806"/>
-              <a:gd name="connsiteY6" fmla="*/ 4239781 h 5154967"/>
-              <a:gd name="connsiteX7" fmla="*/ 363179 w 6184806"/>
-              <a:gd name="connsiteY7" fmla="*/ 4239781 h 5154967"/>
-              <a:gd name="connsiteX8" fmla="*/ 279969 w 6184806"/>
-              <a:gd name="connsiteY8" fmla="*/ 4191421 h 5154967"/>
-              <a:gd name="connsiteX9" fmla="*/ 13002 w 6184806"/>
-              <a:gd name="connsiteY9" fmla="*/ 3729695 h 5154967"/>
-              <a:gd name="connsiteX10" fmla="*/ 13002 w 6184806"/>
-              <a:gd name="connsiteY10" fmla="*/ 3635277 h 5154967"/>
-              <a:gd name="connsiteX11" fmla="*/ 279969 w 6184806"/>
-              <a:gd name="connsiteY11" fmla="*/ 3173551 h 5154967"/>
-              <a:gd name="connsiteX12" fmla="*/ 363179 w 6184806"/>
-              <a:gd name="connsiteY12" fmla="*/ 3125191 h 5154967"/>
-              <a:gd name="connsiteX13" fmla="*/ 2489721 w 6184806"/>
-              <a:gd name="connsiteY13" fmla="*/ 570035 h 5154967"/>
-              <a:gd name="connsiteX14" fmla="*/ 2764862 w 6184806"/>
-              <a:gd name="connsiteY14" fmla="*/ 570035 h 5154967"/>
-              <a:gd name="connsiteX15" fmla="*/ 2796959 w 6184806"/>
-              <a:gd name="connsiteY15" fmla="*/ 570035 h 5154967"/>
-              <a:gd name="connsiteX16" fmla="*/ 2827587 w 6184806"/>
-              <a:gd name="connsiteY16" fmla="*/ 622777 h 5154967"/>
-              <a:gd name="connsiteX17" fmla="*/ 2977604 w 6184806"/>
-              <a:gd name="connsiteY17" fmla="*/ 881117 h 5154967"/>
-              <a:gd name="connsiteX18" fmla="*/ 2977604 w 6184806"/>
-              <a:gd name="connsiteY18" fmla="*/ 1025720 h 5154967"/>
-              <a:gd name="connsiteX19" fmla="*/ 2566968 w 6184806"/>
-              <a:gd name="connsiteY19" fmla="*/ 1732863 h 5154967"/>
-              <a:gd name="connsiteX20" fmla="*/ 2441299 w 6184806"/>
-              <a:gd name="connsiteY20" fmla="*/ 1806927 h 5154967"/>
-              <a:gd name="connsiteX21" fmla="*/ 1621798 w 6184806"/>
-              <a:gd name="connsiteY21" fmla="*/ 1806927 h 5154967"/>
-              <a:gd name="connsiteX22" fmla="*/ 1583218 w 6184806"/>
-              <a:gd name="connsiteY22" fmla="*/ 1801802 h 5154967"/>
-              <a:gd name="connsiteX23" fmla="*/ 1556683 w 6184806"/>
-              <a:gd name="connsiteY23" fmla="*/ 1790677 h 5154967"/>
-              <a:gd name="connsiteX24" fmla="*/ 1572899 w 6184806"/>
-              <a:gd name="connsiteY24" fmla="*/ 1762630 h 5154967"/>
-              <a:gd name="connsiteX25" fmla="*/ 2147429 w 6184806"/>
-              <a:gd name="connsiteY25" fmla="*/ 768968 h 5154967"/>
-              <a:gd name="connsiteX26" fmla="*/ 2489721 w 6184806"/>
-              <a:gd name="connsiteY26" fmla="*/ 570035 h 5154967"/>
-              <a:gd name="connsiteX27" fmla="*/ 1573268 w 6184806"/>
-              <a:gd name="connsiteY27" fmla="*/ 0 h 5154967"/>
-              <a:gd name="connsiteX28" fmla="*/ 2497662 w 6184806"/>
-              <a:gd name="connsiteY28" fmla="*/ 0 h 5154967"/>
-              <a:gd name="connsiteX29" fmla="*/ 2639415 w 6184806"/>
-              <a:gd name="connsiteY29" fmla="*/ 83546 h 5154967"/>
-              <a:gd name="connsiteX30" fmla="*/ 2887862 w 6184806"/>
-              <a:gd name="connsiteY30" fmla="*/ 511387 h 5154967"/>
-              <a:gd name="connsiteX31" fmla="*/ 2915928 w 6184806"/>
-              <a:gd name="connsiteY31" fmla="*/ 559720 h 5154967"/>
-              <a:gd name="connsiteX32" fmla="*/ 2893844 w 6184806"/>
-              <a:gd name="connsiteY32" fmla="*/ 559720 h 5154967"/>
-              <a:gd name="connsiteX33" fmla="*/ 2789466 w 6184806"/>
-              <a:gd name="connsiteY33" fmla="*/ 559720 h 5154967"/>
-              <a:gd name="connsiteX34" fmla="*/ 2744122 w 6184806"/>
-              <a:gd name="connsiteY34" fmla="*/ 481634 h 5154967"/>
-              <a:gd name="connsiteX35" fmla="*/ 2570885 w 6184806"/>
-              <a:gd name="connsiteY35" fmla="*/ 183309 h 5154967"/>
-              <a:gd name="connsiteX36" fmla="*/ 2445216 w 6184806"/>
-              <a:gd name="connsiteY36" fmla="*/ 109243 h 5154967"/>
-              <a:gd name="connsiteX37" fmla="*/ 1625714 w 6184806"/>
-              <a:gd name="connsiteY37" fmla="*/ 109243 h 5154967"/>
-              <a:gd name="connsiteX38" fmla="*/ 1498276 w 6184806"/>
-              <a:gd name="connsiteY38" fmla="*/ 183309 h 5154967"/>
-              <a:gd name="connsiteX39" fmla="*/ 1089410 w 6184806"/>
-              <a:gd name="connsiteY39" fmla="*/ 890450 h 5154967"/>
-              <a:gd name="connsiteX40" fmla="*/ 1089410 w 6184806"/>
-              <a:gd name="connsiteY40" fmla="*/ 1035054 h 5154967"/>
-              <a:gd name="connsiteX41" fmla="*/ 1498276 w 6184806"/>
-              <a:gd name="connsiteY41" fmla="*/ 1742196 h 5154967"/>
-              <a:gd name="connsiteX42" fmla="*/ 1552039 w 6184806"/>
-              <a:gd name="connsiteY42" fmla="*/ 1796422 h 5154967"/>
-              <a:gd name="connsiteX43" fmla="*/ 1558260 w 6184806"/>
-              <a:gd name="connsiteY43" fmla="*/ 1799029 h 5154967"/>
-              <a:gd name="connsiteX44" fmla="*/ 1524911 w 6184806"/>
-              <a:gd name="connsiteY44" fmla="*/ 1856707 h 5154967"/>
-              <a:gd name="connsiteX45" fmla="*/ 1500108 w 6184806"/>
-              <a:gd name="connsiteY45" fmla="*/ 1899604 h 5154967"/>
-              <a:gd name="connsiteX46" fmla="*/ 1525834 w 6184806"/>
-              <a:gd name="connsiteY46" fmla="*/ 1910390 h 5154967"/>
-              <a:gd name="connsiteX47" fmla="*/ 1569352 w 6184806"/>
-              <a:gd name="connsiteY47" fmla="*/ 1916170 h 5154967"/>
-              <a:gd name="connsiteX48" fmla="*/ 2493745 w 6184806"/>
-              <a:gd name="connsiteY48" fmla="*/ 1916170 h 5154967"/>
-              <a:gd name="connsiteX49" fmla="*/ 2635498 w 6184806"/>
-              <a:gd name="connsiteY49" fmla="*/ 1832627 h 5154967"/>
-              <a:gd name="connsiteX50" fmla="*/ 3098693 w 6184806"/>
-              <a:gd name="connsiteY50" fmla="*/ 1034974 h 5154967"/>
-              <a:gd name="connsiteX51" fmla="*/ 3098693 w 6184806"/>
-              <a:gd name="connsiteY51" fmla="*/ 871863 h 5154967"/>
-              <a:gd name="connsiteX52" fmla="*/ 2945803 w 6184806"/>
-              <a:gd name="connsiteY52" fmla="*/ 608576 h 5154967"/>
-              <a:gd name="connsiteX53" fmla="*/ 2923422 w 6184806"/>
-              <a:gd name="connsiteY53" fmla="*/ 570035 h 5154967"/>
-              <a:gd name="connsiteX54" fmla="*/ 3027104 w 6184806"/>
-              <a:gd name="connsiteY54" fmla="*/ 570035 h 5154967"/>
-              <a:gd name="connsiteX55" fmla="*/ 4690846 w 6184806"/>
-              <a:gd name="connsiteY55" fmla="*/ 570035 h 5154967"/>
-              <a:gd name="connsiteX56" fmla="*/ 5028384 w 6184806"/>
-              <a:gd name="connsiteY56" fmla="*/ 768968 h 5154967"/>
-              <a:gd name="connsiteX57" fmla="*/ 6131323 w 6184806"/>
-              <a:gd name="connsiteY57" fmla="*/ 2668304 h 5154967"/>
-              <a:gd name="connsiteX58" fmla="*/ 6131323 w 6184806"/>
-              <a:gd name="connsiteY58" fmla="*/ 3056698 h 5154967"/>
-              <a:gd name="connsiteX59" fmla="*/ 5028384 w 6184806"/>
-              <a:gd name="connsiteY59" fmla="*/ 4956035 h 5154967"/>
-              <a:gd name="connsiteX60" fmla="*/ 4690846 w 6184806"/>
-              <a:gd name="connsiteY60" fmla="*/ 5154967 h 5154967"/>
-              <a:gd name="connsiteX61" fmla="*/ 2489721 w 6184806"/>
-              <a:gd name="connsiteY61" fmla="*/ 5154967 h 5154967"/>
-              <a:gd name="connsiteX62" fmla="*/ 2147429 w 6184806"/>
-              <a:gd name="connsiteY62" fmla="*/ 4956035 h 5154967"/>
-              <a:gd name="connsiteX63" fmla="*/ 1049243 w 6184806"/>
-              <a:gd name="connsiteY63" fmla="*/ 3056698 h 5154967"/>
-              <a:gd name="connsiteX64" fmla="*/ 1049243 w 6184806"/>
-              <a:gd name="connsiteY64" fmla="*/ 2668304 h 5154967"/>
-              <a:gd name="connsiteX65" fmla="*/ 1457007 w 6184806"/>
-              <a:gd name="connsiteY65" fmla="*/ 1963067 h 5154967"/>
-              <a:gd name="connsiteX66" fmla="*/ 1491373 w 6184806"/>
-              <a:gd name="connsiteY66" fmla="*/ 1903634 h 5154967"/>
-              <a:gd name="connsiteX67" fmla="*/ 1490164 w 6184806"/>
-              <a:gd name="connsiteY67" fmla="*/ 1903127 h 5154967"/>
-              <a:gd name="connsiteX68" fmla="*/ 1429519 w 6184806"/>
-              <a:gd name="connsiteY68" fmla="*/ 1841960 h 5154967"/>
-              <a:gd name="connsiteX69" fmla="*/ 968320 w 6184806"/>
-              <a:gd name="connsiteY69" fmla="*/ 1044307 h 5154967"/>
-              <a:gd name="connsiteX70" fmla="*/ 968320 w 6184806"/>
-              <a:gd name="connsiteY70" fmla="*/ 881196 h 5154967"/>
-              <a:gd name="connsiteX71" fmla="*/ 1429519 w 6184806"/>
-              <a:gd name="connsiteY71" fmla="*/ 83546 h 5154967"/>
-              <a:gd name="connsiteX72" fmla="*/ 1573268 w 6184806"/>
-              <a:gd name="connsiteY72" fmla="*/ 0 h 5154967"/>
-            </a:gdLst>
-            <a:ahLst/>
-            <a:cxnLst>
-              <a:cxn ang="0">
-                <a:pos x="connsiteX0" y="connsiteY0"/>
-              </a:cxn>
-              <a:cxn ang="0">
-                <a:pos x="connsiteX1" y="connsiteY1"/>
-              </a:cxn>
-              <a:cxn ang="0">
-                <a:pos x="connsiteX2" y="connsiteY2"/>
-              </a:cxn>
-              <a:cxn ang="0">
-                <a:pos x="connsiteX3" y="connsiteY3"/>
-              </a:cxn>
-              <a:cxn ang="0">
-                <a:pos x="connsiteX4" y="connsiteY4"/>
-              </a:cxn>
-              <a:cxn ang="0">
-                <a:pos x="connsiteX5" y="connsiteY5"/>
-              </a:cxn>
-              <a:cxn ang="0">
-                <a:pos x="connsiteX6" y="connsiteY6"/>
-              </a:cxn>
-              <a:cxn ang="0">
-                <a:pos x="connsiteX7" y="connsiteY7"/>
-              </a:cxn>
-              <a:cxn ang="0">
-                <a:pos x="connsiteX8" y="connsiteY8"/>
-              </a:cxn>
-              <a:cxn ang="0">
-                <a:pos x="connsiteX9" y="connsiteY9"/>
-              </a:cxn>
-              <a:cxn ang="0">
-                <a:pos x="connsiteX10" y="connsiteY10"/>
-              </a:cxn>
-              <a:cxn ang="0">
-                <a:pos x="connsiteX11" y="connsiteY11"/>
-              </a:cxn>
-              <a:cxn ang="0">
-                <a:pos x="connsiteX12" y="connsiteY12"/>
-              </a:cxn>
-              <a:cxn ang="0">
-                <a:pos x="connsiteX13" y="connsiteY13"/>
-              </a:cxn>
-              <a:cxn ang="0">
-                <a:pos x="connsiteX14" y="connsiteY14"/>
-              </a:cxn>
-              <a:cxn ang="0">
-                <a:pos x="connsiteX15" y="connsiteY15"/>
-              </a:cxn>
-              <a:cxn ang="0">
-                <a:pos x="connsiteX16" y="connsiteY16"/>
-              </a:cxn>
-              <a:cxn ang="0">
-                <a:pos x="connsiteX17" y="connsiteY17"/>
-              </a:cxn>
-              <a:cxn ang="0">
-                <a:pos x="connsiteX18" y="connsiteY18"/>
-              </a:cxn>
-              <a:cxn ang="0">
-                <a:pos x="connsiteX19" y="connsiteY19"/>
-              </a:cxn>
-              <a:cxn ang="0">
-                <a:pos x="connsiteX20" y="connsiteY20"/>
-              </a:cxn>
-              <a:cxn ang="0">
-                <a:pos x="connsiteX21" y="connsiteY21"/>
-              </a:cxn>
-              <a:cxn ang="0">
-                <a:pos x="connsiteX22" y="connsiteY22"/>
-              </a:cxn>
-              <a:cxn ang="0">
-                <a:pos x="connsiteX23" y="connsiteY23"/>
-              </a:cxn>
-              <a:cxn ang="0">
-                <a:pos x="connsiteX24" y="connsiteY24"/>
-              </a:cxn>
-              <a:cxn ang="0">
-                <a:pos x="connsiteX25" y="connsiteY25"/>
-              </a:cxn>
-              <a:cxn ang="0">
-                <a:pos x="connsiteX26" y="connsiteY26"/>
-              </a:cxn>
-              <a:cxn ang="0">
-                <a:pos x="connsiteX27" y="connsiteY27"/>
-              </a:cxn>
-              <a:cxn ang="0">
-                <a:pos x="connsiteX28" y="connsiteY28"/>
-              </a:cxn>
-              <a:cxn ang="0">
-                <a:pos x="connsiteX29" y="connsiteY29"/>
-              </a:cxn>
-              <a:cxn ang="0">
-                <a:pos x="connsiteX30" y="connsiteY30"/>
-              </a:cxn>
-              <a:cxn ang="0">
-                <a:pos x="connsiteX31" y="connsiteY31"/>
-              </a:cxn>
-              <a:cxn ang="0">
-                <a:pos x="connsiteX32" y="connsiteY32"/>
-              </a:cxn>
-              <a:cxn ang="0">
-                <a:pos x="connsiteX33" y="connsiteY33"/>
-              </a:cxn>
-              <a:cxn ang="0">
-                <a:pos x="connsiteX34" y="connsiteY34"/>
-              </a:cxn>
-              <a:cxn ang="0">
-                <a:pos x="connsiteX35" y="connsiteY35"/>
-              </a:cxn>
-              <a:cxn ang="0">
-                <a:pos x="connsiteX36" y="connsiteY36"/>
-              </a:cxn>
-              <a:cxn ang="0">
-                <a:pos x="connsiteX37" y="connsiteY37"/>
-              </a:cxn>
-              <a:cxn ang="0">
-                <a:pos x="connsiteX38" y="connsiteY38"/>
-              </a:cxn>
-              <a:cxn ang="0">
-                <a:pos x="connsiteX39" y="connsiteY39"/>
-              </a:cxn>
-              <a:cxn ang="0">
-                <a:pos x="connsiteX40" y="connsiteY40"/>
-              </a:cxn>
-              <a:cxn ang="0">
-                <a:pos x="connsiteX41" y="connsiteY41"/>
-              </a:cxn>
-              <a:cxn ang="0">
-                <a:pos x="connsiteX42" y="connsiteY42"/>
-              </a:cxn>
-              <a:cxn ang="0">
-                <a:pos x="connsiteX43" y="connsiteY43"/>
-              </a:cxn>
-              <a:cxn ang="0">
-                <a:pos x="connsiteX44" y="connsiteY44"/>
-              </a:cxn>
-              <a:cxn ang="0">
-                <a:pos x="connsiteX45" y="connsiteY45"/>
-              </a:cxn>
-              <a:cxn ang="0">
-                <a:pos x="connsiteX46" y="connsiteY46"/>
-              </a:cxn>
-              <a:cxn ang="0">
-                <a:pos x="connsiteX47" y="connsiteY47"/>
-              </a:cxn>
-              <a:cxn ang="0">
-                <a:pos x="connsiteX48" y="connsiteY48"/>
-              </a:cxn>
-              <a:cxn ang="0">
-                <a:pos x="connsiteX49" y="connsiteY49"/>
-              </a:cxn>
-              <a:cxn ang="0">
-                <a:pos x="connsiteX50" y="connsiteY50"/>
-              </a:cxn>
-              <a:cxn ang="0">
-                <a:pos x="connsiteX51" y="connsiteY51"/>
-              </a:cxn>
-              <a:cxn ang="0">
-                <a:pos x="connsiteX52" y="connsiteY52"/>
-              </a:cxn>
-              <a:cxn ang="0">
-                <a:pos x="connsiteX53" y="connsiteY53"/>
-              </a:cxn>
-              <a:cxn ang="0">
-                <a:pos x="connsiteX54" y="connsiteY54"/>
-              </a:cxn>
-              <a:cxn ang="0">
-                <a:pos x="connsiteX55" y="connsiteY55"/>
-              </a:cxn>
-              <a:cxn ang="0">
-                <a:pos x="connsiteX56" y="connsiteY56"/>
-              </a:cxn>
-              <a:cxn ang="0">
-                <a:pos x="connsiteX57" y="connsiteY57"/>
-              </a:cxn>
-              <a:cxn ang="0">
-                <a:pos x="connsiteX58" y="connsiteY58"/>
-              </a:cxn>
-              <a:cxn ang="0">
-                <a:pos x="connsiteX59" y="connsiteY59"/>
-              </a:cxn>
-              <a:cxn ang="0">
-                <a:pos x="connsiteX60" y="connsiteY60"/>
-              </a:cxn>
-              <a:cxn ang="0">
-                <a:pos x="connsiteX61" y="connsiteY61"/>
-              </a:cxn>
-              <a:cxn ang="0">
-                <a:pos x="connsiteX62" y="connsiteY62"/>
-              </a:cxn>
-              <a:cxn ang="0">
-                <a:pos x="connsiteX63" y="connsiteY63"/>
-              </a:cxn>
-              <a:cxn ang="0">
-                <a:pos x="connsiteX64" y="connsiteY64"/>
-              </a:cxn>
-              <a:cxn ang="0">
-                <a:pos x="connsiteX65" y="connsiteY65"/>
-              </a:cxn>
-              <a:cxn ang="0">
-                <a:pos x="connsiteX66" y="connsiteY66"/>
-              </a:cxn>
-              <a:cxn ang="0">
-                <a:pos x="connsiteX67" y="connsiteY67"/>
-              </a:cxn>
-              <a:cxn ang="0">
-                <a:pos x="connsiteX68" y="connsiteY68"/>
-              </a:cxn>
-              <a:cxn ang="0">
-                <a:pos x="connsiteX69" y="connsiteY69"/>
-              </a:cxn>
-              <a:cxn ang="0">
-                <a:pos x="connsiteX70" y="connsiteY70"/>
-              </a:cxn>
-              <a:cxn ang="0">
-                <a:pos x="connsiteX71" y="connsiteY71"/>
-              </a:cxn>
-              <a:cxn ang="0">
-                <a:pos x="connsiteX72" y="connsiteY72"/>
-              </a:cxn>
-            </a:cxnLst>
-            <a:rect l="l" t="t" r="r" b="b"/>
-            <a:pathLst>
-              <a:path w="6184806" h="5154967">
-                <a:moveTo>
-                  <a:pt x="363179" y="3125191"/>
-                </a:moveTo>
-                <a:cubicBezTo>
-                  <a:pt x="363179" y="3125191"/>
-                  <a:pt x="363179" y="3125191"/>
-                  <a:pt x="898270" y="3125191"/>
-                </a:cubicBezTo>
-                <a:cubicBezTo>
-                  <a:pt x="931786" y="3125191"/>
-                  <a:pt x="964145" y="3143614"/>
-                  <a:pt x="980326" y="3173551"/>
-                </a:cubicBezTo>
-                <a:cubicBezTo>
-                  <a:pt x="980326" y="3173551"/>
-                  <a:pt x="980326" y="3173551"/>
-                  <a:pt x="1248448" y="3635277"/>
-                </a:cubicBezTo>
-                <a:cubicBezTo>
-                  <a:pt x="1265784" y="3664063"/>
-                  <a:pt x="1265784" y="3700909"/>
-                  <a:pt x="1248448" y="3729695"/>
-                </a:cubicBezTo>
-                <a:cubicBezTo>
-                  <a:pt x="1248448" y="3729695"/>
-                  <a:pt x="1248448" y="3729695"/>
-                  <a:pt x="980326" y="4191421"/>
-                </a:cubicBezTo>
-                <a:cubicBezTo>
-                  <a:pt x="964145" y="4221358"/>
-                  <a:pt x="931786" y="4239781"/>
-                  <a:pt x="898270" y="4239781"/>
-                </a:cubicBezTo>
-                <a:cubicBezTo>
-                  <a:pt x="898270" y="4239781"/>
-                  <a:pt x="898270" y="4239781"/>
-                  <a:pt x="363179" y="4239781"/>
-                </a:cubicBezTo>
-                <a:cubicBezTo>
-                  <a:pt x="328508" y="4239781"/>
-                  <a:pt x="297305" y="4221358"/>
-                  <a:pt x="279969" y="4191421"/>
-                </a:cubicBezTo>
-                <a:cubicBezTo>
-                  <a:pt x="279969" y="4191421"/>
-                  <a:pt x="279969" y="4191421"/>
-                  <a:pt x="13002" y="3729695"/>
-                </a:cubicBezTo>
-                <a:cubicBezTo>
-                  <a:pt x="-4334" y="3700909"/>
-                  <a:pt x="-4334" y="3664063"/>
-                  <a:pt x="13002" y="3635277"/>
-                </a:cubicBezTo>
-                <a:cubicBezTo>
-                  <a:pt x="13002" y="3635277"/>
-                  <a:pt x="13002" y="3635277"/>
-                  <a:pt x="279969" y="3173551"/>
-                </a:cubicBezTo>
-                <a:cubicBezTo>
-                  <a:pt x="297305" y="3143614"/>
-                  <a:pt x="328508" y="3125191"/>
-                  <a:pt x="363179" y="3125191"/>
-                </a:cubicBezTo>
-                <a:close/>
-                <a:moveTo>
-                  <a:pt x="2489721" y="570035"/>
-                </a:moveTo>
-                <a:cubicBezTo>
-                  <a:pt x="2489721" y="570035"/>
-                  <a:pt x="2489721" y="570035"/>
-                  <a:pt x="2764862" y="570035"/>
-                </a:cubicBezTo>
-                <a:lnTo>
-                  <a:pt x="2796959" y="570035"/>
-                </a:lnTo>
-                <a:lnTo>
-                  <a:pt x="2827587" y="622777"/>
-                </a:lnTo>
-                <a:cubicBezTo>
-                  <a:pt x="2870233" y="696217"/>
-                  <a:pt x="2919858" y="781675"/>
-                  <a:pt x="2977604" y="881117"/>
-                </a:cubicBezTo>
-                <a:cubicBezTo>
-                  <a:pt x="3004153" y="925204"/>
-                  <a:pt x="3004153" y="981634"/>
-                  <a:pt x="2977604" y="1025720"/>
-                </a:cubicBezTo>
-                <a:cubicBezTo>
-                  <a:pt x="2977604" y="1025720"/>
-                  <a:pt x="2977604" y="1025720"/>
-                  <a:pt x="2566968" y="1732863"/>
-                </a:cubicBezTo>
-                <a:cubicBezTo>
-                  <a:pt x="2542188" y="1778712"/>
-                  <a:pt x="2492629" y="1806927"/>
-                  <a:pt x="2441299" y="1806927"/>
-                </a:cubicBezTo>
-                <a:cubicBezTo>
-                  <a:pt x="2441299" y="1806927"/>
-                  <a:pt x="2441299" y="1806927"/>
-                  <a:pt x="1621798" y="1806927"/>
-                </a:cubicBezTo>
-                <a:cubicBezTo>
-                  <a:pt x="1608523" y="1806927"/>
-                  <a:pt x="1595580" y="1805163"/>
-                  <a:pt x="1583218" y="1801802"/>
-                </a:cubicBezTo>
-                <a:lnTo>
-                  <a:pt x="1556683" y="1790677"/>
-                </a:lnTo>
-                <a:lnTo>
-                  <a:pt x="1572899" y="1762630"/>
-                </a:lnTo>
-                <a:cubicBezTo>
-                  <a:pt x="1719523" y="1509042"/>
-                  <a:pt x="1907201" y="1184448"/>
-                  <a:pt x="2147429" y="768968"/>
-                </a:cubicBezTo>
-                <a:cubicBezTo>
-                  <a:pt x="2218739" y="645819"/>
-                  <a:pt x="2347099" y="570035"/>
-                  <a:pt x="2489721" y="570035"/>
-                </a:cubicBezTo>
-                <a:close/>
-                <a:moveTo>
-                  <a:pt x="1573268" y="0"/>
-                </a:moveTo>
-                <a:cubicBezTo>
-                  <a:pt x="1573268" y="0"/>
-                  <a:pt x="1573268" y="0"/>
-                  <a:pt x="2497662" y="0"/>
-                </a:cubicBezTo>
-                <a:cubicBezTo>
-                  <a:pt x="2555561" y="0"/>
-                  <a:pt x="2611463" y="31828"/>
-                  <a:pt x="2639415" y="83546"/>
-                </a:cubicBezTo>
-                <a:cubicBezTo>
-                  <a:pt x="2639415" y="83546"/>
-                  <a:pt x="2639415" y="83546"/>
-                  <a:pt x="2887862" y="511387"/>
-                </a:cubicBezTo>
-                <a:lnTo>
-                  <a:pt x="2915928" y="559720"/>
-                </a:lnTo>
-                <a:lnTo>
-                  <a:pt x="2893844" y="559720"/>
-                </a:lnTo>
-                <a:lnTo>
-                  <a:pt x="2789466" y="559720"/>
-                </a:lnTo>
-                <a:lnTo>
-                  <a:pt x="2744122" y="481634"/>
-                </a:lnTo>
-                <a:cubicBezTo>
-                  <a:pt x="2570885" y="183309"/>
-                  <a:pt x="2570885" y="183309"/>
-                  <a:pt x="2570885" y="183309"/>
-                </a:cubicBezTo>
-                <a:cubicBezTo>
-                  <a:pt x="2546104" y="137459"/>
-                  <a:pt x="2496545" y="109243"/>
-                  <a:pt x="2445216" y="109243"/>
-                </a:cubicBezTo>
-                <a:cubicBezTo>
-                  <a:pt x="1625714" y="109243"/>
-                  <a:pt x="1625714" y="109243"/>
-                  <a:pt x="1625714" y="109243"/>
-                </a:cubicBezTo>
-                <a:cubicBezTo>
-                  <a:pt x="1572615" y="109243"/>
-                  <a:pt x="1524825" y="137459"/>
-                  <a:pt x="1498276" y="183309"/>
-                </a:cubicBezTo>
-                <a:cubicBezTo>
-                  <a:pt x="1089410" y="890450"/>
-                  <a:pt x="1089410" y="890450"/>
-                  <a:pt x="1089410" y="890450"/>
-                </a:cubicBezTo>
-                <a:cubicBezTo>
-                  <a:pt x="1062860" y="934537"/>
-                  <a:pt x="1062860" y="990967"/>
-                  <a:pt x="1089410" y="1035054"/>
-                </a:cubicBezTo>
-                <a:cubicBezTo>
-                  <a:pt x="1498276" y="1742196"/>
-                  <a:pt x="1498276" y="1742196"/>
-                  <a:pt x="1498276" y="1742196"/>
-                </a:cubicBezTo>
-                <a:cubicBezTo>
-                  <a:pt x="1511551" y="1765121"/>
-                  <a:pt x="1530135" y="1783637"/>
-                  <a:pt x="1552039" y="1796422"/>
-                </a:cubicBezTo>
-                <a:lnTo>
-                  <a:pt x="1558260" y="1799029"/>
-                </a:lnTo>
-                <a:lnTo>
-                  <a:pt x="1524911" y="1856707"/>
-                </a:lnTo>
-                <a:lnTo>
-                  <a:pt x="1500108" y="1899604"/>
-                </a:lnTo>
-                <a:lnTo>
-                  <a:pt x="1525834" y="1910390"/>
-                </a:lnTo>
-                <a:cubicBezTo>
-                  <a:pt x="1539779" y="1914181"/>
-                  <a:pt x="1554378" y="1916170"/>
-                  <a:pt x="1569352" y="1916170"/>
-                </a:cubicBezTo>
-                <a:cubicBezTo>
-                  <a:pt x="2493745" y="1916170"/>
-                  <a:pt x="2493745" y="1916170"/>
-                  <a:pt x="2493745" y="1916170"/>
-                </a:cubicBezTo>
-                <a:cubicBezTo>
-                  <a:pt x="2551645" y="1916170"/>
-                  <a:pt x="2607546" y="1884345"/>
-                  <a:pt x="2635498" y="1832627"/>
-                </a:cubicBezTo>
-                <a:cubicBezTo>
-                  <a:pt x="3098693" y="1034974"/>
-                  <a:pt x="3098693" y="1034974"/>
-                  <a:pt x="3098693" y="1034974"/>
-                </a:cubicBezTo>
-                <a:cubicBezTo>
-                  <a:pt x="3128641" y="985246"/>
-                  <a:pt x="3128641" y="921593"/>
-                  <a:pt x="3098693" y="871863"/>
-                </a:cubicBezTo>
-                <a:cubicBezTo>
-                  <a:pt x="3040794" y="772157"/>
-                  <a:pt x="2990132" y="684914"/>
-                  <a:pt x="2945803" y="608576"/>
-                </a:cubicBezTo>
-                <a:lnTo>
-                  <a:pt x="2923422" y="570035"/>
-                </a:lnTo>
-                <a:lnTo>
-                  <a:pt x="3027104" y="570035"/>
-                </a:lnTo>
-                <a:cubicBezTo>
-                  <a:pt x="3349535" y="570035"/>
-                  <a:pt x="3865424" y="570035"/>
-                  <a:pt x="4690846" y="570035"/>
-                </a:cubicBezTo>
-                <a:cubicBezTo>
-                  <a:pt x="4828714" y="570035"/>
-                  <a:pt x="4961827" y="645819"/>
-                  <a:pt x="5028384" y="768968"/>
-                </a:cubicBezTo>
-                <a:cubicBezTo>
-                  <a:pt x="5028384" y="768968"/>
-                  <a:pt x="5028384" y="768968"/>
-                  <a:pt x="6131323" y="2668304"/>
-                </a:cubicBezTo>
-                <a:cubicBezTo>
-                  <a:pt x="6202634" y="2786717"/>
-                  <a:pt x="6202634" y="2938285"/>
-                  <a:pt x="6131323" y="3056698"/>
-                </a:cubicBezTo>
-                <a:cubicBezTo>
-                  <a:pt x="6131323" y="3056698"/>
-                  <a:pt x="6131323" y="3056698"/>
-                  <a:pt x="5028384" y="4956035"/>
-                </a:cubicBezTo>
-                <a:cubicBezTo>
-                  <a:pt x="4961827" y="5079184"/>
-                  <a:pt x="4828714" y="5154967"/>
-                  <a:pt x="4690846" y="5154967"/>
-                </a:cubicBezTo>
-                <a:cubicBezTo>
-                  <a:pt x="4690846" y="5154967"/>
-                  <a:pt x="4690846" y="5154967"/>
-                  <a:pt x="2489721" y="5154967"/>
-                </a:cubicBezTo>
-                <a:cubicBezTo>
-                  <a:pt x="2347099" y="5154967"/>
-                  <a:pt x="2218739" y="5079184"/>
-                  <a:pt x="2147429" y="4956035"/>
-                </a:cubicBezTo>
-                <a:cubicBezTo>
-                  <a:pt x="2147429" y="4956035"/>
-                  <a:pt x="2147429" y="4956035"/>
-                  <a:pt x="1049243" y="3056698"/>
-                </a:cubicBezTo>
-                <a:cubicBezTo>
-                  <a:pt x="977932" y="2938285"/>
-                  <a:pt x="977932" y="2786717"/>
-                  <a:pt x="1049243" y="2668304"/>
-                </a:cubicBezTo>
-                <a:cubicBezTo>
-                  <a:pt x="1049243" y="2668304"/>
-                  <a:pt x="1049243" y="2668304"/>
-                  <a:pt x="1457007" y="1963067"/>
-                </a:cubicBezTo>
-                <a:lnTo>
-                  <a:pt x="1491373" y="1903634"/>
-                </a:lnTo>
-                <a:lnTo>
-                  <a:pt x="1490164" y="1903127"/>
-                </a:lnTo>
-                <a:cubicBezTo>
-                  <a:pt x="1465456" y="1888705"/>
-                  <a:pt x="1444493" y="1867820"/>
-                  <a:pt x="1429519" y="1841960"/>
-                </a:cubicBezTo>
-                <a:cubicBezTo>
-                  <a:pt x="1429519" y="1841960"/>
-                  <a:pt x="1429519" y="1841960"/>
-                  <a:pt x="968320" y="1044307"/>
-                </a:cubicBezTo>
-                <a:cubicBezTo>
-                  <a:pt x="938371" y="994579"/>
-                  <a:pt x="938371" y="930926"/>
-                  <a:pt x="968320" y="881196"/>
-                </a:cubicBezTo>
-                <a:cubicBezTo>
-                  <a:pt x="968320" y="881196"/>
-                  <a:pt x="968320" y="881196"/>
-                  <a:pt x="1429519" y="83546"/>
-                </a:cubicBezTo>
-                <a:cubicBezTo>
-                  <a:pt x="1459466" y="31828"/>
-                  <a:pt x="1513373" y="0"/>
-                  <a:pt x="1573268" y="0"/>
-                </a:cubicBezTo>
-                <a:close/>
-              </a:path>
-            </a:pathLst>
-          </a:custGeom>
-          <a:solidFill>
-            <a:schemeClr val="tx1">
-              <a:lumMod val="50000"/>
-              <a:lumOff val="50000"/>
-              <a:alpha val="15000"/>
-            </a:schemeClr>
-          </a:solidFill>
-          <a:ln>
-            <a:noFill/>
-          </a:ln>
-        </p:spPr>
-        <p:style>
-          <a:lnRef idx="2">
-            <a:schemeClr val="accent1">
-              <a:shade val="50000"/>
-            </a:schemeClr>
-          </a:lnRef>
-          <a:fillRef idx="1">
-            <a:schemeClr val="accent1"/>
-          </a:fillRef>
-          <a:effectRef idx="0">
-            <a:schemeClr val="accent1"/>
-          </a:effectRef>
-          <a:fontRef idx="minor">
-            <a:schemeClr val="lt1"/>
-          </a:fontRef>
-        </p:style>
-        <p:txBody>
-          <a:bodyPr wrap="square" rtlCol="0" anchor="ctr">
-            <a:noAutofit/>
-          </a:bodyPr>
-          <a:lstStyle/>
-          <a:p>
-            <a:pPr algn="ctr"/>
-            <a:endParaRPr lang="en-US"/>
-          </a:p>
-        </p:txBody>
-      </p:sp>
-      <p:pic>
-        <p:nvPicPr>
-          <p:cNvPr id="5" name="Picture 4">
-            <a:extLst>
-              <a:ext uri="{FF2B5EF4-FFF2-40B4-BE49-F238E27FC236}">
-                <a16:creationId xmlns:a16="http://schemas.microsoft.com/office/drawing/2014/main" id="{9120848B-B2B4-45BE-A961-AEC0B06CF41B}"/>
-              </a:ext>
-            </a:extLst>
-          </p:cNvPr>
-          <p:cNvPicPr>
-            <a:picLocks noChangeAspect="1"/>
-          </p:cNvPicPr>
-          <p:nvPr/>
-        </p:nvPicPr>
-        <p:blipFill rotWithShape="1">
-          <a:blip r:embed="rId2"/>
-          <a:srcRect r="59916"/>
-          <a:stretch/>
-        </p:blipFill>
-        <p:spPr>
-          <a:xfrm>
-            <a:off x="6854891" y="1715881"/>
-            <a:ext cx="3203509" cy="3426237"/>
-          </a:xfrm>
-          <a:prstGeom prst="rect">
-            <a:avLst/>
-          </a:prstGeom>
-        </p:spPr>
-      </p:pic>
-      <p:sp>
-        <p:nvSpPr>
           <p:cNvPr id="4" name="Subtitle 3"/>
           <p:cNvSpPr>
             <a:spLocks noGrp="1"/>
@@ -5585,8 +4782,8 @@
         </p:nvSpPr>
         <p:spPr>
           <a:xfrm>
-            <a:off x="1245686" y="648614"/>
-            <a:ext cx="8534400" cy="1752600"/>
+            <a:off x="329184" y="648614"/>
+            <a:ext cx="5852160" cy="1752600"/>
           </a:xfrm>
         </p:spPr>
         <p:txBody>
@@ -5917,7 +5114,7 @@
       </p:pic>
       <p:sp>
         <p:nvSpPr>
-          <p:cNvPr id="38" name="Rounded Rectangle 37"/>
+          <p:cNvPr id="37" name="Rounded Rectangle 36"/>
           <p:cNvSpPr/>
           <p:nvPr/>
         </p:nvSpPr>
@@ -5963,14 +5160,14 @@
       </p:sp>
       <p:sp>
         <p:nvSpPr>
-          <p:cNvPr id="39" name="Oval 38"/>
+          <p:cNvPr id="38" name="Oval 37"/>
           <p:cNvSpPr/>
           <p:nvPr/>
         </p:nvSpPr>
         <p:spPr>
           <a:xfrm>
-            <a:off x="548640" y="5660136"/>
-            <a:ext cx="694944" cy="694944"/>
+            <a:off x="530352" y="5486400"/>
+            <a:ext cx="566928" cy="566928"/>
           </a:xfrm>
           <a:prstGeom prst="ellipse">
             <a:avLst/>
@@ -6005,7 +5202,7 @@
       </p:sp>
       <p:pic>
         <p:nvPicPr>
-          <p:cNvPr id="40" name="Picture 39" descr="LuShieldCheck_white.png"/>
+          <p:cNvPr id="39" name="Picture 38" descr="LuShieldCheck_white.png"/>
           <p:cNvPicPr>
             <a:picLocks noChangeAspect="1"/>
           </p:cNvPicPr>
@@ -6019,8 +5216,8 @@
         </p:blipFill>
         <p:spPr>
           <a:xfrm>
-            <a:off x="701527" y="5813023"/>
-            <a:ext cx="389168" cy="389168"/>
+            <a:off x="655076" y="5611124"/>
+            <a:ext cx="317479" cy="317479"/>
           </a:xfrm>
           <a:prstGeom prst="rect">
             <a:avLst/>
@@ -6029,14 +5226,14 @@
       </p:pic>
       <p:sp>
         <p:nvSpPr>
-          <p:cNvPr id="41" name="TextBox 40"/>
+          <p:cNvPr id="40" name="TextBox 39"/>
           <p:cNvSpPr txBox="1"/>
           <p:nvPr/>
         </p:nvSpPr>
         <p:spPr>
           <a:xfrm>
-            <a:off x="1389888" y="5449824"/>
-            <a:ext cx="4709160" cy="1115568"/>
+            <a:off x="1188720" y="5440680"/>
+            <a:ext cx="3794760" cy="1133856"/>
           </a:xfrm>
           <a:prstGeom prst="rect">
             <a:avLst/>
@@ -6049,7 +5246,7 @@
           <a:p>
             <a:pPr algn="l"/>
             <a:r>
-              <a:rPr sz="2000" b="1" i="0">
+              <a:rPr sz="1800" b="1" i="0">
                 <a:solidFill>
                   <a:srgbClr val="1F3864"/>
                 </a:solidFill>
@@ -6061,7 +5258,7 @@
           <a:p>
             <a:pPr algn="l"/>
             <a:r>
-              <a:rPr sz="1200" b="0" i="0">
+              <a:rPr sz="1100" b="0" i="0">
                 <a:solidFill>
                   <a:srgbClr val="1A1A1A"/>
                 </a:solidFill>
@@ -6073,45 +5270,539 @@
           <a:p>
             <a:pPr algn="l"/>
             <a:r>
+              <a:rPr sz="1050" b="0" i="0">
+                <a:solidFill>
+                  <a:srgbClr val="595959"/>
+                </a:solidFill>
+                <a:latin typeface="Arial"/>
+              </a:rPr>
+              <a:t>Live: </a:t>
+            </a:r>
+            <a:r>
+              <a:rPr sz="1050" b="0" i="0">
+                <a:solidFill>
+                  <a:srgbClr val="0070C0"/>
+                </a:solidFill>
+                <a:latin typeface="Arial"/>
+                <a:hlinkClick r:id="rId5"/>
+              </a:rPr>
+              <a:t>vidya-pramaan-sih26263.onrender.com</a:t>
+            </a:r>
+          </a:p>
+          <a:p>
+            <a:pPr algn="l"/>
+            <a:r>
+              <a:rPr sz="1050" b="0" i="0">
+                <a:solidFill>
+                  <a:srgbClr val="595959"/>
+                </a:solidFill>
+                <a:latin typeface="Arial"/>
+              </a:rPr>
+              <a:t>Demo video (5 min): </a:t>
+            </a:r>
+            <a:r>
+              <a:rPr sz="1050" b="0" i="0">
+                <a:solidFill>
+                  <a:srgbClr val="0070C0"/>
+                </a:solidFill>
+                <a:latin typeface="Arial"/>
+                <a:hlinkClick r:id="rId6"/>
+              </a:rPr>
+              <a:t>youtu.be/eBwySqMs63Q</a:t>
+            </a:r>
+          </a:p>
+          <a:p>
+            <a:pPr algn="l"/>
+            <a:r>
+              <a:rPr sz="1050" b="0" i="0">
+                <a:solidFill>
+                  <a:srgbClr val="595959"/>
+                </a:solidFill>
+                <a:latin typeface="Arial"/>
+              </a:rPr>
+              <a:t>7 roles · 31 rules · 65 tests · synthetic data</a:t>
+            </a:r>
+          </a:p>
+        </p:txBody>
+      </p:sp>
+      <p:pic>
+        <p:nvPicPr>
+          <p:cNvPr id="41" name="Picture 40" descr="qr_live1.png"/>
+          <p:cNvPicPr>
+            <a:picLocks noChangeAspect="1"/>
+          </p:cNvPicPr>
+          <p:nvPr/>
+        </p:nvPicPr>
+        <p:blipFill>
+          <a:blip r:embed="rId7"/>
+          <a:stretch>
+            <a:fillRect/>
+          </a:stretch>
+        </p:blipFill>
+        <p:spPr>
+          <a:xfrm>
+            <a:off x="5074920" y="5504688"/>
+            <a:ext cx="1005840" cy="1005840"/>
+          </a:xfrm>
+          <a:prstGeom prst="rect">
+            <a:avLst/>
+          </a:prstGeom>
+        </p:spPr>
+      </p:pic>
+      <p:sp>
+        <p:nvSpPr>
+          <p:cNvPr id="42" name="TextBox 41"/>
+          <p:cNvSpPr txBox="1"/>
+          <p:nvPr/>
+        </p:nvSpPr>
+        <p:spPr>
+          <a:xfrm>
+            <a:off x="6400800" y="1463040"/>
+            <a:ext cx="5486400" cy="274320"/>
+          </a:xfrm>
+          <a:prstGeom prst="rect">
+            <a:avLst/>
+          </a:prstGeom>
+          <a:noFill/>
+        </p:spPr>
+        <p:txBody>
+          <a:bodyPr wrap="square" lIns="45720" rIns="45720" tIns="18288" bIns="18288" anchor="ctr"/>
+          <a:lstStyle/>
+          <a:p>
+            <a:pPr algn="l"/>
+            <a:r>
+              <a:rPr sz="1300" b="1" i="0">
+                <a:solidFill>
+                  <a:srgbClr val="1F3864"/>
+                </a:solidFill>
+                <a:latin typeface="Arial"/>
+              </a:rPr>
+              <a:t>Working prototype</a:t>
+            </a:r>
+            <a:r>
               <a:rPr sz="1100" b="0" i="0">
                 <a:solidFill>
                   <a:srgbClr val="595959"/>
                 </a:solidFill>
                 <a:latin typeface="Arial"/>
               </a:rPr>
-              <a:t>Working prototype: </a:t>
-            </a:r>
-            <a:r>
-              <a:rPr sz="1100" b="0" i="0">
-                <a:solidFill>
-                  <a:srgbClr val="0070C0"/>
-                </a:solidFill>
-                <a:latin typeface="Arial"/>
-                <a:hlinkClick r:id="rId5"/>
-              </a:rPr>
-              <a:t>vidya-pramaan-sih26263.onrender.com</a:t>
-            </a:r>
-          </a:p>
-          <a:p>
-            <a:pPr algn="l"/>
-            <a:r>
-              <a:rPr sz="1100" b="0" i="0">
+              <a:t>  ·  live now, every screen below is real</a:t>
+            </a:r>
+          </a:p>
+        </p:txBody>
+      </p:sp>
+      <p:sp>
+        <p:nvSpPr>
+          <p:cNvPr id="43" name="Rounded Rectangle 42"/>
+          <p:cNvSpPr/>
+          <p:nvPr/>
+        </p:nvSpPr>
+        <p:spPr>
+          <a:xfrm>
+            <a:off x="6373368" y="1755648"/>
+            <a:ext cx="4169663" cy="2816352"/>
+          </a:xfrm>
+          <a:prstGeom prst="roundRect">
+            <a:avLst>
+              <a:gd name="adj" fmla="val 1298"/>
+            </a:avLst>
+          </a:prstGeom>
+          <a:solidFill>
+            <a:srgbClr val="FFFFFF"/>
+          </a:solidFill>
+          <a:ln w="9525">
+            <a:solidFill>
+              <a:srgbClr val="C9D3E3"/>
+            </a:solidFill>
+          </a:ln>
+          <a:effectLst/>
+        </p:spPr>
+        <p:style>
+          <a:lnRef idx="1">
+            <a:schemeClr val="accent1"/>
+          </a:lnRef>
+          <a:fillRef idx="3">
+            <a:schemeClr val="accent1"/>
+          </a:fillRef>
+          <a:effectRef idx="2">
+            <a:schemeClr val="accent1"/>
+          </a:effectRef>
+          <a:fontRef idx="minor">
+            <a:schemeClr val="lt1"/>
+          </a:fontRef>
+        </p:style>
+        <p:txBody>
+          <a:bodyPr rtlCol="0" anchor="ctr"/>
+          <a:lstStyle/>
+          <a:p/>
+        </p:txBody>
+      </p:sp>
+      <p:pic>
+        <p:nvPicPr>
+          <p:cNvPr id="44" name="Picture 43" descr="10_aicte_dashboard.png"/>
+          <p:cNvPicPr>
+            <a:picLocks noChangeAspect="1"/>
+          </p:cNvPicPr>
+          <p:nvPr/>
+        </p:nvPicPr>
+        <p:blipFill>
+          <a:blip r:embed="rId8"/>
+          <a:srcRect l="17800" t="5800" b="5935"/>
+          <a:stretch>
+            <a:fillRect/>
+          </a:stretch>
+        </p:blipFill>
+        <p:spPr>
+          <a:xfrm>
+            <a:off x="6400800" y="1783080"/>
+            <a:ext cx="4114800" cy="2761488"/>
+          </a:xfrm>
+          <a:prstGeom prst="rect">
+            <a:avLst/>
+          </a:prstGeom>
+        </p:spPr>
+      </p:pic>
+      <p:sp>
+        <p:nvSpPr>
+          <p:cNvPr id="45" name="Rounded Rectangle 44"/>
+          <p:cNvSpPr/>
+          <p:nvPr/>
+        </p:nvSpPr>
+        <p:spPr>
+          <a:xfrm>
+            <a:off x="10597896" y="1755648"/>
+            <a:ext cx="1316736" cy="2816352"/>
+          </a:xfrm>
+          <a:prstGeom prst="roundRect">
+            <a:avLst>
+              <a:gd name="adj" fmla="val 2777"/>
+            </a:avLst>
+          </a:prstGeom>
+          <a:solidFill>
+            <a:srgbClr val="FFFFFF"/>
+          </a:solidFill>
+          <a:ln w="9525">
+            <a:solidFill>
+              <a:srgbClr val="C9D3E3"/>
+            </a:solidFill>
+          </a:ln>
+          <a:effectLst/>
+        </p:spPr>
+        <p:style>
+          <a:lnRef idx="1">
+            <a:schemeClr val="accent1"/>
+          </a:lnRef>
+          <a:fillRef idx="3">
+            <a:schemeClr val="accent1"/>
+          </a:fillRef>
+          <a:effectRef idx="2">
+            <a:schemeClr val="accent1"/>
+          </a:effectRef>
+          <a:fontRef idx="minor">
+            <a:schemeClr val="lt1"/>
+          </a:fontRef>
+        </p:style>
+        <p:txBody>
+          <a:bodyPr rtlCol="0" anchor="ctr"/>
+          <a:lstStyle/>
+          <a:p/>
+        </p:txBody>
+      </p:sp>
+      <p:pic>
+        <p:nvPicPr>
+          <p:cNvPr id="46" name="Picture 45" descr="30_mobile_dashboard.png"/>
+          <p:cNvPicPr>
+            <a:picLocks noChangeAspect="1"/>
+          </p:cNvPicPr>
+          <p:nvPr/>
+        </p:nvPicPr>
+        <p:blipFill>
+          <a:blip r:embed="rId9"/>
+          <a:srcRect l="555" r="555"/>
+          <a:stretch>
+            <a:fillRect/>
+          </a:stretch>
+        </p:blipFill>
+        <p:spPr>
+          <a:xfrm>
+            <a:off x="10625328" y="1783080"/>
+            <a:ext cx="1261872" cy="2761488"/>
+          </a:xfrm>
+          <a:prstGeom prst="rect">
+            <a:avLst/>
+          </a:prstGeom>
+        </p:spPr>
+      </p:pic>
+      <p:sp>
+        <p:nvSpPr>
+          <p:cNvPr id="47" name="TextBox 46"/>
+          <p:cNvSpPr txBox="1"/>
+          <p:nvPr/>
+        </p:nvSpPr>
+        <p:spPr>
+          <a:xfrm>
+            <a:off x="6400800" y="4572000"/>
+            <a:ext cx="4114800" cy="237744"/>
+          </a:xfrm>
+          <a:prstGeom prst="rect">
+            <a:avLst/>
+          </a:prstGeom>
+          <a:noFill/>
+        </p:spPr>
+        <p:txBody>
+          <a:bodyPr wrap="square" lIns="45720" rIns="45720" tIns="18288" bIns="18288" anchor="t"/>
+          <a:lstStyle/>
+          <a:p>
+            <a:pPr algn="ctr"/>
+            <a:r>
+              <a:rPr sz="1000" b="0" i="0">
                 <a:solidFill>
                   <a:srgbClr val="595959"/>
                 </a:solidFill>
                 <a:latin typeface="Arial"/>
               </a:rPr>
-              <a:t>Demo video (5 min): </a:t>
-            </a:r>
-            <a:r>
-              <a:rPr sz="1100" b="0" i="0">
-                <a:solidFill>
-                  <a:srgbClr val="0070C0"/>
-                </a:solidFill>
-                <a:latin typeface="Arial"/>
-                <a:hlinkClick r:id="rId6"/>
-              </a:rPr>
-              <a:t>youtu.be/eBwySqMs63Q</a:t>
+              <a:t>AICTE national view: every breach named with its rule</a:t>
+            </a:r>
+          </a:p>
+        </p:txBody>
+      </p:sp>
+      <p:sp>
+        <p:nvSpPr>
+          <p:cNvPr id="48" name="TextBox 47"/>
+          <p:cNvSpPr txBox="1"/>
+          <p:nvPr/>
+        </p:nvSpPr>
+        <p:spPr>
+          <a:xfrm>
+            <a:off x="10515600" y="4572000"/>
+            <a:ext cx="1463040" cy="237744"/>
+          </a:xfrm>
+          <a:prstGeom prst="rect">
+            <a:avLst/>
+          </a:prstGeom>
+          <a:noFill/>
+        </p:spPr>
+        <p:txBody>
+          <a:bodyPr wrap="square" lIns="45720" rIns="45720" tIns="18288" bIns="18288" anchor="t"/>
+          <a:lstStyle/>
+          <a:p>
+            <a:pPr algn="ctr"/>
+            <a:r>
+              <a:rPr sz="1000" b="0" i="0">
+                <a:solidFill>
+                  <a:srgbClr val="595959"/>
+                </a:solidFill>
+                <a:latin typeface="Arial"/>
+              </a:rPr>
+              <a:t>On a phone (PWA)</a:t>
+            </a:r>
+          </a:p>
+        </p:txBody>
+      </p:sp>
+      <p:sp>
+        <p:nvSpPr>
+          <p:cNvPr id="49" name="Rounded Rectangle 48"/>
+          <p:cNvSpPr/>
+          <p:nvPr/>
+        </p:nvSpPr>
+        <p:spPr>
+          <a:xfrm>
+            <a:off x="6373368" y="4873752"/>
+            <a:ext cx="3712463" cy="1380744"/>
+          </a:xfrm>
+          <a:prstGeom prst="roundRect">
+            <a:avLst>
+              <a:gd name="adj" fmla="val 2649"/>
+            </a:avLst>
+          </a:prstGeom>
+          <a:solidFill>
+            <a:srgbClr val="FFFFFF"/>
+          </a:solidFill>
+          <a:ln w="9525">
+            <a:solidFill>
+              <a:srgbClr val="C9D3E3"/>
+            </a:solidFill>
+          </a:ln>
+          <a:effectLst/>
+        </p:spPr>
+        <p:style>
+          <a:lnRef idx="1">
+            <a:schemeClr val="accent1"/>
+          </a:lnRef>
+          <a:fillRef idx="3">
+            <a:schemeClr val="accent1"/>
+          </a:fillRef>
+          <a:effectRef idx="2">
+            <a:schemeClr val="accent1"/>
+          </a:effectRef>
+          <a:fontRef idx="minor">
+            <a:schemeClr val="lt1"/>
+          </a:fontRef>
+        </p:style>
+        <p:txBody>
+          <a:bodyPr rtlCol="0" anchor="ctr"/>
+          <a:lstStyle/>
+          <a:p/>
+        </p:txBody>
+      </p:sp>
+      <p:pic>
+        <p:nvPicPr>
+          <p:cNvPr id="50" name="Picture 49" descr="14_review_identity_duplicate.png"/>
+          <p:cNvPicPr>
+            <a:picLocks noChangeAspect="1"/>
+          </p:cNvPicPr>
+          <p:nvPr/>
+        </p:nvPicPr>
+        <p:blipFill>
+          <a:blip r:embed="rId10"/>
+          <a:srcRect l="54000" t="1500" b="71820"/>
+          <a:stretch>
+            <a:fillRect/>
+          </a:stretch>
+        </p:blipFill>
+        <p:spPr>
+          <a:xfrm>
+            <a:off x="6400800" y="4901184"/>
+            <a:ext cx="3657600" cy="1325880"/>
+          </a:xfrm>
+          <a:prstGeom prst="rect">
+            <a:avLst/>
+          </a:prstGeom>
+        </p:spPr>
+      </p:pic>
+      <p:sp>
+        <p:nvSpPr>
+          <p:cNvPr id="51" name="Rounded Rectangle 50"/>
+          <p:cNvSpPr/>
+          <p:nvPr/>
+        </p:nvSpPr>
+        <p:spPr>
+          <a:xfrm>
+            <a:off x="10140696" y="4873752"/>
+            <a:ext cx="1773936" cy="1380744"/>
+          </a:xfrm>
+          <a:prstGeom prst="roundRect">
+            <a:avLst>
+              <a:gd name="adj" fmla="val 2649"/>
+            </a:avLst>
+          </a:prstGeom>
+          <a:solidFill>
+            <a:srgbClr val="FFFFFF"/>
+          </a:solidFill>
+          <a:ln w="9525">
+            <a:solidFill>
+              <a:srgbClr val="C9D3E3"/>
+            </a:solidFill>
+          </a:ln>
+          <a:effectLst/>
+        </p:spPr>
+        <p:style>
+          <a:lnRef idx="1">
+            <a:schemeClr val="accent1"/>
+          </a:lnRef>
+          <a:fillRef idx="3">
+            <a:schemeClr val="accent1"/>
+          </a:fillRef>
+          <a:effectRef idx="2">
+            <a:schemeClr val="accent1"/>
+          </a:effectRef>
+          <a:fontRef idx="minor">
+            <a:schemeClr val="lt1"/>
+          </a:fontRef>
+        </p:style>
+        <p:txBody>
+          <a:bodyPr rtlCol="0" anchor="ctr"/>
+          <a:lstStyle/>
+          <a:p/>
+        </p:txBody>
+      </p:sp>
+      <p:pic>
+        <p:nvPicPr>
+          <p:cNvPr id="52" name="Picture 51" descr="19_review_shared_contact_cluster.png"/>
+          <p:cNvPicPr>
+            <a:picLocks noChangeAspect="1"/>
+          </p:cNvPicPr>
+          <p:nvPr/>
+        </p:nvPicPr>
+        <p:blipFill>
+          <a:blip r:embed="rId11"/>
+          <a:srcRect l="60000" t="16500" r="7000" b="42777"/>
+          <a:stretch>
+            <a:fillRect/>
+          </a:stretch>
+        </p:blipFill>
+        <p:spPr>
+          <a:xfrm>
+            <a:off x="10168128" y="4901184"/>
+            <a:ext cx="1719072" cy="1325880"/>
+          </a:xfrm>
+          <a:prstGeom prst="rect">
+            <a:avLst/>
+          </a:prstGeom>
+        </p:spPr>
+      </p:pic>
+      <p:sp>
+        <p:nvSpPr>
+          <p:cNvPr id="53" name="TextBox 52"/>
+          <p:cNvSpPr txBox="1"/>
+          <p:nvPr/>
+        </p:nvSpPr>
+        <p:spPr>
+          <a:xfrm>
+            <a:off x="6400800" y="6272784"/>
+            <a:ext cx="3657600" cy="237744"/>
+          </a:xfrm>
+          <a:prstGeom prst="rect">
+            <a:avLst/>
+          </a:prstGeom>
+          <a:noFill/>
+        </p:spPr>
+        <p:txBody>
+          <a:bodyPr wrap="square" lIns="45720" rIns="45720" tIns="18288" bIns="18288" anchor="t"/>
+          <a:lstStyle/>
+          <a:p>
+            <a:pPr algn="ctr"/>
+            <a:r>
+              <a:rPr sz="1000" b="0" i="0">
+                <a:solidFill>
+                  <a:srgbClr val="595959"/>
+                </a:solidFill>
+                <a:latin typeface="Arial"/>
+              </a:rPr>
+              <a:t>Same person under two APAAR IDs: reasons shown</a:t>
+            </a:r>
+          </a:p>
+        </p:txBody>
+      </p:sp>
+      <p:sp>
+        <p:nvSpPr>
+          <p:cNvPr id="54" name="TextBox 53"/>
+          <p:cNvSpPr txBox="1"/>
+          <p:nvPr/>
+        </p:nvSpPr>
+        <p:spPr>
+          <a:xfrm>
+            <a:off x="9966960" y="6272784"/>
+            <a:ext cx="2103120" cy="237744"/>
+          </a:xfrm>
+          <a:prstGeom prst="rect">
+            <a:avLst/>
+          </a:prstGeom>
+          <a:noFill/>
+        </p:spPr>
+        <p:txBody>
+          <a:bodyPr wrap="square" lIns="45720" rIns="45720" tIns="18288" bIns="18288" anchor="t"/>
+          <a:lstStyle/>
+          <a:p>
+            <a:pPr algn="ctr"/>
+            <a:r>
+              <a:rPr sz="1000" b="0" i="0">
+                <a:solidFill>
+                  <a:srgbClr val="595959"/>
+                </a:solidFill>
+                <a:latin typeface="Arial"/>
+              </a:rPr>
+              <a:t>1 phone, 8 students, 2 colleges</a:t>
             </a:r>
           </a:p>
         </p:txBody>
@@ -12373,7 +12064,7 @@
       </p:sp>
       <p:pic>
         <p:nvPicPr>
-          <p:cNvPr id="17474" name="Picture 17473" descr="qr_live.png"/>
+          <p:cNvPr id="17474" name="Picture 17473" descr="qr_live1.png"/>
           <p:cNvPicPr>
             <a:picLocks noChangeAspect="1"/>
           </p:cNvPicPr>
@@ -12953,8 +12644,8 @@
         </p:nvSpPr>
         <p:spPr>
           <a:xfrm>
-            <a:off x="457200" y="1572768"/>
-            <a:ext cx="384048" cy="384048"/>
+            <a:off x="457200" y="1554480"/>
+            <a:ext cx="365760" cy="365760"/>
           </a:xfrm>
           <a:prstGeom prst="ellipse">
             <a:avLst/>
@@ -13003,8 +12694,8 @@
         </p:blipFill>
         <p:spPr>
           <a:xfrm>
-            <a:off x="541690" y="1657258"/>
-            <a:ext cx="215066" cy="215066"/>
+            <a:off x="537667" y="1634947"/>
+            <a:ext cx="204825" cy="204825"/>
           </a:xfrm>
           <a:prstGeom prst="rect">
             <a:avLst/>
@@ -13019,8 +12710,8 @@
         </p:nvSpPr>
         <p:spPr>
           <a:xfrm>
-            <a:off x="886968" y="1536192"/>
-            <a:ext cx="1284732" cy="457200"/>
+            <a:off x="868680" y="1517904"/>
+            <a:ext cx="1303019" cy="420624"/>
           </a:xfrm>
           <a:prstGeom prst="rect">
             <a:avLst/>
@@ -13033,7 +12724,7 @@
           <a:p>
             <a:pPr algn="l"/>
             <a:r>
-              <a:rPr sz="1800" b="1" i="0">
+              <a:rPr sz="1700" b="1" i="0">
                 <a:solidFill>
                   <a:srgbClr val="1F3864"/>
                 </a:solidFill>
@@ -13052,8 +12743,8 @@
         </p:nvSpPr>
         <p:spPr>
           <a:xfrm>
-            <a:off x="457200" y="2029968"/>
-            <a:ext cx="1696212" cy="530352"/>
+            <a:off x="438912" y="1947672"/>
+            <a:ext cx="1714500" cy="621792"/>
           </a:xfrm>
           <a:prstGeom prst="rect">
             <a:avLst/>
@@ -13066,14 +12757,13 @@
           <a:p>
             <a:pPr algn="l"/>
             <a:r>
-              <a:rPr sz="1100" b="0" i="0">
+              <a:rPr sz="1050" b="0" i="0">
                 <a:solidFill>
                   <a:srgbClr val="1A1A1A"/>
                 </a:solidFill>
                 <a:latin typeface="Arial"/>
               </a:rPr>
-              <a:t>held-out precision / recall
-(old matcher 0.65 / 0.68)</a:t>
+              <a:t>name-match precision / recall on 49 held-out pairs (old 0.65 / 0.68)</a:t>
             </a:r>
           </a:p>
         </p:txBody>
@@ -13132,8 +12822,8 @@
         </p:nvSpPr>
         <p:spPr>
           <a:xfrm>
-            <a:off x="2382012" y="1572768"/>
-            <a:ext cx="384048" cy="384048"/>
+            <a:off x="2382012" y="1554480"/>
+            <a:ext cx="365760" cy="365760"/>
           </a:xfrm>
           <a:prstGeom prst="ellipse">
             <a:avLst/>
@@ -13182,8 +12872,8 @@
         </p:blipFill>
         <p:spPr>
           <a:xfrm>
-            <a:off x="2466502" y="1657258"/>
-            <a:ext cx="215066" cy="215066"/>
+            <a:off x="2462479" y="1634947"/>
+            <a:ext cx="204825" cy="204825"/>
           </a:xfrm>
           <a:prstGeom prst="rect">
             <a:avLst/>
@@ -13198,8 +12888,8 @@
         </p:nvSpPr>
         <p:spPr>
           <a:xfrm>
-            <a:off x="2811780" y="1536192"/>
-            <a:ext cx="1284732" cy="457200"/>
+            <a:off x="2793492" y="1517904"/>
+            <a:ext cx="1303019" cy="420624"/>
           </a:xfrm>
           <a:prstGeom prst="rect">
             <a:avLst/>
@@ -13212,13 +12902,13 @@
           <a:p>
             <a:pPr algn="l"/>
             <a:r>
-              <a:rPr sz="1800" b="1" i="0">
+              <a:rPr sz="2000" b="1" i="0">
                 <a:solidFill>
                   <a:srgbClr val="1F3864"/>
                 </a:solidFill>
                 <a:latin typeface="Arial"/>
               </a:rPr>
-              <a:t>0/80 · 2/12</a:t>
+              <a:t>0 of 80</a:t>
             </a:r>
           </a:p>
         </p:txBody>
@@ -13231,8 +12921,8 @@
         </p:nvSpPr>
         <p:spPr>
           <a:xfrm>
-            <a:off x="2382012" y="2029968"/>
-            <a:ext cx="1696212" cy="530352"/>
+            <a:off x="2363724" y="1947672"/>
+            <a:ext cx="1714500" cy="621792"/>
           </a:xfrm>
           <a:prstGeom prst="rect">
             <a:avLst/>
@@ -13245,14 +12935,13 @@
           <a:p>
             <a:pPr algn="l"/>
             <a:r>
-              <a:rPr sz="1100" b="0" i="0">
+              <a:rPr sz="1050" b="0" i="0">
                 <a:solidFill>
                   <a:srgbClr val="1A1A1A"/>
                 </a:solidFill>
                 <a:latin typeface="Arial"/>
               </a:rPr>
-              <a:t>twins flagged:
-seeded · held-out</a:t>
+              <a:t>seeded twin pairs wrongly merged (held-out: 2 of 12, sent to an officer)</a:t>
             </a:r>
           </a:p>
         </p:txBody>
@@ -13311,8 +13000,8 @@
         </p:nvSpPr>
         <p:spPr>
           <a:xfrm>
-            <a:off x="4306824" y="1572768"/>
-            <a:ext cx="384048" cy="384048"/>
+            <a:off x="4306824" y="1554480"/>
+            <a:ext cx="365760" cy="365760"/>
           </a:xfrm>
           <a:prstGeom prst="ellipse">
             <a:avLst/>
@@ -13361,8 +13050,8 @@
         </p:blipFill>
         <p:spPr>
           <a:xfrm>
-            <a:off x="4391314" y="1657258"/>
-            <a:ext cx="215066" cy="215066"/>
+            <a:off x="4387291" y="1634947"/>
+            <a:ext cx="204825" cy="204825"/>
           </a:xfrm>
           <a:prstGeom prst="rect">
             <a:avLst/>
@@ -13377,8 +13066,8 @@
         </p:nvSpPr>
         <p:spPr>
           <a:xfrm>
-            <a:off x="4736592" y="1536192"/>
-            <a:ext cx="1284732" cy="457200"/>
+            <a:off x="4718303" y="1517904"/>
+            <a:ext cx="1303019" cy="420624"/>
           </a:xfrm>
           <a:prstGeom prst="rect">
             <a:avLst/>
@@ -13391,13 +13080,13 @@
           <a:p>
             <a:pPr algn="l"/>
             <a:r>
-              <a:rPr sz="2100" b="1" i="0">
+              <a:rPr sz="2000" b="1" i="0">
                 <a:solidFill>
                   <a:srgbClr val="1F3864"/>
                 </a:solidFill>
                 <a:latin typeface="Arial"/>
               </a:rPr>
-              <a:t>17/17</a:t>
+              <a:t>17 of 17</a:t>
             </a:r>
           </a:p>
         </p:txBody>
@@ -13410,8 +13099,8 @@
         </p:nvSpPr>
         <p:spPr>
           <a:xfrm>
-            <a:off x="4306824" y="2029968"/>
-            <a:ext cx="1696212" cy="530352"/>
+            <a:off x="4288536" y="1947672"/>
+            <a:ext cx="1714500" cy="621792"/>
           </a:xfrm>
           <a:prstGeom prst="rect">
             <a:avLst/>
@@ -13424,14 +13113,13 @@
           <a:p>
             <a:pPr algn="l"/>
             <a:r>
-              <a:rPr sz="1100" b="0" i="0">
+              <a:rPr sz="1050" b="0" i="0">
                 <a:solidFill>
                   <a:srgbClr val="1A1A1A"/>
                 </a:solidFill>
                 <a:latin typeface="Arial"/>
               </a:rPr>
-              <a:t>error types caught;
-0 false flags (56 rows)</a:t>
+              <a:t>error types caught in the demo upload; 0 false flags on 56 clean rows</a:t>
             </a:r>
           </a:p>
         </p:txBody>
@@ -13490,8 +13178,8 @@
         </p:nvSpPr>
         <p:spPr>
           <a:xfrm>
-            <a:off x="6231636" y="1572768"/>
-            <a:ext cx="384048" cy="384048"/>
+            <a:off x="6231636" y="1554480"/>
+            <a:ext cx="365760" cy="365760"/>
           </a:xfrm>
           <a:prstGeom prst="ellipse">
             <a:avLst/>
@@ -13540,8 +13228,8 @@
         </p:blipFill>
         <p:spPr>
           <a:xfrm>
-            <a:off x="6316126" y="1657258"/>
-            <a:ext cx="215066" cy="215066"/>
+            <a:off x="6312103" y="1634947"/>
+            <a:ext cx="204825" cy="204825"/>
           </a:xfrm>
           <a:prstGeom prst="rect">
             <a:avLst/>
@@ -13556,8 +13244,8 @@
         </p:nvSpPr>
         <p:spPr>
           <a:xfrm>
-            <a:off x="6661403" y="1536192"/>
-            <a:ext cx="1284732" cy="457200"/>
+            <a:off x="6643115" y="1517904"/>
+            <a:ext cx="1303019" cy="420624"/>
           </a:xfrm>
           <a:prstGeom prst="rect">
             <a:avLst/>
@@ -13570,13 +13258,13 @@
           <a:p>
             <a:pPr algn="l"/>
             <a:r>
-              <a:rPr sz="1800" b="1" i="0">
+              <a:rPr sz="1700" b="1" i="0">
                 <a:solidFill>
                   <a:srgbClr val="1F3864"/>
                 </a:solidFill>
                 <a:latin typeface="Arial"/>
               </a:rPr>
-              <a:t>164 · 57 · 4</a:t>
+              <a:t>225 of 225</a:t>
             </a:r>
           </a:p>
         </p:txBody>
@@ -13589,8 +13277,8 @@
         </p:nvSpPr>
         <p:spPr>
           <a:xfrm>
-            <a:off x="6231636" y="2029968"/>
-            <a:ext cx="1696212" cy="530352"/>
+            <a:off x="6213347" y="1947672"/>
+            <a:ext cx="1714500" cy="621792"/>
           </a:xfrm>
           <a:prstGeom prst="rect">
             <a:avLst/>
@@ -13603,14 +13291,13 @@
           <a:p>
             <a:pPr algn="l"/>
             <a:r>
-              <a:rPr sz="1100" b="0" i="0">
+              <a:rPr sz="1050" b="0" i="0">
                 <a:solidFill>
                   <a:srgbClr val="1A1A1A"/>
                 </a:solidFill>
                 <a:latin typeface="Arial"/>
               </a:rPr>
-              <a:t>dual enrolments · ID
-dupes · contact rings</a:t>
+              <a:t>planted cases found: 164 dual enrolments, 57 ID duplicates, 4 contact rings</a:t>
             </a:r>
           </a:p>
         </p:txBody>
@@ -13669,8 +13356,8 @@
         </p:nvSpPr>
         <p:spPr>
           <a:xfrm>
-            <a:off x="8156448" y="1572768"/>
-            <a:ext cx="384048" cy="384048"/>
+            <a:off x="8156448" y="1554480"/>
+            <a:ext cx="365760" cy="365760"/>
           </a:xfrm>
           <a:prstGeom prst="ellipse">
             <a:avLst/>
@@ -13719,8 +13406,8 @@
         </p:blipFill>
         <p:spPr>
           <a:xfrm>
-            <a:off x="8240938" y="1657258"/>
-            <a:ext cx="215066" cy="215066"/>
+            <a:off x="8236915" y="1634947"/>
+            <a:ext cx="204825" cy="204825"/>
           </a:xfrm>
           <a:prstGeom prst="rect">
             <a:avLst/>
@@ -13735,8 +13422,8 @@
         </p:nvSpPr>
         <p:spPr>
           <a:xfrm>
-            <a:off x="8586215" y="1536192"/>
-            <a:ext cx="1284732" cy="457200"/>
+            <a:off x="8567928" y="1517904"/>
+            <a:ext cx="1303019" cy="420624"/>
           </a:xfrm>
           <a:prstGeom prst="rect">
             <a:avLst/>
@@ -13749,13 +13436,13 @@
           <a:p>
             <a:pPr algn="l"/>
             <a:r>
-              <a:rPr sz="2100" b="1" i="0">
+              <a:rPr sz="2000" b="1" i="0">
                 <a:solidFill>
                   <a:srgbClr val="1F3864"/>
                 </a:solidFill>
                 <a:latin typeface="Arial"/>
               </a:rPr>
-              <a:t>42/46</a:t>
+              <a:t>42 of 46</a:t>
             </a:r>
           </a:p>
         </p:txBody>
@@ -13768,8 +13455,8 @@
         </p:nvSpPr>
         <p:spPr>
           <a:xfrm>
-            <a:off x="8156448" y="2029968"/>
-            <a:ext cx="1696212" cy="530352"/>
+            <a:off x="8138160" y="1947672"/>
+            <a:ext cx="1714500" cy="621792"/>
           </a:xfrm>
           <a:prstGeom prst="rect">
             <a:avLst/>
@@ -13782,14 +13469,13 @@
           <a:p>
             <a:pPr algn="l"/>
             <a:r>
-              <a:rPr sz="1100" b="0" i="0">
+              <a:rPr sz="1050" b="0" i="0">
                 <a:solidFill>
                   <a:srgbClr val="1A1A1A"/>
                 </a:solidFill>
                 <a:latin typeface="Arial"/>
               </a:rPr>
-              <a:t>top-ranked colleges
-were planted ones</a:t>
+              <a:t>highest-risk colleges were the planted anomalies</a:t>
             </a:r>
           </a:p>
         </p:txBody>
@@ -13848,8 +13534,8 @@
         </p:nvSpPr>
         <p:spPr>
           <a:xfrm>
-            <a:off x="10081260" y="1572768"/>
-            <a:ext cx="384048" cy="384048"/>
+            <a:off x="10081260" y="1554480"/>
+            <a:ext cx="365760" cy="365760"/>
           </a:xfrm>
           <a:prstGeom prst="ellipse">
             <a:avLst/>
@@ -13898,8 +13584,8 @@
         </p:blipFill>
         <p:spPr>
           <a:xfrm>
-            <a:off x="10165750" y="1657258"/>
-            <a:ext cx="215066" cy="215066"/>
+            <a:off x="10161727" y="1634947"/>
+            <a:ext cx="204825" cy="204825"/>
           </a:xfrm>
           <a:prstGeom prst="rect">
             <a:avLst/>
@@ -13914,8 +13600,8 @@
         </p:nvSpPr>
         <p:spPr>
           <a:xfrm>
-            <a:off x="10511028" y="1536192"/>
-            <a:ext cx="1284732" cy="457200"/>
+            <a:off x="10492740" y="1517904"/>
+            <a:ext cx="1303019" cy="420624"/>
           </a:xfrm>
           <a:prstGeom prst="rect">
             <a:avLst/>
@@ -13928,7 +13614,7 @@
           <a:p>
             <a:pPr algn="l"/>
             <a:r>
-              <a:rPr sz="1800" b="1" i="0">
+              <a:rPr sz="2000" b="1" i="0">
                 <a:solidFill>
                   <a:srgbClr val="1F3864"/>
                 </a:solidFill>
@@ -13947,8 +13633,8 @@
         </p:nvSpPr>
         <p:spPr>
           <a:xfrm>
-            <a:off x="10081260" y="2029968"/>
-            <a:ext cx="1696212" cy="530352"/>
+            <a:off x="10062972" y="1947672"/>
+            <a:ext cx="1714500" cy="621792"/>
           </a:xfrm>
           <a:prstGeom prst="rect">
             <a:avLst/>
@@ -13961,14 +13647,13 @@
           <a:p>
             <a:pPr algn="l"/>
             <a:r>
-              <a:rPr sz="1100" b="0" i="0">
+              <a:rPr sz="1050" b="0" i="0">
                 <a:solidFill>
                   <a:srgbClr val="1A1A1A"/>
                 </a:solidFill>
                 <a:latin typeface="Arial"/>
               </a:rPr>
-              <a:t>93% coverage;
-security + WCAG in CI</a:t>
+              <a:t>93% line coverage; security and WCAG checks in CI</a:t>
             </a:r>
           </a:p>
         </p:txBody>
@@ -21086,7 +20771,7 @@
       </p:sp>
       <p:pic>
         <p:nvPicPr>
-          <p:cNvPr id="17452" name="Picture 17451" descr="qr_live.png"/>
+          <p:cNvPr id="17452" name="Picture 17451" descr="qr_live1.png"/>
           <p:cNvPicPr>
             <a:picLocks noChangeAspect="1"/>
           </p:cNvPicPr>

</xml_diff>